<commit_message>
Rewrite the overview and demo deck in a plainer presenter voice
Same 23-slide structure and layouts; every title, subtitle, card and
callout reworded to read like a presenter talking: shorter sentences,
fewer labels and colons, no repeated mantras, concrete phrasing. Slide
outline in the README updated to the new titles.

Co-Authored-By: Claude Fable 5.1 <noreply@anthropic.com>
Claude-Session: https://claude.ai/code/session_01EqHkQCasz2hM7pvmZNN3oL
</commit_message>
<xml_diff>
--- a/Day1/Agentic_AI_Overview_and_Live_Demo/Agentic_AI_Overview_and_Live_Demo.pptx
+++ b/Day1/Agentic_AI_Overview_and_Live_Demo/Agentic_AI_Overview_and_Live_Demo.pptx
@@ -1013,42 +1013,37 @@
           <a:lstStyle/>
           <a:p>
             <a:r>
-              <a:t>Welcome. This session does two things in 45 minutes: it gives the room a shared vocabulary for Agentic AI (what an agent</a:t>
-            </a:r>
-          </a:p>
-          <a:p>
-            <a:r>
-              <a:t>is, what RAG, MCP and composite AI add to it), and it shows a real agent at work on a population-health problem, the</a:t>
-            </a:r>
-          </a:p>
-          <a:p>
-            <a:r>
-              <a:t>same agent the participants will build themselves in the hands-on part of the bootcamp. No code, no maths; every</a:t>
-            </a:r>
-          </a:p>
-          <a:p>
-            <a:r>
-              <a:t>concept is shown once in plain words and once live in the demo.</a:t>
-            </a:r>
-          </a:p>
-          <a:p>
-            <a:r>
-              <a:t>Timing guide: intro 3 min (slides 1-2), what is Agentic AI 8 min (3-6), the building blocks 10 min (7-12), live demo</a:t>
-            </a:r>
-          </a:p>
-          <a:p>
-            <a:r>
-              <a:t>18 min (13-18, of which about 12 min live in SAS Retrieval Agent Manager), what you will build 4 min (19-21), wrap-up</a:t>
-            </a:r>
-          </a:p>
-          <a:p>
-            <a:r>
-              <a:t>2 min (22-23). About 45 minutes. If you are short on time, skip slide 6 (healthcare examples) and slide 21 (the</a:t>
-            </a:r>
-          </a:p>
-          <a:p>
-            <a:r>
-              <a:t>component table). If the live environment misbehaves, slide 17 is the backup walk-through of one answer.</a:t>
+              <a:t>Welcome. Two things in the next 45 minutes: a shared vocabulary for Agentic AI (what an agent is, what RAG, MCP and</a:t>
+            </a:r>
+          </a:p>
+          <a:p>
+            <a:r>
+              <a:t>composite AI add to it), and a real agent at work on a population-health problem. It is the same agent the</a:t>
+            </a:r>
+          </a:p>
+          <a:p>
+            <a:r>
+              <a:t>participants build themselves in the hands-on, so everything shown here comes back later. No code, no maths.</a:t>
+            </a:r>
+          </a:p>
+          <a:p>
+            <a:r>
+              <a:t>Timing guide: intro 3 min (slides 1-2), what is an agent 8 min (3-6), the parts 10 min (7-12), live demo 18 min</a:t>
+            </a:r>
+          </a:p>
+          <a:p>
+            <a:r>
+              <a:t>(13-18, of which about 12 min live in SAS Retrieval Agent Manager), what you will build 4 min (19-21), wrap-up 2 min</a:t>
+            </a:r>
+          </a:p>
+          <a:p>
+            <a:r>
+              <a:t>(22-23). If short on time, skip slide 6 (healthcare examples) and slide 21 (the component table). If the live</a:t>
+            </a:r>
+          </a:p>
+          <a:p>
+            <a:r>
+              <a:t>environment misbehaves, slide 17 is the backup walk-through of one answer.</a:t>
             </a:r>
           </a:p>
           <a:p>
@@ -1128,32 +1123,32 @@
           <a:lstStyle/>
           <a:p>
             <a:r>
-              <a:t>RAG in two rows. Row one happens once, when you build the knowledge base: documents are chunked, each chunk is turned</a:t>
-            </a:r>
-          </a:p>
-          <a:p>
-            <a:r>
-              <a:t>into a vector (a fingerprint of its meaning) and stored. Row two happens at every question: the question is turned</a:t>
-            </a:r>
-          </a:p>
-          <a:p>
-            <a:r>
-              <a:t>into a vector, the closest passages are fetched, and the model writes from those passages only, with the citation.</a:t>
-            </a:r>
-          </a:p>
-          <a:p>
-            <a:r>
-              <a:t>The last card matters most for healthcare: when the collection does not cover the question, the agent says so instead</a:t>
-            </a:r>
-          </a:p>
-          <a:p>
-            <a:r>
-              <a:t>of guessing. In SAS this whole slide is a Retrieval Agent Manager 'collection'; the participants create one from the</a:t>
-            </a:r>
-          </a:p>
-          <a:p>
-            <a:r>
-              <a:t>four PDFs in the hands-on part, and in the demo you will see the retrieved passages in the trace.</a:t>
+              <a:t>RAG in two rows. The top row happens once, when you build the knowledge base: documents are cut into passages, each</a:t>
+            </a:r>
+          </a:p>
+          <a:p>
+            <a:r>
+              <a:t>passage is turned into a vector (a fingerprint of its meaning) and stored. The bottom row happens at every question:</a:t>
+            </a:r>
+          </a:p>
+          <a:p>
+            <a:r>
+              <a:t>the question gets a fingerprint too, the closest passages are fetched, and the model writes from those passages only,</a:t>
+            </a:r>
+          </a:p>
+          <a:p>
+            <a:r>
+              <a:t>with the citation. The last card matters most in healthcare: when the documents do not cover the question, the agent</a:t>
+            </a:r>
+          </a:p>
+          <a:p>
+            <a:r>
+              <a:t>says so instead of guessing. In SAS this whole slide is a Retrieval Agent Manager collection; the participants build</a:t>
+            </a:r>
+          </a:p>
+          <a:p>
+            <a:r>
+              <a:t>one from the four PDFs in the hands-on, and in the demo you will see the retrieved passages in the trace.</a:t>
             </a:r>
           </a:p>
         </p:txBody>
@@ -1233,22 +1228,22 @@
           </a:p>
           <a:p>
             <a:r>
-              <a:t>knows what the agent is allowed to call, executes it, logs it, and returns the result. Three things for a non-technical</a:t>
-            </a:r>
-          </a:p>
-          <a:p>
-            <a:r>
-              <a:t>audience: tools are described in plain language, so a business owner can read the tool list; the model asks and the</a:t>
-            </a:r>
-          </a:p>
-          <a:p>
-            <a:r>
-              <a:t>runtime executes, which is where permissions live; and everything is logged, which is the trace you will see in the</a:t>
-            </a:r>
-          </a:p>
-          <a:p>
-            <a:r>
-              <a:t>demo. In the bootcamp each team gets an MCP server scoped to its own table and model.</a:t>
+              <a:t>knows what the agent may call, runs it, logs it, and returns the result. Three things for a non-technical audience:</a:t>
+            </a:r>
+          </a:p>
+          <a:p>
+            <a:r>
+              <a:t>tools are described in plain language, so a business owner can read the tool list; the model asks and the runtime</a:t>
+            </a:r>
+          </a:p>
+          <a:p>
+            <a:r>
+              <a:t>executes, which is where permissions live; and everything is logged, which is the trace you will see in the demo. In</a:t>
+            </a:r>
+          </a:p>
+          <a:p>
+            <a:r>
+              <a:t>the bootcamp each team gets an MCP server scoped to its own table and model.</a:t>
             </a:r>
           </a:p>
         </p:txBody>
@@ -1318,27 +1313,27 @@
           <a:lstStyle/>
           <a:p>
             <a:r>
-              <a:t>Composite AI is the reason the agent is trustworthy: each kind of fact comes from the engine that is good at it. One</a:t>
-            </a:r>
-          </a:p>
-          <a:p>
-            <a:r>
-              <a:t>real question from the demo flows left to right. The retrieval engine finds the section; SQL counts the cohort; the</a:t>
-            </a:r>
-          </a:p>
-          <a:p>
-            <a:r>
-              <a:t>model ranks it; the rules say who may see what and who decides; the language model only orchestrates and writes.</a:t>
-            </a:r>
-          </a:p>
-          <a:p>
-            <a:r>
-              <a:t>Read the answer card: every number has a cohort, every clinical statement has a section, and the last line hands the</a:t>
-            </a:r>
-          </a:p>
-          <a:p>
-            <a:r>
-              <a:t>decision to the clinician. This is the slide to come back to when someone asks 'but can we trust what it says?'.</a:t>
+              <a:t>Composite AI is why the agent can be trusted: each kind of fact comes from the engine that is good at it. One real</a:t>
+            </a:r>
+          </a:p>
+          <a:p>
+            <a:r>
+              <a:t>question from the demo flows left to right. Retrieval finds the section; SQL counts the cohort; the model ranks it;</a:t>
+            </a:r>
+          </a:p>
+          <a:p>
+            <a:r>
+              <a:t>the rules say who may be listed and who decides; the language model only orchestrates and writes. Read the answer</a:t>
+            </a:r>
+          </a:p>
+          <a:p>
+            <a:r>
+              <a:t>card: every number has a cohort, every clinical statement has a section, and the last line hands the decision to the</a:t>
+            </a:r>
+          </a:p>
+          <a:p>
+            <a:r>
+              <a:t>clinician. Come back to this slide when someone asks 'but can we trust what it says?'.</a:t>
             </a:r>
           </a:p>
         </p:txBody>
@@ -1408,7 +1403,7 @@
           <a:lstStyle/>
           <a:p>
             <a:r>
-              <a:t>Part 3 of 4. About 18 minutes: the scenario and the solution overview (3 min), the demo plan (1 min), the live demo in SAS Retrieval Agent Manager (12 min), then the backup walk-through and the guardrails (2 min).</a:t>
+              <a:t>Part 3 of 4. About 18 minutes: the scenario and the solution overview (3 min), the demo plan (1 min), the live demo in SAS Retrieval Agent Manager (12 min), then the backup walk-through and the rules (2 min).</a:t>
             </a:r>
           </a:p>
         </p:txBody>
@@ -1488,22 +1483,22 @@
           </a:p>
           <a:p>
             <a:r>
-              <a:t>say, what would a programme intervention save. Three ingredients, one per card: the registry (structured, in CAS),</a:t>
-            </a:r>
-          </a:p>
-          <a:p>
-            <a:r>
-              <a:t>the guidelines (unstructured, in a RAM collection), and the model (built in Model Studio, published for scoring).</a:t>
-            </a:r>
-          </a:p>
-          <a:p>
-            <a:r>
-              <a:t>Say clearly that the data is synthetic and the guidelines are a teaching set: the numbers are real for this data, not</a:t>
-            </a:r>
-          </a:p>
-          <a:p>
-            <a:r>
-              <a:t>for EHS. These three cards are exactly the three things the participants will create.</a:t>
+              <a:t>say, what would a programme intervention save. Three ingredients, one per card: the registry (in CAS), the guidelines</a:t>
+            </a:r>
+          </a:p>
+          <a:p>
+            <a:r>
+              <a:t>(in a RAM collection), and the model (built in Model Studio, published for scoring). Say clearly that the data is</a:t>
+            </a:r>
+          </a:p>
+          <a:p>
+            <a:r>
+              <a:t>synthetic and the guidelines are a teaching set. These three cards are exactly the three things the participants</a:t>
+            </a:r>
+          </a:p>
+          <a:p>
+            <a:r>
+              <a:t>will create.</a:t>
             </a:r>
           </a:p>
         </p:txBody>
@@ -1598,7 +1593,7 @@
           </a:p>
           <a:p>
             <a:r>
-              <a:t>bottom is what the solution delivers. Everything on this slide is what the participants assemble in the hands-on.</a:t>
+              <a:t>bottom is what the solution gives you. Everything on this slide is what the participants assemble in the hands-on.</a:t>
             </a:r>
           </a:p>
         </p:txBody>
@@ -1673,32 +1668,32 @@
           </a:p>
           <a:p>
             <a:r>
-              <a:t>count (so the room sees a query and a cohort), a comparison (a chart and the equity rule firing on its own), a pure</a:t>
-            </a:r>
-          </a:p>
-          <a:p>
-            <a:r>
-              <a:t>guideline question (no query at all, just the citation), a question that needs RAG and SQL together, and a model</a:t>
-            </a:r>
-          </a:p>
-          <a:p>
-            <a:r>
-              <a:t>score for one patient. For each question, show the answer first, then open the trace and point at the tool call or</a:t>
-            </a:r>
-          </a:p>
-          <a:p>
-            <a:r>
-              <a:t>the retrieved passage. Expected answers are in the kit (agents/population_health_agent.md): 4,000 patients, 34.9% well</a:t>
-            </a:r>
-          </a:p>
-          <a:p>
-            <a:r>
-              <a:t>controlled; Ajman 46.3% to Umm Al Quwain 22.0%; LDL below 1.4 mmol/L; 399 eligible, 373 not yet treated; EHS-100092</a:t>
-            </a:r>
-          </a:p>
-          <a:p>
-            <a:r>
-              <a:t>well above the 10.4% base rate. If the environment is slow, drop question 2; if it fails, use slide 17.</a:t>
+              <a:t>count (so the room sees a query and a cohort), a comparison (a chart, and the equity rule firing on its own), a pure</a:t>
+            </a:r>
+          </a:p>
+          <a:p>
+            <a:r>
+              <a:t>guideline question (no query, just the citation), one that needs RAG and SQL together, and a model score for one</a:t>
+            </a:r>
+          </a:p>
+          <a:p>
+            <a:r>
+              <a:t>patient. For each, show the answer first, then open the trace and point at the tool call or the retrieved passage.</a:t>
+            </a:r>
+          </a:p>
+          <a:p>
+            <a:r>
+              <a:t>Expected answers are in the kit (agents/population_health_agent.md): 4,000 patients, 34.9% well controlled; Ajman</a:t>
+            </a:r>
+          </a:p>
+          <a:p>
+            <a:r>
+              <a:t>46.3% to Umm Al Quwain 22.0%; LDL below 1.4 mmol/L; 399 eligible, 373 not yet treated; EHS-100092 well above the</a:t>
+            </a:r>
+          </a:p>
+          <a:p>
+            <a:r>
+              <a:t>10.4% base rate. If the environment is slow, drop question 2; if it fails, use slide 17.</a:t>
             </a:r>
           </a:p>
         </p:txBody>
@@ -1778,7 +1773,7 @@
           </a:p>
           <a:p>
             <a:r>
-              <a:t>story, with the real numbers. Three design decisions hide in it: the guideline was retrieved before any number was</a:t>
+              <a:t>story, with the real numbers. Three design decisions hide in it: the guideline was read before any number was</a:t>
             </a:r>
           </a:p>
           <a:p>
@@ -1858,32 +1853,27 @@
           <a:lstStyle/>
           <a:p>
             <a:r>
-              <a:t>Six guardrails, and the point is where they live: in the agent's written instructions (the system prompt the</a:t>
-            </a:r>
-          </a:p>
-          <a:p>
-            <a:r>
-              <a:t>participants will paste) and in the tools (the MCP server's scope, the consent filter), not in the model's good</a:t>
-            </a:r>
-          </a:p>
-          <a:p>
-            <a:r>
-              <a:t>judgement. Numbers from queries, citations or silence, consent, humans decide, scoped tools, a visible trace. These</a:t>
-            </a:r>
-          </a:p>
-          <a:p>
-            <a:r>
-              <a:t>six are also the answer to 'how do we audit an agent?': the trace shows every call, the scope shows what it could</a:t>
-            </a:r>
-          </a:p>
-          <a:p>
-            <a:r>
-              <a:t>reach, and the instructions show what it was told. Carry this list into the hands-on: each team writes these rules</a:t>
-            </a:r>
-          </a:p>
-          <a:p>
-            <a:r>
-              <a:t>into its own agent.</a:t>
+              <a:t>Six rules, and the point is where they live: in the agent's written instructions (the system prompt the participants</a:t>
+            </a:r>
+          </a:p>
+          <a:p>
+            <a:r>
+              <a:t>will paste) and in the tools (the MCP server's scope, the consent filter), not in the model's good judgement. Numbers</a:t>
+            </a:r>
+          </a:p>
+          <a:p>
+            <a:r>
+              <a:t>from queries, a section or silence, consent, people decide, scoped tools, everything on record. These six are also</a:t>
+            </a:r>
+          </a:p>
+          <a:p>
+            <a:r>
+              <a:t>the answer to 'how do we audit an agent?': the trace shows every call, the scope shows what it could reach, and the</a:t>
+            </a:r>
+          </a:p>
+          <a:p>
+            <a:r>
+              <a:t>instructions show what it was told. Carry the list into the hands-on: each team writes these rules into its own agent.</a:t>
             </a:r>
           </a:p>
         </p:txBody>
@@ -2028,17 +2018,12 @@
           </a:p>
           <a:p>
             <a:r>
-              <a:t>build are the same agent: same registry, same guidelines, same model, same tools. Everything in parts 1 and 2 is there</a:t>
-            </a:r>
-          </a:p>
-          <a:p>
-            <a:r>
-              <a:t>so that the demo makes sense, and everything in the demo is there so that the build makes sense. The card on the right</a:t>
-            </a:r>
-          </a:p>
-          <a:p>
-            <a:r>
-              <a:t>is the contract with the room: three things they will be able to do.</a:t>
+              <a:t>build are the same agent: same registry, same guidelines, same model, same tools. Parts 1 and 2 exist so the demo makes</a:t>
+            </a:r>
+          </a:p>
+          <a:p>
+            <a:r>
+              <a:t>sense; the demo exists so the build makes sense. The card on the right is the promise to the room.</a:t>
             </a:r>
           </a:p>
         </p:txBody>
@@ -2118,17 +2103,17 @@
           </a:p>
           <a:p>
             <a:r>
-              <a:t>the agent itself. Point at the coloured tags: the colours match the building blocks from part 2. Mention the copilot:</a:t>
-            </a:r>
-          </a:p>
-          <a:p>
-            <a:r>
-              <a:t>a pre-built agent in RAM can do the data loading and the model build through MCP on request, which is itself a nice</a:t>
-            </a:r>
-          </a:p>
-          <a:p>
-            <a:r>
-              <a:t>demonstration of an agent at work. The hands-on guide has a screenshot for every click.</a:t>
+              <a:t>the agent itself. Point at the coloured tags: the colours match the parts from the second section. Mention the</a:t>
+            </a:r>
+          </a:p>
+          <a:p>
+            <a:r>
+              <a:t>copilot: a pre-built agent in RAM can do the data loading and the model build through MCP on request, which is itself</a:t>
+            </a:r>
+          </a:p>
+          <a:p>
+            <a:r>
+              <a:t>a nice demonstration of an agent at work. The hands-on guide has a screenshot for every click.</a:t>
             </a:r>
           </a:p>
         </p:txBody>
@@ -2198,22 +2183,17 @@
           <a:lstStyle/>
           <a:p>
             <a:r>
-              <a:t>The reference slide for the hands-on: one row per component, what it gives the agent, where it is built, and the</a:t>
-            </a:r>
-          </a:p>
-          <a:p>
-            <a:r>
-              <a:t>material in the kit. Skippable if you are behind; the hands-on guide repeats all of it with screenshots. If you keep</a:t>
-            </a:r>
-          </a:p>
-          <a:p>
-            <a:r>
-              <a:t>it, read only the third column: everything in SAS Viya is data and model, everything in RAM is knowledge, tools and</a:t>
-            </a:r>
-          </a:p>
-          <a:p>
-            <a:r>
-              <a:t>the agent.</a:t>
+              <a:t>The reference slide for the hands-on: one row per part, what it does, where it lives, and what is in the kit.</a:t>
+            </a:r>
+          </a:p>
+          <a:p>
+            <a:r>
+              <a:t>Skippable if you are behind; the hands-on guide repeats all of it with screenshots. If you keep it, read only the</a:t>
+            </a:r>
+          </a:p>
+          <a:p>
+            <a:r>
+              <a:t>third column: everything in SAS Viya is data and model, everything in RAM is knowledge, tools and the agent.</a:t>
             </a:r>
           </a:p>
         </p:txBody>
@@ -2283,17 +2263,17 @@
           <a:lstStyle/>
           <a:p>
             <a:r>
-              <a:t>Three sentences to remember. If they remember only one: the LLM reasons, and everything around it keeps it honest.</a:t>
-            </a:r>
-          </a:p>
-          <a:p>
-            <a:r>
-              <a:t>Then hand over to the hands-on part: the participants build exactly the agent they have just seen, step by step, with</a:t>
-            </a:r>
-          </a:p>
-          <a:p>
-            <a:r>
-              <a:t>the materials in the kit.</a:t>
+              <a:t>Three sentences to remember. If they keep only one: the LLM thinks, and everything around it keeps it honest. Then</a:t>
+            </a:r>
+          </a:p>
+          <a:p>
+            <a:r>
+              <a:t>hand over to the hands-on: the participants build exactly the agent they have just seen, step by step, with the</a:t>
+            </a:r>
+          </a:p>
+          <a:p>
+            <a:r>
+              <a:t>materials in the kit.</a:t>
             </a:r>
           </a:p>
         </p:txBody>
@@ -2433,7 +2413,7 @@
           <a:lstStyle/>
           <a:p>
             <a:r>
-              <a:t>Part 1 of 4. About 8 minutes: three generations of AI, the agent loop, and where agents fit in healthcare.</a:t>
+              <a:t>Part 1 of 4. About 8 minutes: three kinds of AI, the loop, and where agents already fit in healthcare.</a:t>
             </a:r>
           </a:p>
         </p:txBody>
@@ -2503,22 +2483,22 @@
           <a:lstStyle/>
           <a:p>
             <a:r>
-              <a:t>Three generations, one sentence each. Analytical AI predicts: EHS already runs this (risk scores, forecasts). Generative</a:t>
-            </a:r>
-          </a:p>
-          <a:p>
-            <a:r>
-              <a:t>AI creates language: most of the room has used a chatbot. Agentic AI acts: it is given a goal, and it works through the</a:t>
-            </a:r>
-          </a:p>
-          <a:p>
-            <a:r>
-              <a:t>steps itself, calling the other two as tools. The callout is the point of the whole session: the agent is not a better</a:t>
-            </a:r>
-          </a:p>
-          <a:p>
-            <a:r>
-              <a:t>chatbot, it is an orchestrator of things you already have. The third card is blue on purpose: it is the one we build.</a:t>
+              <a:t>Three kinds of AI, one sentence each. Machine learning predicts, and EHS already runs it (risk scores, forecasts).</a:t>
+            </a:r>
+          </a:p>
+          <a:p>
+            <a:r>
+              <a:t>Generative AI writes, and most of the room has used a chatbot. Agentic AI is given a goal and works through the steps</a:t>
+            </a:r>
+          </a:p>
+          <a:p>
+            <a:r>
+              <a:t>itself, calling the other two as tools. The callout is the message of the whole session: this is not a better</a:t>
+            </a:r>
+          </a:p>
+          <a:p>
+            <a:r>
+              <a:t>chatbot, it is an orchestrator of things you already own. The third card is blue because it is the one we build.</a:t>
             </a:r>
           </a:p>
         </p:txBody>
@@ -2588,27 +2568,27 @@
           <a:lstStyle/>
           <a:p>
             <a:r>
-              <a:t>This loop is the definition of 'agentic'. Four beats: perceive, reason and plan, act, observe, then round again. A</a:t>
-            </a:r>
-          </a:p>
-          <a:p>
-            <a:r>
-              <a:t>chatbot runs the loop once; an agent runs it until the goal is met or a boundary stops it. Three words carry the rest</a:t>
-            </a:r>
-          </a:p>
-          <a:p>
-            <a:r>
-              <a:t>of the session: goal, tools, boundaries. If people ask 'where is the LLM?', point to Reason &amp; plan: that is where it</a:t>
-            </a:r>
-          </a:p>
-          <a:p>
-            <a:r>
-              <a:t>lives, and only there. Everything else in the loop is ordinary software that we control. You will see this loop in the</a:t>
-            </a:r>
-          </a:p>
-          <a:p>
-            <a:r>
-              <a:t>demo as the trace: every turn shows up as a retrieval, a query or a model call.</a:t>
+              <a:t>This loop is what the word 'agentic' means. Four beats: perceive, reason and plan, act, observe, then round again. A</a:t>
+            </a:r>
+          </a:p>
+          <a:p>
+            <a:r>
+              <a:t>chatbot goes round once; an agent keeps going until the goal is met or a limit stops it. Three words carry the rest of</a:t>
+            </a:r>
+          </a:p>
+          <a:p>
+            <a:r>
+              <a:t>the session: goal, tools, lines. If someone asks 'where is the LLM?', point at Reason &amp; plan: that is where it lives,</a:t>
+            </a:r>
+          </a:p>
+          <a:p>
+            <a:r>
+              <a:t>and only there. Everything else is ordinary software that we control. In the demo this loop shows up as the trace:</a:t>
+            </a:r>
+          </a:p>
+          <a:p>
+            <a:r>
+              <a:t>every turn is a retrieval, a query or a model call you can see.</a:t>
             </a:r>
           </a:p>
         </p:txBody>
@@ -2678,22 +2658,22 @@
           <a:lstStyle/>
           <a:p>
             <a:r>
-              <a:t>Six patterns, all real, all the same shape: the agent reads, reasons and drafts; a person decides. Read the blue foot</a:t>
-            </a:r>
-          </a:p>
-          <a:p>
-            <a:r>
-              <a:t>line of each card aloud, because that is what makes them acceptable in a hospital. The first card is today's demo and</a:t>
-            </a:r>
-          </a:p>
-          <a:p>
-            <a:r>
-              <a:t>the bootcamp's build. Invite the room to map their own process onto one of the six; most back-office and</a:t>
-            </a:r>
-          </a:p>
-          <a:p>
-            <a:r>
-              <a:t>programme-management work fits. Skip this slide if you are behind.</a:t>
+              <a:t>Six patterns, all real, all the same shape: the agent reads, reasons and drafts; a person decides. Read the blue line</a:t>
+            </a:r>
+          </a:p>
+          <a:p>
+            <a:r>
+              <a:t>on each card aloud, because that line is what makes an agent acceptable in a hospital. The first card is today's demo</a:t>
+            </a:r>
+          </a:p>
+          <a:p>
+            <a:r>
+              <a:t>and the bootcamp's build. Ask the room to map their own process onto one of the six; most programme and back-office</a:t>
+            </a:r>
+          </a:p>
+          <a:p>
+            <a:r>
+              <a:t>work fits. Skip this slide if you are behind.</a:t>
             </a:r>
           </a:p>
         </p:txBody>
@@ -2763,7 +2743,7 @@
           <a:lstStyle/>
           <a:p>
             <a:r>
-              <a:t>Part 2 of 4. About 10 minutes: the map, then one slide each for the language model, RAG, MCP, and composite AI with one question flowing through all of them.</a:t>
+              <a:t>Part 2 of 4. About 10 minutes: the map, then one slide each on the language model, RAG, MCP, and one question going through all of them.</a:t>
             </a:r>
           </a:p>
         </p:txBody>
@@ -2833,27 +2813,27 @@
           <a:lstStyle/>
           <a:p>
             <a:r>
-              <a:t>The map for the next four slides. The language model is in the middle because it reasons, plans and writes, and only</a:t>
-            </a:r>
-          </a:p>
-          <a:p>
-            <a:r>
-              <a:t>that. Knowledge is what it can quote (RAG). Tools are what it can call (MCP). Models and rules are the analytics you</a:t>
-            </a:r>
-          </a:p>
-          <a:p>
-            <a:r>
-              <a:t>already own, exposed as tools (composite AI). People set the goal and the boundaries and take the decisions. Say the</a:t>
-            </a:r>
-          </a:p>
-          <a:p>
-            <a:r>
-              <a:t>footer sentence slowly: the model never touches your data or systems directly. That is the sentence that makes the</a:t>
-            </a:r>
-          </a:p>
-          <a:p>
-            <a:r>
-              <a:t>security people in the room relax.</a:t>
+              <a:t>The map for the next four slides. The language model is in the middle because it thinks, plans and writes, and only</a:t>
+            </a:r>
+          </a:p>
+          <a:p>
+            <a:r>
+              <a:t>that. Knowledge is what it can quote (RAG). Tools are what it can call (MCP). Your models and rules are the analytics</a:t>
+            </a:r>
+          </a:p>
+          <a:p>
+            <a:r>
+              <a:t>you already own, exposed as tools (composite AI). People set the goal and the limits and take the decisions. Say the</a:t>
+            </a:r>
+          </a:p>
+          <a:p>
+            <a:r>
+              <a:t>footer sentence slowly: the model never touches your data or systems. That is the sentence that makes the security</a:t>
+            </a:r>
+          </a:p>
+          <a:p>
+            <a:r>
+              <a:t>people in the room relax.</a:t>
             </a:r>
           </a:p>
         </p:txBody>
@@ -2923,27 +2903,27 @@
           <a:lstStyle/>
           <a:p>
             <a:r>
-              <a:t>Give the language model its due and its limits. Good at language, planning and faithful summarising. Cannot know your</a:t>
-            </a:r>
-          </a:p>
-          <a:p>
-            <a:r>
-              <a:t>data or your current guideline, cannot count reliably, cannot run anything. When none of its sources contains the</a:t>
-            </a:r>
-          </a:p>
-          <a:p>
-            <a:r>
-              <a:t>answer it produces a plausible guess: that is the hallucination problem, and the cure is design, not hope. The callout</a:t>
-            </a:r>
-          </a:p>
-          <a:p>
-            <a:r>
-              <a:t>is the structure of the next three slides: RAG, tools and models, people. Ask the room which of the four 'cannot'</a:t>
-            </a:r>
-          </a:p>
-          <a:p>
-            <a:r>
-              <a:t>items worries them most; the answer is usually the guideline, which is exactly what RAG fixes.</a:t>
+              <a:t>Give the language model its due and its limits. Good with language, planning and faithful summarising. It cannot know</a:t>
+            </a:r>
+          </a:p>
+          <a:p>
+            <a:r>
+              <a:t>your data or today's guideline, cannot count reliably, cannot run anything. When none of its sources has the answer it</a:t>
+            </a:r>
+          </a:p>
+          <a:p>
+            <a:r>
+              <a:t>produces a plausible guess: that is the hallucination problem, and the cure is design, not hope. The callout is the</a:t>
+            </a:r>
+          </a:p>
+          <a:p>
+            <a:r>
+              <a:t>plan for the next three slides: RAG, tools and models, people. Ask which of the four 'cannot' lines worries them</a:t>
+            </a:r>
+          </a:p>
+          <a:p>
+            <a:r>
+              <a:t>most; usually the guideline, which is exactly what RAG fixes.</a:t>
             </a:r>
           </a:p>
         </p:txBody>
@@ -6563,7 +6543,7 @@
           <a:p>
             <a:r>
               <a:rPr sz="3600"/>
-              <a:t>From the concepts to a live Population Health agent</a:t>
+              <a:t>From the concepts to a working Population Health agent</a:t>
             </a:r>
           </a:p>
         </p:txBody>
@@ -6848,8 +6828,8 @@
           <a:lstStyle/>
           <a:p>
             <a:r>
-              <a:rPr sz="5000"/>
-              <a:t>RAG: Retrieval-Augmented Generation</a:t>
+              <a:rPr sz="5600"/>
+              <a:t>RAG in one picture</a:t>
             </a:r>
           </a:p>
         </p:txBody>
@@ -6871,7 +6851,7 @@
           <a:p>
             <a:r>
               <a:rPr sz="3000"/>
-              <a:t>Answers from your documents, with the section cited, or “not covered”</a:t>
+              <a:t>How the agent answers from your documents instead of from memory</a:t>
             </a:r>
           </a:p>
         </p:txBody>
@@ -6984,7 +6964,7 @@
                 </a:solidFill>
                 <a:latin typeface="+mj-lt"/>
               </a:rPr>
-              <a:t>Before: build the knowledge base</a:t>
+              <a:t>Once, when you build the knowledge base</a:t>
             </a:r>
           </a:p>
         </p:txBody>
@@ -7167,7 +7147,7 @@
                   <a:srgbClr val="262626"/>
                 </a:solidFill>
               </a:rPr>
-              <a:t>The four NHA guideline PDFs: diabetes, lipids, hypertension, screening and recall.</a:t>
+              <a:t>The four NHA guidelines as PDFs. Diabetes, lipids, hypertension, screening and recall.</a:t>
             </a:r>
           </a:p>
         </p:txBody>
@@ -7394,7 +7374,7 @@
                   <a:srgbClr val="262626"/>
                 </a:solidFill>
               </a:rPr>
-              <a:t>Split into passages of 600 to 800 characters, with overlap, so a section stays together.</a:t>
+              <a:t>Cut into passages of a few hundred characters, with overlap, so a section stays in one piece.</a:t>
             </a:r>
           </a:p>
         </p:txBody>
@@ -7587,7 +7567,7 @@
                 </a:solidFill>
                 <a:latin typeface="+mj-lt"/>
               </a:rPr>
-              <a:t>Embedding model</a:t>
+              <a:t>Embed</a:t>
             </a:r>
           </a:p>
         </p:txBody>
@@ -7621,7 +7601,7 @@
                   <a:srgbClr val="262626"/>
                 </a:solidFill>
               </a:rPr>
-              <a:t>Turn each passage into a vector: a numeric fingerprint of its meaning.</a:t>
+              <a:t>Each passage becomes a vector, a numeric fingerprint of what it means.</a:t>
             </a:r>
           </a:p>
         </p:txBody>
@@ -7814,7 +7794,7 @@
                 </a:solidFill>
                 <a:latin typeface="+mj-lt"/>
               </a:rPr>
-              <a:t>Vector store</a:t>
+              <a:t>Store</a:t>
             </a:r>
           </a:p>
         </p:txBody>
@@ -7848,7 +7828,7 @@
                   <a:srgbClr val="262626"/>
                 </a:solidFill>
               </a:rPr>
-              <a:t>Keep the vectors so that passages can be found by meaning, not by keyword.</a:t>
+              <a:t>The vectors are kept so a passage can be found by meaning, not by keyword.</a:t>
             </a:r>
           </a:p>
         </p:txBody>
@@ -7961,7 +7941,7 @@
                 </a:solidFill>
                 <a:latin typeface="+mj-lt"/>
               </a:rPr>
-              <a:t>At question time: retrieve, then generate</a:t>
+              <a:t>Every time someone asks a question</a:t>
             </a:r>
           </a:p>
         </p:txBody>
@@ -8371,7 +8351,7 @@
                   <a:srgbClr val="262626"/>
                 </a:solidFill>
               </a:rPr>
-              <a:t>Embed the question; fetch the 4 to 6 passages closest in meaning.</a:t>
+              <a:t>The question gets its own fingerprint. The four to six closest passages come back.</a:t>
             </a:r>
           </a:p>
         </p:txBody>
@@ -8564,7 +8544,7 @@
                 </a:solidFill>
                 <a:latin typeface="+mj-lt"/>
               </a:rPr>
-              <a:t>Generate</a:t>
+              <a:t>Write</a:t>
             </a:r>
           </a:p>
         </p:txBody>
@@ -8598,7 +8578,7 @@
                   <a:srgbClr val="262626"/>
                 </a:solidFill>
               </a:rPr>
-              <a:t>The LLM writes the answer from those passages only, nothing from memory.</a:t>
+              <a:t>The LLM writes from those passages and nothing else.</a:t>
             </a:r>
           </a:p>
         </p:txBody>
@@ -8825,7 +8805,7 @@
                   <a:srgbClr val="262626"/>
                 </a:solidFill>
               </a:rPr>
-              <a:t>“Below 1.4 mmol/L, NHA-CG-02 §3.” Or: “not covered by the guidelines in my collection.”</a:t>
+              <a:t>“Below 1.4 mmol/L, NHA-CG-02 §3.” And if the documents are silent, it says so.</a:t>
             </a:r>
           </a:p>
         </p:txBody>
@@ -9082,8 +9062,8 @@
           <a:lstStyle/>
           <a:p>
             <a:r>
-              <a:rPr sz="5600"/>
-              <a:t>MCP: the Model Context Protocol</a:t>
+              <a:rPr sz="5000"/>
+              <a:t>MCP: how the agent reaches your systems</a:t>
             </a:r>
           </a:p>
         </p:txBody>
@@ -9105,7 +9085,7 @@
           <a:p>
             <a:r>
               <a:rPr sz="3000"/>
-              <a:t>One standard plug between the agent and your data, models and systems</a:t>
+              <a:t>One standard plug. The agent asks, the server does the work, everything is written down.</a:t>
             </a:r>
           </a:p>
         </p:txBody>
@@ -9369,7 +9349,7 @@
                 </a:solidFill>
                 <a:latin typeface="+mj-lt"/>
               </a:rPr>
-              <a:t>Goal &amp; rules</a:t>
+              <a:t>Goal and rules</a:t>
             </a:r>
           </a:p>
         </p:txBody>
@@ -9472,7 +9452,7 @@
                 </a:solidFill>
                 <a:latin typeface="+mj-lt"/>
               </a:rPr>
-              <a:t>Reasoning engine (LLM)</a:t>
+              <a:t>The LLM</a:t>
             </a:r>
           </a:p>
         </p:txBody>
@@ -9575,7 +9555,7 @@
                 </a:solidFill>
                 <a:latin typeface="+mj-lt"/>
               </a:rPr>
-              <a:t>Knowledge (RAG)</a:t>
+              <a:t>The guidelines (RAG)</a:t>
             </a:r>
           </a:p>
         </p:txBody>
@@ -9678,7 +9658,7 @@
                 </a:solidFill>
                 <a:latin typeface="+mj-lt"/>
               </a:rPr>
-              <a:t>Memory of this task</a:t>
+              <a:t>What happened so far</a:t>
             </a:r>
           </a:p>
         </p:txBody>
@@ -9776,7 +9756,7 @@
                   <a:srgbClr val="FFFFFF"/>
                 </a:solidFill>
               </a:rPr>
-              <a:t>tool descriptions  ·  permissions  ·  audit log</a:t>
+              <a:t>knows the tools, who may call them, and keeps the log</a:t>
             </a:r>
           </a:p>
         </p:txBody>
@@ -9849,7 +9829,7 @@
                 </a:solidFill>
                 <a:latin typeface="+mj-lt"/>
               </a:rPr>
-              <a:t>asks  ·  gets results</a:t>
+              <a:t>asks, gets the result</a:t>
             </a:r>
           </a:p>
         </p:txBody>
@@ -10004,7 +9984,7 @@
                 </a:solidFill>
                 <a:latin typeface="+mj-lt"/>
               </a:rPr>
-              <a:t>Query data (SQL)</a:t>
+              <a:t>Query the registry</a:t>
             </a:r>
           </a:p>
         </p:txBody>
@@ -10038,7 +10018,7 @@
                   <a:srgbClr val="7E889A"/>
                 </a:solidFill>
               </a:rPr>
-              <a:t>FedSQL over the registry tables in SAS Viya CAS: counts, rates, costs, one patient</a:t>
+              <a:t>FedSQL on the CAS tables. Counts, rates, costs, or one patient</a:t>
             </a:r>
           </a:p>
         </p:txBody>
@@ -10230,7 +10210,7 @@
                 </a:solidFill>
                 <a:latin typeface="+mj-lt"/>
               </a:rPr>
-              <a:t>Score the ML model</a:t>
+              <a:t>Score the model</a:t>
             </a:r>
           </a:p>
         </p:txBody>
@@ -10264,7 +10244,7 @@
                   <a:srgbClr val="7E889A"/>
                 </a:solidFill>
               </a:rPr>
-              <a:t>The published deterioration-risk model in SAS Micro Analytic Service</a:t>
+              <a:t>The published risk model in SAS Micro Analytic Service</a:t>
             </a:r>
           </a:p>
         </p:txBody>
@@ -10490,7 +10470,7 @@
                   <a:srgbClr val="7E889A"/>
                 </a:solidFill>
               </a:rPr>
-              <a:t>SAS Intelligent Decisioning rules: recall priority, the 30-day window</a:t>
+              <a:t>SAS Intelligent Decisioning. Recall priority, the 30-day window</a:t>
             </a:r>
           </a:p>
         </p:txBody>
@@ -10682,7 +10662,7 @@
                 </a:solidFill>
                 <a:latin typeface="+mj-lt"/>
               </a:rPr>
-              <a:t>Generate a chart</a:t>
+              <a:t>Draw a chart</a:t>
             </a:r>
           </a:p>
         </p:txBody>
@@ -10788,7 +10768,7 @@
                 </a:solidFill>
                 <a:latin typeface="+mj-lt"/>
               </a:rPr>
-              <a:t>Tools, described in plain language</a:t>
+              <a:t>Each tool comes with a one-line description the agent reads</a:t>
             </a:r>
           </a:p>
         </p:txBody>
@@ -10892,7 +10872,7 @@
                   <a:srgbClr val="032954"/>
                 </a:solidFill>
               </a:rPr>
-              <a:t>Think USB-C: one plug, any device. Tools are described in plain language so you can read what the agent can reach; the agent asks and the server executes with the permissions you granted; every call is logged.</a:t>
+              <a:t>Think USB-C: one plug, any device. You can read the tool list and know exactly what the agent can reach. Nothing else.</a:t>
             </a:r>
           </a:p>
         </p:txBody>
@@ -11149,8 +11129,8 @@
           <a:lstStyle/>
           <a:p>
             <a:r>
-              <a:rPr sz="4600"/>
-              <a:t>Composite AI: one question, several engines</a:t>
+              <a:rPr sz="5600"/>
+              <a:t>One question, four engines</a:t>
             </a:r>
           </a:p>
         </p:txBody>
@@ -11172,7 +11152,7 @@
           <a:p>
             <a:r>
               <a:rPr sz="3000"/>
-              <a:t>Each kind of fact comes from the engine that is good at it</a:t>
+              <a:t>Why the answer can be trusted: each part comes from the thing that is good at it</a:t>
             </a:r>
           </a:p>
         </p:txBody>
@@ -11522,7 +11502,7 @@
                 </a:solidFill>
                 <a:latin typeface="+mj-lt"/>
               </a:rPr>
-              <a:t>Guideline retrieval (RAG)</a:t>
+              <a:t>The guideline</a:t>
             </a:r>
           </a:p>
         </p:txBody>
@@ -11556,7 +11536,7 @@
                   <a:srgbClr val="262626"/>
                 </a:solidFill>
               </a:rPr>
-              <a:t>Finds NHA-CG-01 §4: consider a GLP-1 RA when HbA1c stays above target and BMI &gt; 30.</a:t>
+              <a:t>NHA-CG-01 §4: consider a GLP-1 RA when HbA1c stays high and BMI is over 30.</a:t>
             </a:r>
           </a:p>
         </p:txBody>
@@ -11745,7 +11725,7 @@
                   <a:srgbClr val="262626"/>
                 </a:solidFill>
               </a:rPr>
-              <a:t>Counts the eligible cohort, then the share not yet treated. Every number is a query that ran.</a:t>
+              <a:t>Counts who meets that, then who is not yet treated. Both are real queries.</a:t>
             </a:r>
           </a:p>
         </p:txBody>
@@ -11900,7 +11880,7 @@
                 </a:solidFill>
                 <a:latin typeface="+mj-lt"/>
               </a:rPr>
-              <a:t>Machine learning</a:t>
+              <a:t>The risk model</a:t>
             </a:r>
           </a:p>
         </p:txBody>
@@ -11934,7 +11914,7 @@
                   <a:srgbClr val="262626"/>
                 </a:solidFill>
               </a:rPr>
-              <a:t>Scores the cohort with the deterioration model so the clinic reviews the riskiest first.</a:t>
+              <a:t>Scores that group so the clinic sees the riskiest first.</a:t>
             </a:r>
           </a:p>
         </p:txBody>
@@ -12089,7 +12069,7 @@
                 </a:solidFill>
                 <a:latin typeface="+mj-lt"/>
               </a:rPr>
-              <a:t>Decision rules</a:t>
+              <a:t>The rules</a:t>
             </a:r>
           </a:p>
         </p:txBody>
@@ -12123,7 +12103,7 @@
                   <a:srgbClr val="262626"/>
                 </a:solidFill>
               </a:rPr>
-              <a:t>Recall within 30 days; consent exclusions; the clinician signs off (NHA-CG-01 §7).</a:t>
+              <a:t>Restricted-consent patients stay out of the list. A clinician signs off (§7).</a:t>
             </a:r>
           </a:p>
         </p:txBody>
@@ -12415,7 +12395,7 @@
                   <a:srgbClr val="032954"/>
                 </a:solidFill>
               </a:rPr>
-              <a:t>Type 2, HbA1c ≥ 9%, BMI &gt; 30: </a:t>
+              <a:t>Type 2, HbA1c 9% or more, BMI over 30: </a:t>
             </a:r>
             <a:r>
               <a:rPr sz="1400">
@@ -12443,14 +12423,6 @@
                 <a:solidFill>
                   <a:srgbClr val="032954"/>
                 </a:solidFill>
-              </a:rPr>
-              <a:t>Of whom </a:t>
-            </a:r>
-            <a:r>
-              <a:rPr sz="1400">
-                <a:solidFill>
-                  <a:srgbClr val="032954"/>
-                </a:solidFill>
                 <a:latin typeface="+mj-lt"/>
               </a:rPr>
               <a:t>373</a:t>
@@ -12461,7 +12433,7 @@
                   <a:srgbClr val="032954"/>
                 </a:solidFill>
               </a:rPr>
-              <a:t> are not yet on an SGLT2i or GLP-1 RA</a:t>
+              <a:t> of them not yet on an SGLT2i or GLP-1 RA</a:t>
             </a:r>
           </a:p>
           <a:p>
@@ -12481,7 +12453,7 @@
                   <a:srgbClr val="032954"/>
                 </a:solidFill>
               </a:rPr>
-              <a:t>Guideline: consider a GLP-1 RA, </a:t>
+              <a:t>The guideline says consider a GLP-1 RA, </a:t>
             </a:r>
             <a:r>
               <a:rPr sz="1400">
@@ -12510,7 +12482,7 @@
                   <a:srgbClr val="032954"/>
                 </a:solidFill>
               </a:rPr>
-              <a:t>Top ten by model risk for the clinic to review first</a:t>
+              <a:t>Ten names for the clinic to look at first, by model risk</a:t>
             </a:r>
           </a:p>
           <a:p>
@@ -12530,7 +12502,7 @@
                   <a:srgbClr val="032954"/>
                 </a:solidFill>
               </a:rPr>
-              <a:t>A draft list; </a:t>
+              <a:t>A draft. </a:t>
             </a:r>
             <a:r>
               <a:rPr sz="1400">
@@ -12539,15 +12511,7 @@
                 </a:solidFill>
                 <a:latin typeface="+mj-lt"/>
               </a:rPr>
-              <a:t>the clinician decides</a:t>
-            </a:r>
-            <a:r>
-              <a:rPr sz="1400">
-                <a:solidFill>
-                  <a:srgbClr val="032954"/>
-                </a:solidFill>
-              </a:rPr>
-              <a:t> (§7)</a:t>
+              <a:t>The clinician decides.</a:t>
             </a:r>
           </a:p>
           <a:p>
@@ -12567,7 +12531,7 @@
                   <a:srgbClr val="032954"/>
                 </a:solidFill>
               </a:rPr>
-              <a:t>Source line: the query, the sections used</a:t>
+              <a:t>Last line: the query it ran and the sections it used</a:t>
             </a:r>
           </a:p>
         </p:txBody>
@@ -12671,7 +12635,7 @@
                   <a:srgbClr val="032954"/>
                 </a:solidFill>
               </a:rPr>
-              <a:t>The LLM never computes a number or invents a threshold. It decides which engine to call, and writes the answer from what came back.</a:t>
+              <a:t>The LLM did not count anything or invent a threshold. It chose the engines and wrote up what came back.</a:t>
             </a:r>
           </a:p>
         </p:txBody>
@@ -12733,7 +12697,7 @@
           <a:p>
             <a:r>
               <a:rPr sz="3600"/>
-              <a:t>One registry, four national guidelines, one risk model, one agent</a:t>
+              <a:t>Real questions, on the same data you will work with</a:t>
             </a:r>
           </a:p>
         </p:txBody>
@@ -13081,7 +13045,7 @@
           <a:p>
             <a:r>
               <a:rPr sz="3000"/>
-              <a:t>One programme lead, 4,000 patients, 18 facilities, and the questions asked every week</a:t>
+              <a:t>A programme lead, 4,000 patients, 18 facilities, and the same questions every Monday</a:t>
             </a:r>
           </a:p>
         </p:txBody>
@@ -13242,7 +13206,7 @@
                 </a:solidFill>
                 <a:latin typeface="+mj-lt"/>
               </a:rPr>
-              <a:t>Structured data</a:t>
+              <a:t>The registry</a:t>
             </a:r>
           </a:p>
         </p:txBody>
@@ -13276,7 +13240,7 @@
                   <a:srgbClr val="262626"/>
                 </a:solidFill>
               </a:rPr>
-              <a:t>A diabetes registry modelled on the national health information exchange: one row per patient, 4,000 patients across 18 hospitals and health centres in 5 emirates, 54 columns: HbA1c, blood pressure, lipids, kidneys, therapy, open care gaps, utilisation and cost.</a:t>
+              <a:t>One row per patient, modelled on the national HIE. 4,000 people with diabetes across 18 hospitals and health centres in five emirates. 54 columns: HbA1c, blood pressure, lipids, kidney function, therapy, open care gaps, visits, cost.</a:t>
             </a:r>
           </a:p>
         </p:txBody>
@@ -13311,7 +13275,7 @@
                 </a:solidFill>
                 <a:latin typeface="+mj-lt"/>
               </a:rPr>
-              <a:t>Loaded as a CAS table in SAS Viya</a:t>
+              <a:t>Lives in SAS Viya as a CAS table</a:t>
             </a:r>
           </a:p>
         </p:txBody>
@@ -13472,7 +13436,7 @@
                 </a:solidFill>
                 <a:latin typeface="+mj-lt"/>
               </a:rPr>
-              <a:t>Unstructured data</a:t>
+              <a:t>The guidelines</a:t>
             </a:r>
           </a:p>
         </p:txBody>
@@ -13506,7 +13470,7 @@
                   <a:srgbClr val="262626"/>
                 </a:solidFill>
               </a:rPr>
-              <a:t>Four national guidelines, section-numbered, as PDFs: NHA-CG-01 type 2 diabetes management, NHA-CG-02 cardiovascular risk and lipids, NHA-CG-03 hypertension, NHA-PP-01 population screening and recall.</a:t>
+              <a:t>Four national documents with numbered sections: type 2 diabetes (NHA-CG-01), cardiovascular risk and lipids (CG-02), hypertension (CG-03), screening and recall (PP-01).</a:t>
             </a:r>
           </a:p>
         </p:txBody>
@@ -13541,7 +13505,7 @@
                 </a:solidFill>
                 <a:latin typeface="+mj-lt"/>
               </a:rPr>
-              <a:t>Indexed as a collection in SAS Retrieval Agent Manager</a:t>
+              <a:t>Lives in SAS RAM as a collection</a:t>
             </a:r>
           </a:p>
         </p:txBody>
@@ -13702,7 +13666,7 @@
                 </a:solidFill>
                 <a:latin typeface="+mj-lt"/>
               </a:rPr>
-              <a:t>The machine learning model</a:t>
+              <a:t>The risk model</a:t>
             </a:r>
           </a:p>
         </p:txBody>
@@ -13736,7 +13700,7 @@
                   <a:srgbClr val="262626"/>
                 </a:solidFill>
               </a:rPr>
-              <a:t>Predicts a deterioration event in the next 12 months: an admission for hypo- or hyperglycaemia, DKA, a foot infection, acute kidney injury, or HbA1c rising to 10% or more. Event rate in the registry: 10.4%.</a:t>
+              <a:t>Who is likely to deteriorate in the next 12 months: an admission for a glucose crisis, a foot infection, kidney injury, or HbA1c climbing past 10%. It happens to one patient in ten.</a:t>
             </a:r>
           </a:p>
         </p:txBody>
@@ -13771,7 +13735,7 @@
                 </a:solidFill>
                 <a:latin typeface="+mj-lt"/>
               </a:rPr>
-              <a:t>Champion from Model Studio, published for scoring</a:t>
+              <a:t>Built in Model Studio, published for scoring</a:t>
             </a:r>
           </a:p>
         </p:txBody>
@@ -14265,7 +14229,7 @@
                   <a:srgbClr val="7E889A"/>
                 </a:solidFill>
               </a:rPr>
-              <a:t>All patient data is synthetic and the guidelines are a teaching set written for this bootcamp. Not for clinical use.</a:t>
+              <a:t>Synthetic patients and teaching guidelines. The numbers are real for this data, not for EHS. Not for clinical use.</a:t>
             </a:r>
           </a:p>
         </p:txBody>
@@ -15329,7 +15293,7 @@
                   <a:srgbClr val="FFFFFF"/>
                 </a:solidFill>
               </a:rPr>
-              <a:t>Patient-level queries, population insights, cost forecasting and policy simulation, with traceable, cited reasoning</a:t>
+              <a:t>Answers questions about patients, cohorts, cost and policy, and shows where every answer came from</a:t>
             </a:r>
           </a:p>
         </p:txBody>
@@ -15424,7 +15388,7 @@
                   <a:srgbClr val="032954"/>
                 </a:solidFill>
               </a:rPr>
-              <a:t>  ·  picks the tool for each step</a:t>
+              <a:t>  ·  picks the next tool</a:t>
             </a:r>
           </a:p>
           <a:p>
@@ -15453,7 +15417,7 @@
                   <a:srgbClr val="032954"/>
                 </a:solidFill>
               </a:rPr>
-              <a:t>  ·  cites document and section</a:t>
+              <a:t>  ·  quotes the section</a:t>
             </a:r>
           </a:p>
           <a:p>
@@ -15482,7 +15446,7 @@
                   <a:srgbClr val="032954"/>
                 </a:solidFill>
               </a:rPr>
-              <a:t>  ·  every call visible in the trace</a:t>
+              <a:t>  ·  every call on record</a:t>
             </a:r>
           </a:p>
         </p:txBody>
@@ -16315,7 +16279,7 @@
                 </a:solidFill>
                 <a:latin typeface="+mj-lt"/>
               </a:rPr>
-              <a:t>What this solution delivers</a:t>
+              <a:t>What this gives you</a:t>
             </a:r>
           </a:p>
           <a:p>
@@ -16326,7 +16290,7 @@
                   <a:srgbClr val="032954"/>
                 </a:solidFill>
               </a:rPr>
-              <a:t>Natural-language questions → governed analytics, cohorts and charts   ·   ML scoring, forecasting and policy simulation on demand   ·   Every answer cites the national guideline and shows its tool calls</a:t>
+              <a:t>Ask in plain English or Arabic and get governed numbers, cohorts and charts   ·   Score, forecast and test a policy on demand   ·   Every answer cites the guideline and shows the tools it used</a:t>
             </a:r>
           </a:p>
         </p:txBody>
@@ -16584,7 +16548,7 @@
           <a:p>
             <a:r>
               <a:rPr sz="5600"/>
-              <a:t>What you will see in the demo</a:t>
+              <a:t>The demo: five questions</a:t>
             </a:r>
           </a:p>
         </p:txBody>
@@ -16606,7 +16570,7 @@
           <a:p>
             <a:r>
               <a:rPr sz="3000"/>
-              <a:t>Five real questions, and what to watch for in the agent's trace</a:t>
+              <a:t>What I will ask, what happens underneath, and what to watch for</a:t>
             </a:r>
           </a:p>
         </p:txBody>
@@ -16672,7 +16636,7 @@
                           </a:solidFill>
                           <a:latin typeface="+mj-lt"/>
                         </a:rPr>
-                        <a:t>The question</a:t>
+                        <a:t>I will ask</a:t>
                       </a:r>
                     </a:p>
                   </a:txBody>
@@ -16695,7 +16659,7 @@
                           </a:solidFill>
                           <a:latin typeface="+mj-lt"/>
                         </a:rPr>
-                        <a:t>What the agent does</a:t>
+                        <a:t>What happens underneath</a:t>
                       </a:r>
                     </a:p>
                   </a:txBody>
@@ -16766,7 +16730,7 @@
                           </a:solidFill>
                           <a:latin typeface="+mj-lt"/>
                         </a:rPr>
-                        <a:t>How many patients are in the registry, and how many are well controlled?</a:t>
+                        <a:t>How many patients do we have, and how many are well controlled?</a:t>
                       </a:r>
                     </a:p>
                   </a:txBody>
@@ -16788,7 +16752,7 @@
                             <a:srgbClr val="262626"/>
                           </a:solidFill>
                         </a:rPr>
-                        <a:t>One SQL query on the registry; cites NHA-CG-01 §2 for the HbA1c bands</a:t>
+                        <a:t>One query. The HbA1c bands come from NHA-CG-01 §2.</a:t>
                       </a:r>
                     </a:p>
                   </a:txBody>
@@ -16810,7 +16774,7 @@
                             <a:srgbClr val="262626"/>
                           </a:solidFill>
                         </a:rPr>
-                        <a:t>The query in the trace; the cohort stated next to every number</a:t>
+                        <a:t>The query in the trace. Every number has its cohort next to it.</a:t>
                       </a:r>
                     </a:p>
                   </a:txBody>
@@ -16858,7 +16822,7 @@
                           </a:solidFill>
                           <a:latin typeface="+mj-lt"/>
                         </a:rPr>
-                        <a:t>Compare glycaemic control across the emirates.</a:t>
+                        <a:t>Compare control across the emirates.</a:t>
                       </a:r>
                     </a:p>
                   </a:txBody>
@@ -16880,7 +16844,7 @@
                             <a:srgbClr val="262626"/>
                           </a:solidFill>
                         </a:rPr>
-                        <a:t>A group-by query, a chart, and the equity check against NHA-PP-01 §4</a:t>
+                        <a:t>A group-by query and a chart. Then it checks the gap against NHA-PP-01 §4.</a:t>
                       </a:r>
                     </a:p>
                   </a:txBody>
@@ -16902,7 +16866,7 @@
                             <a:srgbClr val="262626"/>
                           </a:solidFill>
                         </a:rPr>
-                        <a:t>The 5-point equity trigger, named without being asked</a:t>
+                        <a:t>It names the equity trigger on its own. Nobody asked.</a:t>
                       </a:r>
                     </a:p>
                   </a:txBody>
@@ -16972,7 +16936,7 @@
                             <a:srgbClr val="262626"/>
                           </a:solidFill>
                         </a:rPr>
-                        <a:t>Retrieval only: no query; the answer comes from NHA-CG-02 §3</a:t>
+                        <a:t>No query at all. Pure retrieval, NHA-CG-02 §3.</a:t>
                       </a:r>
                     </a:p>
                   </a:txBody>
@@ -16994,7 +16958,7 @@
                             <a:srgbClr val="262626"/>
                           </a:solidFill>
                         </a:rPr>
-                        <a:t>The citation, and “not covered” when the collection is silent</a:t>
+                        <a:t>The citation. And what it says when the documents are silent.</a:t>
                       </a:r>
                     </a:p>
                   </a:txBody>
@@ -17042,7 +17006,7 @@
                           </a:solidFill>
                           <a:latin typeface="+mj-lt"/>
                         </a:rPr>
-                        <a:t>Who would qualify for a GLP-1 RA under the guideline, and how many are already on one?</a:t>
+                        <a:t>Who would qualify for a GLP-1 RA, and how many are already on one?</a:t>
                       </a:r>
                     </a:p>
                   </a:txBody>
@@ -17064,7 +17028,7 @@
                             <a:srgbClr val="262626"/>
                           </a:solidFill>
                         </a:rPr>
-                        <a:t>Guideline first (NHA-CG-01 §4), then two queries: eligible, and not yet treated</a:t>
+                        <a:t>Guideline first, then two queries: who qualifies, who is not yet treated.</a:t>
                       </a:r>
                     </a:p>
                   </a:txBody>
@@ -17086,7 +17050,7 @@
                             <a:srgbClr val="262626"/>
                           </a:solidFill>
                         </a:rPr>
-                        <a:t>RAG and SQL in one answer; the clinician decides (§7)</a:t>
+                        <a:t>RAG and SQL in one answer. It hands the decision to the clinician.</a:t>
                       </a:r>
                     </a:p>
                   </a:txBody>
@@ -17134,7 +17098,7 @@
                           </a:solidFill>
                           <a:latin typeface="+mj-lt"/>
                         </a:rPr>
-                        <a:t>What is patient EHS-100092's risk of deterioration in the next 12 months?</a:t>
+                        <a:t>How likely is patient EHS-100092 to deteriorate this year?</a:t>
                       </a:r>
                     </a:p>
                   </a:txBody>
@@ -17156,7 +17120,7 @@
                             <a:srgbClr val="262626"/>
                           </a:solidFill>
                         </a:rPr>
-                        <a:t>Scores the patient through the published model and contrasts it with the registry's rule-based tier</a:t>
+                        <a:t>Calls the published model for that patient and compares with the registry tier.</a:t>
                       </a:r>
                     </a:p>
                   </a:txBody>
@@ -17178,7 +17142,7 @@
                             <a:srgbClr val="262626"/>
                           </a:solidFill>
                         </a:rPr>
-                        <a:t>The model call in the trace; restricted-consent patients are never listed</a:t>
+                        <a:t>The model call in the trace. Restricted-consent patients never appear by name.</a:t>
                       </a:r>
                     </a:p>
                   </a:txBody>
@@ -17222,7 +17186,7 @@
                   <a:srgbClr val="7E889A"/>
                 </a:solidFill>
               </a:rPr>
-              <a:t>If time allows, question 6: “If we put every eligible uncontrolled patient on a GLP-1 RA and closed the statin gap, what would it save?” A policy what-if: the agent takes the measured effects from NHA-PP-01 §5, scales them to the cohorts it counted, and shows the arithmetic.</a:t>
+              <a:t>If there is time, a sixth: “If we put every eligible patient on a GLP-1 RA and closed the statin gap, what would it save?” The agent takes the measured effects from NHA-PP-01 §5, scales them to the cohorts it counted, and shows the arithmetic.</a:t>
             </a:r>
           </a:p>
         </p:txBody>
@@ -17480,7 +17444,7 @@
           <a:p>
             <a:r>
               <a:rPr sz="5600"/>
-              <a:t>Under the hood of one answer</a:t>
+              <a:t>One answer, step by step</a:t>
             </a:r>
           </a:p>
         </p:txBody>
@@ -17502,7 +17466,7 @@
           <a:p>
             <a:r>
               <a:rPr sz="3000"/>
-              <a:t>Question 4 step by step, from retrieval to the hand-over</a:t>
+              <a:t>Question 4, exactly as the agent did it</a:t>
             </a:r>
           </a:p>
         </p:txBody>
@@ -17695,7 +17659,7 @@
                   <a:srgbClr val="262626"/>
                 </a:solidFill>
               </a:rPr>
-              <a:t>Searches the NHA collection. NHA-CG-01 §4: consider a GLP-1 RA when HbA1c stays above target and BMI is over 30.</a:t>
+              <a:t>Opens the collection. NHA-CG-01 §4: consider a GLP-1 RA when HbA1c stays high and BMI is over 30.</a:t>
             </a:r>
           </a:p>
         </p:txBody>
@@ -17880,7 +17844,7 @@
                   <a:srgbClr val="262626"/>
                 </a:solidFill>
               </a:rPr>
-              <a:t>query_data: type 2, HbA1c ≥ 9%, BMI &gt; 30, from Public.EHS_DIABETES. Result: 399 patients.</a:t>
+              <a:t>Asks the registry: type 2, HbA1c 9% or more, BMI over 30. Answer: 399 patients.</a:t>
             </a:r>
           </a:p>
         </p:txBody>
@@ -18065,7 +18029,7 @@
                   <a:srgbClr val="262626"/>
                 </a:solidFill>
               </a:rPr>
-              <a:t>Same cohort, on_sglt2_glp1 = 0. Result: 373 not yet treated. Restricted-consent patients are counted, never listed.</a:t>
+              <a:t>Same group, not on an SGLT2i or GLP-1 RA. Answer: 373. Restricted-consent patients are counted, never listed.</a:t>
             </a:r>
           </a:p>
         </p:txBody>
@@ -18206,7 +18170,7 @@
                   <a:srgbClr val="262626"/>
                 </a:solidFill>
               </a:rPr>
-              <a:t>score_table_rows on the published model for the ten highest-cost eligible patients: a probability and its drivers for each.</a:t>
+              <a:t>Runs the risk model on the ten highest-cost of them. A probability, and the drivers behind it, for each.</a:t>
             </a:r>
           </a:p>
         </p:txBody>
@@ -18391,7 +18355,7 @@
                   <a:srgbClr val="262626"/>
                 </a:solidFill>
               </a:rPr>
-              <a:t>The answer: the cohort in words, the two numbers with their denominator, the citation, and the source line (query + sections).</a:t>
+              <a:t>Puts it together: the group in words, both numbers with their base, the section, and a last line saying what it ran.</a:t>
             </a:r>
           </a:p>
         </p:txBody>
@@ -18576,7 +18540,7 @@
                   <a:srgbClr val="262626"/>
                 </a:solidFill>
               </a:rPr>
-              <a:t>A draft review list for the clinic. The guideline (§7) and the agent's own rules say: a clinician decides; the agent never prescribes.</a:t>
+              <a:t>A list for the clinic to review. Section 7 and the agent's own rules: a clinician decides, the agent never prescribes.</a:t>
             </a:r>
           </a:p>
         </p:txBody>
@@ -18833,8 +18797,8 @@
           <a:lstStyle/>
           <a:p>
             <a:r>
-              <a:rPr sz="5000"/>
-              <a:t>The guardrails you saw in the demo</a:t>
+              <a:rPr sz="5600"/>
+              <a:t>The rules it was playing by</a:t>
             </a:r>
           </a:p>
         </p:txBody>
@@ -18856,7 +18820,7 @@
           <a:p>
             <a:r>
               <a:rPr sz="3000"/>
-              <a:t>Written into the agent's instructions and enforced by the tools</a:t>
+              <a:t>Written into its instructions and enforced by the tools. Not left to its judgement.</a:t>
             </a:r>
           </a:p>
         </p:txBody>
@@ -19011,7 +18975,7 @@
                 </a:solidFill>
                 <a:latin typeface="+mj-lt"/>
               </a:rPr>
-              <a:t>Numbers come from queries</a:t>
+              <a:t>No number without a query</a:t>
             </a:r>
           </a:p>
         </p:txBody>
@@ -19045,7 +19009,7 @@
                   <a:srgbClr val="262626"/>
                 </a:solidFill>
               </a:rPr>
-              <a:t>The agent runs query_data before stating any count, rate or cost. No estimates, no reuse of an old number for a new cohort.</a:t>
+              <a:t>It runs the query first, every time. No estimates, no recycling last week's figure for a new cohort.</a:t>
             </a:r>
           </a:p>
         </p:txBody>
@@ -19080,7 +19044,7 @@
                 </a:solidFill>
                 <a:latin typeface="+mj-lt"/>
               </a:rPr>
-              <a:t>Lives in: the agent instructions, rule 1</a:t>
+              <a:t>In the instructions, rule 1</a:t>
             </a:r>
           </a:p>
         </p:txBody>
@@ -19235,7 +19199,7 @@
                 </a:solidFill>
                 <a:latin typeface="+mj-lt"/>
               </a:rPr>
-              <a:t>Clinical statements are cited</a:t>
+              <a:t>No clinical claim without a section</a:t>
             </a:r>
           </a:p>
         </p:txBody>
@@ -19269,7 +19233,7 @@
                   <a:srgbClr val="262626"/>
                 </a:solidFill>
               </a:rPr>
-              <a:t>Document and section, or “not covered by the NHA guidelines in my collection”. Never from general knowledge.</a:t>
+              <a:t>Document and section, or “the guidelines in my collection do not cover this”.</a:t>
             </a:r>
           </a:p>
         </p:txBody>
@@ -19304,7 +19268,7 @@
                 </a:solidFill>
                 <a:latin typeface="+mj-lt"/>
               </a:rPr>
-              <a:t>Lives in: the agent instructions, rule 3</a:t>
+              <a:t>In the instructions, rule 3</a:t>
             </a:r>
           </a:p>
         </p:txBody>
@@ -19459,7 +19423,7 @@
                 </a:solidFill>
                 <a:latin typeface="+mj-lt"/>
               </a:rPr>
-              <a:t>Consent is respected</a:t>
+              <a:t>Consent comes first</a:t>
             </a:r>
           </a:p>
         </p:txBody>
@@ -19493,7 +19457,7 @@
                   <a:srgbClr val="262626"/>
                 </a:solidFill>
               </a:rPr>
-              <a:t>Restricted-consent patients appear in aggregates only: never named, listed or scored (NHA-PP-01 §6).</a:t>
+              <a:t>Patients with restricted consent are counted, never named, listed or scored. NHA-PP-01 §6.</a:t>
             </a:r>
           </a:p>
         </p:txBody>
@@ -19528,7 +19492,7 @@
                 </a:solidFill>
                 <a:latin typeface="+mj-lt"/>
               </a:rPr>
-              <a:t>Lives in: the instructions, and the query the tool runs</a:t>
+              <a:t>In the instructions, and in the query itself</a:t>
             </a:r>
           </a:p>
         </p:txBody>
@@ -19683,7 +19647,7 @@
                 </a:solidFill>
                 <a:latin typeface="+mj-lt"/>
               </a:rPr>
-              <a:t>Humans decide</a:t>
+              <a:t>People decide</a:t>
             </a:r>
           </a:p>
         </p:txBody>
@@ -19717,7 +19681,7 @@
                   <a:srgbClr val="262626"/>
                 </a:solidFill>
               </a:rPr>
-              <a:t>The agent drafts recall lists and recommendations; a clinician or the programme lead approves them (NHA-CG-01 §7).</a:t>
+              <a:t>It drafts recall lists and suggestions. A clinician or the programme lead approves. NHA-CG-01 §7.</a:t>
             </a:r>
           </a:p>
         </p:txBody>
@@ -19752,7 +19716,7 @@
                 </a:solidFill>
                 <a:latin typeface="+mj-lt"/>
               </a:rPr>
-              <a:t>Lives in: the agent instructions, rule 5</a:t>
+              <a:t>In the instructions, rule 5</a:t>
             </a:r>
           </a:p>
         </p:txBody>
@@ -19907,7 +19871,7 @@
                 </a:solidFill>
                 <a:latin typeface="+mj-lt"/>
               </a:rPr>
-              <a:t>Tools are scoped</a:t>
+              <a:t>It sees only its own tables</a:t>
             </a:r>
           </a:p>
         </p:txBody>
@@ -19941,7 +19905,7 @@
                   <a:srgbClr val="262626"/>
                 </a:solidFill>
               </a:rPr>
-              <a:t>The MCP server sees only the team's registry table and model. Anything else answers “out of scope”, by design.</a:t>
+              <a:t>The MCP server is scoped to the team's registry and model. Ask for anything else and it says “out of scope”.</a:t>
             </a:r>
           </a:p>
         </p:txBody>
@@ -19976,7 +19940,7 @@
                 </a:solidFill>
                 <a:latin typeface="+mj-lt"/>
               </a:rPr>
-              <a:t>Lives in: the MCP server (allowed tables and models)</a:t>
+              <a:t>In the MCP server configuration</a:t>
             </a:r>
           </a:p>
         </p:txBody>
@@ -20131,7 +20095,7 @@
                 </a:solidFill>
                 <a:latin typeface="+mj-lt"/>
               </a:rPr>
-              <a:t>The trace is visible</a:t>
+              <a:t>Everything is on the record</a:t>
             </a:r>
           </a:p>
         </p:txBody>
@@ -20165,7 +20129,7 @@
                   <a:srgbClr val="262626"/>
                 </a:solidFill>
               </a:rPr>
-              <a:t>Every retrieval, query and model call is shown next to the answer. That is the audit trail, built in, not bolted on.</a:t>
+              <a:t>Every retrieval, query and model call sits next to the answer. That is your audit trail.</a:t>
             </a:r>
           </a:p>
         </p:txBody>
@@ -20200,7 +20164,7 @@
                 </a:solidFill>
                 <a:latin typeface="+mj-lt"/>
               </a:rPr>
-              <a:t>Lives in: SAS Retrieval Agent Manager, on every answer</a:t>
+              <a:t>In SAS RAM, on every answer</a:t>
             </a:r>
           </a:p>
         </p:txBody>
@@ -20240,7 +20204,7 @@
           <a:p>
             <a:r>
               <a:rPr sz="6000"/>
-              <a:t>What you will build</a:t>
+              <a:t>Now you build one</a:t>
             </a:r>
           </a:p>
         </p:txBody>
@@ -20262,7 +20226,7 @@
           <a:p>
             <a:r>
               <a:rPr sz="3600"/>
-              <a:t>The same agent, assembled by you, without code</a:t>
+              <a:t>The same agent, step by step, no code</a:t>
             </a:r>
           </a:p>
         </p:txBody>
@@ -20610,7 +20574,7 @@
           <a:p>
             <a:r>
               <a:rPr sz="3000"/>
-              <a:t>Four parts: the concepts, the building blocks, a live agent, and what you will build</a:t>
+              <a:t>A few concepts, one live agent, and what you will build yourselves</a:t>
             </a:r>
           </a:p>
         </p:txBody>
@@ -20736,7 +20700,7 @@
                 </a:solidFill>
                 <a:latin typeface="+mj-lt"/>
               </a:rPr>
-              <a:t>What Agentic AI is, and is not</a:t>
+              <a:t>What is an agent, really?</a:t>
             </a:r>
           </a:p>
         </p:txBody>
@@ -20770,7 +20734,7 @@
                   <a:srgbClr val="7E889A"/>
                 </a:solidFill>
               </a:rPr>
-              <a:t>From predicting and generating to acting: the agent loop, and where agents fit in healthcare</a:t>
+              <a:t>How it differs from a chatbot, and why that matters in a hospital</a:t>
             </a:r>
           </a:p>
         </p:txBody>
@@ -20860,7 +20824,7 @@
                 </a:solidFill>
                 <a:latin typeface="+mj-lt"/>
               </a:rPr>
-              <a:t>The building blocks: LLM, RAG, MCP, composite AI</a:t>
+              <a:t>The parts you need: LLM, RAG, MCP, and your own models</a:t>
             </a:r>
           </a:p>
         </p:txBody>
@@ -20894,7 +20858,7 @@
                   <a:srgbClr val="7E889A"/>
                 </a:solidFill>
               </a:rPr>
-              <a:t>What each one does for the agent, in plain words, and why the agent needs all of them</a:t>
+              <a:t>What each one does, without the jargon</a:t>
             </a:r>
           </a:p>
         </p:txBody>
@@ -21018,7 +20982,7 @@
                   <a:srgbClr val="7E889A"/>
                 </a:solidFill>
               </a:rPr>
-              <a:t>One registry, four national guidelines, one risk model, and the trace behind every answer</a:t>
+              <a:t>Real questions on a diabetes registry, with the trace behind each answer</a:t>
             </a:r>
           </a:p>
         </p:txBody>
@@ -21108,7 +21072,7 @@
                 </a:solidFill>
                 <a:latin typeface="+mj-lt"/>
               </a:rPr>
-              <a:t>What you will build in this bootcamp</a:t>
+              <a:t>What you will build in the hands-on</a:t>
             </a:r>
           </a:p>
         </p:txBody>
@@ -21142,7 +21106,7 @@
                   <a:srgbClr val="7E889A"/>
                 </a:solidFill>
               </a:rPr>
-              <a:t>The same agent, assembled by you in SAS Viya and SAS Retrieval Agent Manager, without code</a:t>
+              <a:t>The same agent, in SAS Viya and SAS RAM, without writing code</a:t>
             </a:r>
           </a:p>
         </p:txBody>
@@ -21332,7 +21296,7 @@
                 </a:solidFill>
                 <a:latin typeface="+mj-lt"/>
               </a:rPr>
-              <a:t>Explain Agentic AI in one sentence</a:t>
+              <a:t>Explain what an agent is in one sentence</a:t>
             </a:r>
           </a:p>
         </p:txBody>
@@ -21366,7 +21330,7 @@
                   <a:srgbClr val="262626"/>
                 </a:solidFill>
               </a:rPr>
-              <a:t>and tell an agent apart from a chatbot and from a script</a:t>
+              <a:t>and say why it is not just a smarter chatbot</a:t>
             </a:r>
           </a:p>
         </p:txBody>
@@ -21469,7 +21433,7 @@
                 </a:solidFill>
                 <a:latin typeface="+mj-lt"/>
               </a:rPr>
-              <a:t>Say what RAG, MCP and composite AI do</a:t>
+              <a:t>Describe RAG, MCP and composite AI</a:t>
             </a:r>
           </a:p>
         </p:txBody>
@@ -21503,7 +21467,7 @@
                   <a:srgbClr val="262626"/>
                 </a:solidFill>
               </a:rPr>
-              <a:t>for an agent, in plain words, and why it needs all three</a:t>
+              <a:t>in words your colleagues will understand</a:t>
             </a:r>
           </a:p>
         </p:txBody>
@@ -21606,7 +21570,7 @@
                 </a:solidFill>
                 <a:latin typeface="+mj-lt"/>
               </a:rPr>
-              <a:t>Read the Population Health Agent</a:t>
+              <a:t>Follow the Population Health Agent</a:t>
             </a:r>
           </a:p>
         </p:txBody>
@@ -21640,7 +21604,7 @@
                   <a:srgbClr val="262626"/>
                 </a:solidFill>
               </a:rPr>
-              <a:t>its data, documents, model, tools and guardrails, before you build your own</a:t>
+              <a:t>and recognise its parts when you build your own</a:t>
             </a:r>
           </a:p>
         </p:txBody>
@@ -21897,8 +21861,8 @@
           <a:lstStyle/>
           <a:p>
             <a:r>
-              <a:rPr sz="5000"/>
-              <a:t>Your build path: five steps, no code</a:t>
+              <a:rPr sz="5600"/>
+              <a:t>Five steps to your own agent</a:t>
             </a:r>
           </a:p>
         </p:txBody>
@@ -22168,7 +22132,7 @@
                   <a:srgbClr val="262626"/>
                 </a:solidFill>
               </a:rPr>
-              <a:t>Import the registry CSV into SAS Viya (Manage Data). It becomes a CAS table that the tools can query.</a:t>
+              <a:t>Import the registry CSV through Manage Data. It lands in CAS, where the tools can query it.</a:t>
             </a:r>
           </a:p>
         </p:txBody>
@@ -22223,7 +22187,7 @@
                 </a:solidFill>
                 <a:latin typeface="+mj-lt"/>
               </a:rPr>
-              <a:t>SAS Viya  ·  structured data</a:t>
+              <a:t>SAS Viya  ·  data</a:t>
             </a:r>
           </a:p>
         </p:txBody>
@@ -22481,7 +22445,7 @@
                 </a:solidFill>
                 <a:latin typeface="+mj-lt"/>
               </a:rPr>
-              <a:t>Build and publish the model</a:t>
+              <a:t>Build the model</a:t>
             </a:r>
           </a:p>
         </p:txBody>
@@ -22515,7 +22479,7 @@
                   <a:srgbClr val="262626"/>
                 </a:solidFill>
               </a:rPr>
-              <a:t>Model Studio trains the pipeline; the champion predicts deterioration in 12 months; publish it for scoring.</a:t>
+              <a:t>Model Studio trains the pipeline and picks a champion. Publish it so the agent can score with it.</a:t>
             </a:r>
           </a:p>
         </p:txBody>
@@ -22570,7 +22534,7 @@
                 </a:solidFill>
                 <a:latin typeface="+mj-lt"/>
               </a:rPr>
-              <a:t>SAS Viya  ·  machine learning</a:t>
+              <a:t>SAS Viya  ·  model</a:t>
             </a:r>
           </a:p>
         </p:txBody>
@@ -22862,7 +22826,7 @@
                   <a:srgbClr val="262626"/>
                 </a:solidFill>
               </a:rPr>
-              <a:t>Create a RAM collection from the four NHA PDFs: chunk, embed, store. Write the retrieval instructions.</a:t>
+              <a:t>Create a collection in RAM from the four PDFs. Chunk, embed, store. Write the retrieval instructions.</a:t>
             </a:r>
           </a:p>
         </p:txBody>
@@ -23209,7 +23173,7 @@
                   <a:srgbClr val="262626"/>
                 </a:solidFill>
               </a:rPr>
-              <a:t>Register the MCP tool server, scoped to your table and your model: list, describe, query, score.</a:t>
+              <a:t>Add the MCP tool server, scoped to your table and your model.</a:t>
             </a:r>
           </a:p>
         </p:txBody>
@@ -23522,7 +23486,7 @@
                 </a:solidFill>
                 <a:latin typeface="+mj-lt"/>
               </a:rPr>
-              <a:t>Assemble and test the agent</a:t>
+              <a:t>Assemble and test</a:t>
             </a:r>
           </a:p>
         </p:txBody>
@@ -23556,7 +23520,7 @@
                   <a:srgbClr val="262626"/>
                 </a:solidFill>
               </a:rPr>
-              <a:t>Instructions + collection + tools. Run the test questions and read the trace behind each answer.</a:t>
+              <a:t>Instructions, collection, tools. Then ask it the test questions and read the trace.</a:t>
             </a:r>
           </a:p>
         </p:txBody>
@@ -23715,7 +23679,7 @@
                   <a:srgbClr val="032954"/>
                 </a:solidFill>
               </a:rPr>
-              <a:t>A ready-made copilot agent in RAM can drive steps 1 and 2 for you through MCP: talk to your data, build the model. Steps 3 to 5 are yours, in the RAM interface.</a:t>
+              <a:t>Steps 1 and 2 can be done by talking to the copilot agent in RAM, which drives SAS Viya through MCP. Worth watching in itself. Steps 3 to 5 are yours.</a:t>
             </a:r>
           </a:p>
         </p:txBody>
@@ -23995,7 +23959,7 @@
           <a:p>
             <a:r>
               <a:rPr sz="3000"/>
-              <a:t>What each part gives the agent, where you build it, and the material to use</a:t>
+              <a:t>Each part, what it does, where it lives, and what is in the kit</a:t>
             </a:r>
           </a:p>
         </p:txBody>
@@ -24038,7 +24002,7 @@
                           </a:solidFill>
                           <a:latin typeface="+mj-lt"/>
                         </a:rPr>
-                        <a:t>Component</a:t>
+                        <a:t>Part</a:t>
                       </a:r>
                     </a:p>
                   </a:txBody>
@@ -24061,7 +24025,7 @@
                           </a:solidFill>
                           <a:latin typeface="+mj-lt"/>
                         </a:rPr>
-                        <a:t>What it gives the agent</a:t>
+                        <a:t>What it does for the agent</a:t>
                       </a:r>
                     </a:p>
                   </a:txBody>
@@ -24084,7 +24048,7 @@
                           </a:solidFill>
                           <a:latin typeface="+mj-lt"/>
                         </a:rPr>
-                        <a:t>Where you build it</a:t>
+                        <a:t>Where it lives</a:t>
                       </a:r>
                     </a:p>
                   </a:txBody>
@@ -24107,7 +24071,7 @@
                           </a:solidFill>
                           <a:latin typeface="+mj-lt"/>
                         </a:rPr>
-                        <a:t>Material in the kit</a:t>
+                        <a:t>What is in the kit</a:t>
                       </a:r>
                     </a:p>
                   </a:txBody>
@@ -24132,7 +24096,7 @@
                           </a:solidFill>
                           <a:latin typeface="+mj-lt"/>
                         </a:rPr>
-                        <a:t>Structured data</a:t>
+                        <a:t>The registry</a:t>
                       </a:r>
                     </a:p>
                   </a:txBody>
@@ -24154,7 +24118,7 @@
                             <a:srgbClr val="262626"/>
                           </a:solidFill>
                         </a:rPr>
-                        <a:t>Every number: cohorts, rates, costs, the patient a clinician asks about</a:t>
+                        <a:t>All the numbers: cohorts, rates, costs, and one patient when a clinician asks</a:t>
                       </a:r>
                     </a:p>
                   </a:txBody>
@@ -24176,7 +24140,7 @@
                             <a:srgbClr val="0766D1"/>
                           </a:solidFill>
                         </a:rPr>
-                        <a:t>SAS Viya  ·  CAS table (Public.EHS_DIABETES)</a:t>
+                        <a:t>SAS Viya, CAS table Public.EHS_DIABETES</a:t>
                       </a:r>
                     </a:p>
                   </a:txBody>
@@ -24223,7 +24187,7 @@
                           </a:solidFill>
                           <a:latin typeface="+mj-lt"/>
                         </a:rPr>
-                        <a:t>ML model</a:t>
+                        <a:t>The risk model</a:t>
                       </a:r>
                     </a:p>
                   </a:txBody>
@@ -24245,7 +24209,7 @@
                             <a:srgbClr val="262626"/>
                           </a:solidFill>
                         </a:rPr>
-                        <a:t>The 12-month deterioration risk of a patient or a cohort, with its drivers</a:t>
+                        <a:t>How likely each patient is to deteriorate in the next 12 months, and why</a:t>
                       </a:r>
                     </a:p>
                   </a:txBody>
@@ -24267,7 +24231,7 @@
                             <a:srgbClr val="0766D1"/>
                           </a:solidFill>
                         </a:rPr>
-                        <a:t>SAS Viya  ·  Model Studio, champion published to SAS Micro Analytic Service</a:t>
+                        <a:t>SAS Viya, Model Studio; champion published to SAS Micro Analytic Service</a:t>
                       </a:r>
                     </a:p>
                   </a:txBody>
@@ -24289,7 +24253,7 @@
                             <a:srgbClr val="262626"/>
                           </a:solidFill>
                         </a:rPr>
-                        <a:t>Target deterioration_next_12m; leakage columns listed in the data dictionary</a:t>
+                        <a:t>Target column deterioration_next_12m; the columns to leave out are listed in the data dictionary</a:t>
                       </a:r>
                     </a:p>
                   </a:txBody>
@@ -24314,7 +24278,7 @@
                           </a:solidFill>
                           <a:latin typeface="+mj-lt"/>
                         </a:rPr>
-                        <a:t>Knowledge (RAG)</a:t>
+                        <a:t>The guidelines (RAG)</a:t>
                       </a:r>
                     </a:p>
                   </a:txBody>
@@ -24336,7 +24300,7 @@
                             <a:srgbClr val="262626"/>
                           </a:solidFill>
                         </a:rPr>
-                        <a:t>Guideline answers with document and section, or “not covered”</a:t>
+                        <a:t>Answers with document and section, or “not covered”</a:t>
                       </a:r>
                     </a:p>
                   </a:txBody>
@@ -24358,7 +24322,7 @@
                             <a:srgbClr val="0766D1"/>
                           </a:solidFill>
                         </a:rPr>
-                        <a:t>SAS RAM  ·  collection + retrieval settings</a:t>
+                        <a:t>SAS RAM, a collection plus retrieval settings</a:t>
                       </a:r>
                     </a:p>
                   </a:txBody>
@@ -24380,7 +24344,7 @@
                             <a:srgbClr val="262626"/>
                           </a:solidFill>
                         </a:rPr>
-                        <a:t>NHA-CG-01, NHA-CG-02, NHA-CG-03, NHA-PP-01 as PDFs</a:t>
+                        <a:t>NHA-CG-01, CG-02, CG-03 and PP-01 as PDFs</a:t>
                       </a:r>
                     </a:p>
                   </a:txBody>
@@ -24405,7 +24369,7 @@
                           </a:solidFill>
                           <a:latin typeface="+mj-lt"/>
                         </a:rPr>
-                        <a:t>Tools (MCP)</a:t>
+                        <a:t>The tools (MCP)</a:t>
                       </a:r>
                     </a:p>
                   </a:txBody>
@@ -24427,7 +24391,7 @@
                             <a:srgbClr val="262626"/>
                           </a:solidFill>
                         </a:rPr>
-                        <a:t>Its hands: list, describe and preview tables, query, list and describe models, score</a:t>
+                        <a:t>List, describe and preview tables; query; list and describe models; score</a:t>
                       </a:r>
                     </a:p>
                   </a:txBody>
@@ -24449,7 +24413,7 @@
                             <a:srgbClr val="0766D1"/>
                           </a:solidFill>
                         </a:rPr>
-                        <a:t>SAS RAM  ·  MCP tool source, scoped to your table and model</a:t>
+                        <a:t>SAS RAM, an MCP tool source scoped to your table and model</a:t>
                       </a:r>
                     </a:p>
                   </a:txBody>
@@ -24518,7 +24482,7 @@
                             <a:srgbClr val="262626"/>
                           </a:solidFill>
                         </a:rPr>
-                        <a:t>The orchestrator: reads the question, picks the tool, writes the cited answer</a:t>
+                        <a:t>Reads the question, picks the tool, writes the cited answer</a:t>
                       </a:r>
                     </a:p>
                   </a:txBody>
@@ -24540,7 +24504,7 @@
                             <a:srgbClr val="0766D1"/>
                           </a:solidFill>
                         </a:rPr>
-                        <a:t>SAS RAM  ·  agent = instructions + collection + tools</a:t>
+                        <a:t>SAS RAM: instructions + collection + tools</a:t>
                       </a:r>
                     </a:p>
                   </a:txBody>
@@ -24562,7 +24526,7 @@
                             <a:srgbClr val="262626"/>
                           </a:solidFill>
                         </a:rPr>
-                        <a:t>The system prompt template and 20 test questions with expected answers</a:t>
+                        <a:t>The prompt template and 20 test questions with their expected answers</a:t>
                       </a:r>
                     </a:p>
                   </a:txBody>
@@ -24783,7 +24747,7 @@
                 </a:solidFill>
                 <a:latin typeface="+mj-lt"/>
               </a:rPr>
-              <a:t>An agent is a loop with a goal, tools and boundaries</a:t>
+              <a:t>An agent chases a goal, not a question</a:t>
             </a:r>
           </a:p>
         </p:txBody>
@@ -24817,7 +24781,7 @@
                   <a:srgbClr val="C4DEFD"/>
                 </a:solidFill>
               </a:rPr>
-              <a:t>It reasons, acts, checks, and keeps going until the job is done or a person must step in.</a:t>
+              <a:t>It uses tools, checks its own work, and stops when the job is done or a person needs to step in.</a:t>
             </a:r>
           </a:p>
         </p:txBody>
@@ -24887,7 +24851,7 @@
                 </a:solidFill>
                 <a:latin typeface="+mj-lt"/>
               </a:rPr>
-              <a:t>The LLM reasons; RAG, tools and models keep it honest</a:t>
+              <a:t>The LLM thinks. Everything else keeps it honest.</a:t>
             </a:r>
           </a:p>
         </p:txBody>
@@ -24921,7 +24885,7 @@
                   <a:srgbClr val="C4DEFD"/>
                 </a:solidFill>
               </a:rPr>
-              <a:t>Words from the LLM, facts from your documents, numbers from queries and models, all connected through MCP and logged.</a:t>
+              <a:t>Your documents for the quotes, your queries and models for the numbers, MCP to connect them, a trace to prove it.</a:t>
             </a:r>
           </a:p>
         </p:txBody>
@@ -24991,7 +24955,7 @@
                 </a:solidFill>
                 <a:latin typeface="+mj-lt"/>
               </a:rPr>
-              <a:t>You will build this agent in the bootcamp</a:t>
+              <a:t>In the hands-on, you build one</a:t>
             </a:r>
           </a:p>
         </p:txBody>
@@ -25025,7 +24989,7 @@
                   <a:srgbClr val="C4DEFD"/>
                 </a:solidFill>
               </a:rPr>
-              <a:t>Load the data, publish the model, index the guidelines, connect the tools, assemble and test.</a:t>
+              <a:t>Data, model, guidelines, tools, agent. Five steps, no code.</a:t>
             </a:r>
           </a:p>
         </p:txBody>
@@ -25153,7 +25117,7 @@
                   <a:srgbClr val="C4DEFD"/>
                 </a:solidFill>
               </a:rPr>
-              <a:t>Bring the registry CSV, the four NHA guideline PDFs and the test questions.</a:t>
+              <a:t>You will need the registry CSV, the four NHA PDFs and the test questions.</a:t>
             </a:r>
           </a:p>
         </p:txBody>
@@ -25311,7 +25275,7 @@
           <a:p>
             <a:r>
               <a:rPr sz="3600"/>
-              <a:t>From answering questions to getting work done</a:t>
+              <a:t>From answering questions to getting things done</a:t>
             </a:r>
           </a:p>
         </p:txBody>
@@ -25659,7 +25623,7 @@
           <a:p>
             <a:r>
               <a:rPr sz="3000"/>
-              <a:t>Agentic AI is the third step, and it stands on the other two</a:t>
+              <a:t>Three kinds of AI. The third one puts the other two to work.</a:t>
             </a:r>
           </a:p>
         </p:txBody>
@@ -25899,7 +25863,7 @@
                 </a:solidFill>
                 <a:latin typeface="+mj-lt"/>
               </a:rPr>
-              <a:t>Analytical AI and machine learning</a:t>
+              <a:t>Machine learning</a:t>
             </a:r>
           </a:p>
         </p:txBody>
@@ -25933,7 +25897,7 @@
                   <a:srgbClr val="262626"/>
                 </a:solidFill>
               </a:rPr>
-              <a:t>Learns from data to predict and classify: a deterioration risk score, a demand forecast, a fraud flag, a no-show probability.</a:t>
+              <a:t>Learns patterns from data and gives you a number: a risk score, a forecast, the chance a patient does not turn up. EHS has done this for years.</a:t>
             </a:r>
           </a:p>
           <a:p>
@@ -25949,7 +25913,7 @@
                 </a:solidFill>
                 <a:latin typeface="+mj-lt"/>
               </a:rPr>
-              <a:t>In the demo: the deterioration-risk model behind the agent.</a:t>
+              <a:t>This is the risk model in today's demo.</a:t>
             </a:r>
           </a:p>
         </p:txBody>
@@ -25984,7 +25948,7 @@
                 </a:solidFill>
                 <a:latin typeface="+mj-lt"/>
               </a:rPr>
-              <a:t>Answers: how likely? how many? which ones?</a:t>
+              <a:t>Good at: how likely? how many?</a:t>
             </a:r>
           </a:p>
         </p:txBody>
@@ -26179,7 +26143,7 @@
                   <a:srgbClr val="262626"/>
                 </a:solidFill>
               </a:rPr>
-              <a:t>Learns language to create: it summarises a guideline, drafts a letter, explains a chart, answers one question at a time.</a:t>
+              <a:t>Learns language and produces it: a summary, a draft letter, an answer to the question you typed. One question, one answer, then it stops.</a:t>
             </a:r>
           </a:p>
           <a:p>
@@ -26195,7 +26159,7 @@
                 </a:solidFill>
                 <a:latin typeface="+mj-lt"/>
               </a:rPr>
-              <a:t>In the demo: the language model that writes every answer.</a:t>
+              <a:t>This is what writes the answers in the demo.</a:t>
             </a:r>
           </a:p>
         </p:txBody>
@@ -26230,7 +26194,7 @@
                 </a:solidFill>
                 <a:latin typeface="+mj-lt"/>
               </a:rPr>
-              <a:t>Answers: what does this say? write this for me.</a:t>
+              <a:t>Good at: explain this, write that.</a:t>
             </a:r>
           </a:p>
         </p:txBody>
@@ -26425,7 +26389,7 @@
                   <a:srgbClr val="FFFFFF"/>
                 </a:solidFill>
               </a:rPr>
-              <a:t>Pursues a goal: breaks it into steps, uses tools, models and documents, checks the results, and keeps going until the job is done, inside boundaries set by people.</a:t>
+              <a:t>Gets a goal, not a question. Works out the steps, uses the other two as tools, checks the result, and keeps going until the job is done or it needs a person.</a:t>
             </a:r>
           </a:p>
           <a:p>
@@ -26441,7 +26405,7 @@
                 </a:solidFill>
                 <a:latin typeface="+mj-lt"/>
               </a:rPr>
-              <a:t>In the demo: the Population Health Agent itself.</a:t>
+              <a:t>This is the whole Population Health Agent.</a:t>
             </a:r>
           </a:p>
         </p:txBody>
@@ -26476,7 +26440,7 @@
                 </a:solidFill>
                 <a:latin typeface="+mj-lt"/>
               </a:rPr>
-              <a:t>Answers: get this done, and show me how you did it.</a:t>
+              <a:t>Good at: get this done, and show me how.</a:t>
             </a:r>
           </a:p>
         </p:txBody>
@@ -26580,7 +26544,7 @@
                   <a:srgbClr val="032954"/>
                 </a:solidFill>
               </a:rPr>
-              <a:t>Agentic AI does not replace the first two. It uses them as tools: the model scores, the LLM reasons and writes, the agent decides what to do next.</a:t>
+              <a:t>Nothing here replaces what you already have. The agent is the layer that puts your models and the language model to work.</a:t>
             </a:r>
           </a:p>
         </p:txBody>
@@ -26838,7 +26802,7 @@
           <a:p>
             <a:r>
               <a:rPr sz="5600"/>
-              <a:t>What makes it an agent: the loop</a:t>
+              <a:t>What makes it an agent</a:t>
             </a:r>
           </a:p>
         </p:txBody>
@@ -26860,7 +26824,7 @@
           <a:p>
             <a:r>
               <a:rPr sz="3000"/>
-              <a:t>A chatbot answers once. An agent keeps going until the goal is met</a:t>
+              <a:t>It does not stop after one answer. It looks, thinks, acts, checks, and goes again.</a:t>
             </a:r>
           </a:p>
         </p:txBody>
@@ -27353,7 +27317,7 @@
                 </a:solidFill>
                 <a:latin typeface="+mj-lt"/>
               </a:rPr>
-              <a:t>Repeat until the goal is met,</a:t>
+              <a:t>Round and round until the job is done,</a:t>
             </a:r>
           </a:p>
           <a:p>
@@ -27365,7 +27329,7 @@
                 </a:solidFill>
                 <a:latin typeface="+mj-lt"/>
               </a:rPr>
-              <a:t>or a boundary is hit</a:t>
+              <a:t>or a limit is reached</a:t>
             </a:r>
           </a:p>
         </p:txBody>
@@ -27452,7 +27416,7 @@
                 </a:solidFill>
                 <a:latin typeface="+mj-lt"/>
               </a:rPr>
-              <a:t>Each turn of the loop</a:t>
+              <a:t>One turn around the loop</a:t>
             </a:r>
           </a:p>
         </p:txBody>
@@ -27589,7 +27553,7 @@
                   <a:srgbClr val="262626"/>
                 </a:solidFill>
               </a:rPr>
-              <a:t>Read the situation: the question, the data that came back, the last tool result.</a:t>
+              <a:t>What is in front of it now: your question, the last result, a new row of data.</a:t>
             </a:r>
           </a:p>
         </p:txBody>
@@ -27726,7 +27690,7 @@
                   <a:srgbClr val="262626"/>
                 </a:solidFill>
               </a:rPr>
-              <a:t>The language model weighs goal, rules, knowledge and tools, and proposes the next step.</a:t>
+              <a:t>The LLM decides the next step. Ask the registry? Open the guideline? Score the model?</a:t>
             </a:r>
           </a:p>
         </p:txBody>
@@ -27863,7 +27827,7 @@
                   <a:srgbClr val="262626"/>
                 </a:solidFill>
               </a:rPr>
-              <a:t>The runtime executes it: a query, a model score, a document search, a draft.</a:t>
+              <a:t>The runtime runs that step. The LLM itself never touches a system.</a:t>
             </a:r>
           </a:p>
         </p:txBody>
@@ -28000,7 +27964,7 @@
                   <a:srgbClr val="262626"/>
                 </a:solidFill>
               </a:rPr>
-              <a:t>The result comes back and becomes the next thing to perceive.</a:t>
+              <a:t>The result comes back, and the loop starts again.</a:t>
             </a:r>
           </a:p>
         </p:txBody>
@@ -28104,7 +28068,7 @@
                   <a:srgbClr val="032954"/>
                 </a:solidFill>
               </a:rPr>
-              <a:t>An AI agent is a system that pursues a </a:t>
+              <a:t>In one sentence: an agent chases a </a:t>
             </a:r>
             <a:r>
               <a:rPr sz="1500">
@@ -28121,7 +28085,7 @@
                   <a:srgbClr val="032954"/>
                 </a:solidFill>
               </a:rPr>
-              <a:t> by reasoning about what to do next, using </a:t>
+              <a:t>, uses </a:t>
             </a:r>
             <a:r>
               <a:rPr sz="1500">
@@ -28138,7 +28102,7 @@
                   <a:srgbClr val="032954"/>
                 </a:solidFill>
               </a:rPr>
-              <a:t> to act, and checking the result, inside </a:t>
+              <a:t>, checks its own work, and stays inside the </a:t>
             </a:r>
             <a:r>
               <a:rPr sz="1500">
@@ -28147,7 +28111,7 @@
                 </a:solidFill>
                 <a:latin typeface="+mj-lt"/>
               </a:rPr>
-              <a:t>boundaries</a:t>
+              <a:t>lines we draw</a:t>
             </a:r>
             <a:r>
               <a:rPr sz="1500">
@@ -28155,7 +28119,7 @@
                   <a:srgbClr val="032954"/>
                 </a:solidFill>
               </a:rPr>
-              <a:t> set by people.</a:t>
+              <a:t>.</a:t>
             </a:r>
           </a:p>
         </p:txBody>
@@ -28435,7 +28399,7 @@
           <a:p>
             <a:r>
               <a:rPr sz="3000"/>
-              <a:t>Real-world patterns: the agent reads, reasons and drafts; a person decides</a:t>
+              <a:t>Six places this already works. In every one, a person signs off.</a:t>
             </a:r>
           </a:p>
         </p:txBody>
@@ -28679,7 +28643,7 @@
                   <a:srgbClr val="262626"/>
                 </a:solidFill>
               </a:rPr>
-              <a:t>Finds cohorts and care gaps in the registry, scores risk, drafts a recall list with the guideline section that justifies it.</a:t>
+              <a:t>Who is slipping, where the care gaps are, and what the guideline says to do about it. A recall list with the evidence attached.</a:t>
             </a:r>
           </a:p>
         </p:txBody>
@@ -28903,7 +28867,7 @@
                   <a:srgbClr val="262626"/>
                 </a:solidFill>
               </a:rPr>
-              <a:t>Spots who is likely to miss tomorrow's appointment, confirms or reschedules, and refills the freed slot from the waiting list.</a:t>
+              <a:t>Who is likely to miss tomorrow, a message to confirm or move the slot, and the freed slot offered to the waiting list.</a:t>
             </a:r>
           </a:p>
         </p:txBody>
@@ -28938,7 +28902,7 @@
                 </a:solidFill>
                 <a:latin typeface="+mj-lt"/>
               </a:rPr>
-              <a:t>The coordinator handles exceptions.</a:t>
+              <a:t>The coordinator handles the exceptions.</a:t>
             </a:r>
           </a:p>
         </p:txBody>
@@ -29127,7 +29091,7 @@
                   <a:srgbClr val="262626"/>
                 </a:solidFill>
               </a:rPr>
-              <a:t>Reads the discharge note, proposes the codes and a summary, with the supporting sentences highlighted.</a:t>
+              <a:t>Reads the discharge note and proposes the codes, with the sentences that support each one highlighted.</a:t>
             </a:r>
           </a:p>
         </p:txBody>
@@ -29351,7 +29315,7 @@
                   <a:srgbClr val="262626"/>
                 </a:solidFill>
               </a:rPr>
-              <a:t>Reads messages and complaints, routes them to the right department, drafts the reply in the patient's language.</a:t>
+              <a:t>Reads the message, sends it to the right department, drafts the reply in the patient's own language.</a:t>
             </a:r>
           </a:p>
         </p:txBody>
@@ -29575,7 +29539,7 @@
                   <a:srgbClr val="262626"/>
                 </a:solidFill>
               </a:rPr>
-              <a:t>Forecasts demand per facility, flags bed pressure and stock-outs, proposes transfers and orders.</a:t>
+              <a:t>Next month's demand per facility, the wards under pressure, the stock that will run out first.</a:t>
             </a:r>
           </a:p>
         </p:txBody>
@@ -29765,7 +29729,7 @@
                 </a:solidFill>
                 <a:latin typeface="+mj-lt"/>
               </a:rPr>
-              <a:t>Quality and audit reporting</a:t>
+              <a:t>Quality and audit</a:t>
             </a:r>
           </a:p>
         </p:txBody>
@@ -29799,7 +29763,7 @@
                   <a:srgbClr val="262626"/>
                 </a:solidFill>
               </a:rPr>
-              <a:t>Computes the quality measures, explains the drivers, drafts the report against the national standard.</a:t>
+              <a:t>The measures, the drivers behind them, and a first draft of the report against the national standard.</a:t>
             </a:r>
           </a:p>
         </p:txBody>
@@ -29874,7 +29838,7 @@
           <a:p>
             <a:r>
               <a:rPr sz="6000"/>
-              <a:t>The building blocks</a:t>
+              <a:t>The parts you need</a:t>
             </a:r>
           </a:p>
         </p:txBody>
@@ -29896,7 +29860,7 @@
           <a:p>
             <a:r>
               <a:rPr sz="3600"/>
-              <a:t>LLM, RAG, MCP and composite AI, in plain words</a:t>
+              <a:t>LLM, RAG, MCP and your own models, in plain words</a:t>
             </a:r>
           </a:p>
         </p:txBody>
@@ -30221,8 +30185,8 @@
           <a:lstStyle/>
           <a:p>
             <a:r>
-              <a:rPr sz="5000"/>
-              <a:t>Four blocks around one reasoning engine</a:t>
+              <a:rPr sz="5600"/>
+              <a:t>The LLM is only the middle</a:t>
             </a:r>
           </a:p>
         </p:txBody>
@@ -30244,7 +30208,7 @@
           <a:p>
             <a:r>
               <a:rPr sz="3000"/>
-              <a:t>The LLM reasons; everything that makes it useful and safe sits around it</a:t>
+              <a:t>Four things around it turn a clever model into a useful, safe agent</a:t>
             </a:r>
           </a:p>
         </p:txBody>
@@ -30436,7 +30400,7 @@
                 </a:solidFill>
                 <a:latin typeface="+mj-lt"/>
               </a:rPr>
-              <a:t>Knowledge  ·  RAG</a:t>
+              <a:t>Knowledge (RAG)</a:t>
             </a:r>
           </a:p>
         </p:txBody>
@@ -30470,7 +30434,7 @@
                   <a:srgbClr val="262626"/>
                 </a:solidFill>
               </a:rPr>
-              <a:t>Your documents, retrieved on demand and cited: the national guidelines, policies, protocols.</a:t>
+              <a:t>Your own documents, pulled in when needed and quoted with the section number.</a:t>
             </a:r>
           </a:p>
         </p:txBody>
@@ -30662,7 +30626,7 @@
                 </a:solidFill>
                 <a:latin typeface="+mj-lt"/>
               </a:rPr>
-              <a:t>Tools  ·  MCP</a:t>
+              <a:t>Tools (MCP)</a:t>
             </a:r>
           </a:p>
         </p:txBody>
@@ -30696,7 +30660,7 @@
                   <a:srgbClr val="262626"/>
                 </a:solidFill>
               </a:rPr>
-              <a:t>A standard plug into data, models and systems: the agent asks, the server executes, every call is logged.</a:t>
+              <a:t>The plug that lets the agent query data, run a model or draw a chart, without touching anything directly.</a:t>
             </a:r>
           </a:p>
         </p:txBody>
@@ -30888,7 +30852,7 @@
                 </a:solidFill>
                 <a:latin typeface="+mj-lt"/>
               </a:rPr>
-              <a:t>Analytics  ·  composite AI</a:t>
+              <a:t>Your models and rules</a:t>
             </a:r>
           </a:p>
         </p:txBody>
@@ -30922,7 +30886,7 @@
                   <a:srgbClr val="262626"/>
                 </a:solidFill>
               </a:rPr>
-              <a:t>The ML models, SQL queries and decision rules you already trust, called as tools.</a:t>
+              <a:t>The risk model, the SQL, the decision rules you already trust. The agent calls them; it does not replace them.</a:t>
             </a:r>
           </a:p>
         </p:txBody>
@@ -31114,7 +31078,7 @@
                 </a:solidFill>
                 <a:latin typeface="+mj-lt"/>
               </a:rPr>
-              <a:t>People  ·  human oversight</a:t>
+              <a:t>People</a:t>
             </a:r>
           </a:p>
         </p:txBody>
@@ -31148,7 +31112,7 @@
                   <a:srgbClr val="262626"/>
                 </a:solidFill>
               </a:rPr>
-              <a:t>Goal, boundaries, approvals and review. The agent drafts; a person decides.</a:t>
+              <a:t>The goal, the limits, the approvals. The agent drafts, you decide.</a:t>
             </a:r>
           </a:p>
         </p:txBody>
@@ -31313,7 +31277,7 @@
                 </a:solidFill>
                 <a:latin typeface="+mj-lt"/>
               </a:rPr>
-              <a:t>reasons, plans, writes</a:t>
+              <a:t>thinks, plans, writes</a:t>
             </a:r>
           </a:p>
         </p:txBody>
@@ -31347,7 +31311,7 @@
                   <a:srgbClr val="7E889A"/>
                 </a:solidFill>
               </a:rPr>
-              <a:t>One slide for each block follows. The language model never touches data or systems directly; the blocks around it do.</a:t>
+              <a:t>The LLM never touches your data or your systems. The parts around it do. One slide on each, next.</a:t>
             </a:r>
           </a:p>
         </p:txBody>
@@ -31604,8 +31568,8 @@
           <a:lstStyle/>
           <a:p>
             <a:r>
-              <a:rPr sz="4600"/>
-              <a:t>The LLM: a reasoning engine with no access</a:t>
+              <a:rPr sz="5600"/>
+              <a:t>Why the LLM alone is not enough</a:t>
             </a:r>
           </a:p>
         </p:txBody>
@@ -31627,7 +31591,7 @@
           <a:p>
             <a:r>
               <a:rPr sz="3000"/>
-              <a:t>What the language model is good at, and what it cannot know on its own</a:t>
+              <a:t>Brilliant with language. Blind to your data.</a:t>
             </a:r>
           </a:p>
         </p:txBody>
@@ -31782,7 +31746,7 @@
                 </a:solidFill>
                 <a:latin typeface="+mj-lt"/>
               </a:rPr>
-              <a:t>Good at</a:t>
+              <a:t>What it does well</a:t>
             </a:r>
           </a:p>
         </p:txBody>
@@ -31825,7 +31789,7 @@
                   <a:srgbClr val="262626"/>
                 </a:solidFill>
               </a:rPr>
-              <a:t>Understanding the question, in English or Arabic</a:t>
+              <a:t>Understands the question, in English or Arabic</a:t>
             </a:r>
           </a:p>
           <a:p>
@@ -31845,7 +31809,7 @@
                   <a:srgbClr val="262626"/>
                 </a:solidFill>
               </a:rPr>
-              <a:t>Breaking a goal into steps and choosing the right tool for each</a:t>
+              <a:t>Breaks a task into steps and picks the right tool for each</a:t>
             </a:r>
           </a:p>
           <a:p>
@@ -31865,7 +31829,7 @@
                   <a:srgbClr val="262626"/>
                 </a:solidFill>
               </a:rPr>
-              <a:t>Reading a retrieved passage and summarising it faithfully</a:t>
+              <a:t>Reads a passage and summarises it without inventing</a:t>
             </a:r>
           </a:p>
           <a:p>
@@ -31885,7 +31849,7 @@
                   <a:srgbClr val="262626"/>
                 </a:solidFill>
               </a:rPr>
-              <a:t>Writing the answer: clear, structured, the cohort stated in words</a:t>
+              <a:t>Writes a clear answer, cohort and all</a:t>
             </a:r>
           </a:p>
         </p:txBody>
@@ -31920,7 +31884,7 @@
                 </a:solidFill>
                 <a:latin typeface="+mj-lt"/>
               </a:rPr>
-              <a:t>In the demo: it picks the SQL tool for a count and the collection for a target.</a:t>
+              <a:t>In the demo it chooses the SQL tool for counts and the collection for targets.</a:t>
             </a:r>
           </a:p>
         </p:txBody>
@@ -32075,7 +32039,7 @@
                 </a:solidFill>
                 <a:latin typeface="+mj-lt"/>
               </a:rPr>
-              <a:t>Cannot, on its own</a:t>
+              <a:t>What it cannot do on its own</a:t>
             </a:r>
           </a:p>
         </p:txBody>
@@ -32118,7 +32082,7 @@
                   <a:srgbClr val="262626"/>
                 </a:solidFill>
               </a:rPr>
-              <a:t>Know your registry: how many patients are uncontrolled today</a:t>
+              <a:t>Know how many of your patients are uncontrolled today</a:t>
             </a:r>
           </a:p>
           <a:p>
@@ -32138,7 +32102,7 @@
                   <a:srgbClr val="262626"/>
                 </a:solidFill>
               </a:rPr>
-              <a:t>Know the current national guideline, section by section</a:t>
+              <a:t>Know what the national guideline says in section 4</a:t>
             </a:r>
           </a:p>
           <a:p>
@@ -32158,7 +32122,7 @@
                   <a:srgbClr val="262626"/>
                 </a:solidFill>
               </a:rPr>
-              <a:t>Do reliable arithmetic across 4,000 rows</a:t>
+              <a:t>Count reliably across 4,000 rows</a:t>
             </a:r>
           </a:p>
           <a:p>
@@ -32178,7 +32142,7 @@
                   <a:srgbClr val="262626"/>
                 </a:solidFill>
               </a:rPr>
-              <a:t>Run anything: it proposes an action, it never executes one</a:t>
+              <a:t>Run anything. It can only propose.</a:t>
             </a:r>
           </a:p>
         </p:txBody>
@@ -32213,7 +32177,7 @@
                 </a:solidFill>
                 <a:latin typeface="+mj-lt"/>
               </a:rPr>
-              <a:t>In the demo: every number is a query that ran, every target is a citation.</a:t>
+              <a:t>In the demo every number is a query that ran, and every target has a section number.</a:t>
             </a:r>
           </a:p>
         </p:txBody>
@@ -32317,7 +32281,7 @@
                   <a:srgbClr val="032954"/>
                 </a:solidFill>
               </a:rPr>
-              <a:t>That is why we surround it: </a:t>
+              <a:t>So we surround it. </a:t>
             </a:r>
             <a:r>
               <a:rPr sz="1600">
@@ -32334,7 +32298,7 @@
                   <a:srgbClr val="032954"/>
                 </a:solidFill>
               </a:rPr>
-              <a:t> for the words it must quote, </a:t>
+              <a:t> for the quotes, </a:t>
             </a:r>
             <a:r>
               <a:rPr sz="1600">
@@ -32351,7 +32315,7 @@
                   <a:srgbClr val="032954"/>
                 </a:solidFill>
               </a:rPr>
-              <a:t> for the numbers it must not guess, </a:t>
+              <a:t> for the numbers, </a:t>
             </a:r>
             <a:r>
               <a:rPr sz="1600">
@@ -32368,7 +32332,7 @@
                   <a:srgbClr val="032954"/>
                 </a:solidFill>
               </a:rPr>
-              <a:t> for the decisions it must not take.</a:t>
+              <a:t> for the decisions.</a:t>
             </a:r>
           </a:p>
         </p:txBody>

</xml_diff>

<commit_message>
Drop the arrow strip and callout bars from the overview deck
Removes the light-blue arrow strip on the "Predict, generate, act" slide
and the full-width callout bars at the bottom of seven slides. The
affected slides now carry that content inside the cards or as a plain
closing line, with card heights tightened to match.

Co-Authored-By: Claude Fable 5.1 <noreply@anthropic.com>
Claude-Session: https://claude.ai/code/session_01EqHkQCasz2hM7pvmZNN3oL
</commit_message>
<xml_diff>
--- a/Day1/Agentic_AI_Overview_and_Live_Demo/Agentic_AI_Overview_and_Live_Demo.pptx
+++ b/Day1/Agentic_AI_Overview_and_Live_Demo/Agentic_AI_Overview_and_Live_Demo.pptx
@@ -9099,7 +9099,7 @@
         <p:spPr>
           <a:xfrm>
             <a:off x="1252728" y="3017520"/>
-            <a:ext cx="4206240" cy="4846320"/>
+            <a:ext cx="4206240" cy="5577840"/>
           </a:xfrm>
           <a:prstGeom prst="roundRect">
             <a:avLst>
@@ -9259,7 +9259,7 @@
         </p:nvSpPr>
         <p:spPr>
           <a:xfrm>
-            <a:off x="1664208" y="4526279"/>
+            <a:off x="1664208" y="4617720"/>
             <a:ext cx="548640" cy="548640"/>
           </a:xfrm>
           <a:prstGeom prst="ellipse">
@@ -9311,7 +9311,7 @@
         </p:blipFill>
         <p:spPr>
           <a:xfrm>
-            <a:off x="1787652" y="4649723"/>
+            <a:off x="1787652" y="4741164"/>
             <a:ext cx="301752" cy="301752"/>
           </a:xfrm>
           <a:prstGeom prst="rect">
@@ -9327,7 +9327,7 @@
         </p:nvSpPr>
         <p:spPr>
           <a:xfrm>
-            <a:off x="2395728" y="4571999"/>
+            <a:off x="2395728" y="4663440"/>
             <a:ext cx="2834639" cy="457200"/>
           </a:xfrm>
           <a:prstGeom prst="rect">
@@ -9362,7 +9362,7 @@
         </p:nvSpPr>
         <p:spPr>
           <a:xfrm>
-            <a:off x="1664208" y="5330951"/>
+            <a:off x="1664208" y="5577840"/>
             <a:ext cx="548640" cy="548640"/>
           </a:xfrm>
           <a:prstGeom prst="ellipse">
@@ -9414,7 +9414,7 @@
         </p:blipFill>
         <p:spPr>
           <a:xfrm>
-            <a:off x="1787652" y="5454395"/>
+            <a:off x="1787652" y="5701283"/>
             <a:ext cx="301752" cy="301752"/>
           </a:xfrm>
           <a:prstGeom prst="rect">
@@ -9430,7 +9430,7 @@
         </p:nvSpPr>
         <p:spPr>
           <a:xfrm>
-            <a:off x="2395728" y="5376671"/>
+            <a:off x="2395728" y="5623559"/>
             <a:ext cx="2834639" cy="457200"/>
           </a:xfrm>
           <a:prstGeom prst="rect">
@@ -9465,7 +9465,7 @@
         </p:nvSpPr>
         <p:spPr>
           <a:xfrm>
-            <a:off x="1664208" y="6135623"/>
+            <a:off x="1664208" y="6537960"/>
             <a:ext cx="548640" cy="548640"/>
           </a:xfrm>
           <a:prstGeom prst="ellipse">
@@ -9517,7 +9517,7 @@
         </p:blipFill>
         <p:spPr>
           <a:xfrm>
-            <a:off x="1787652" y="6259067"/>
+            <a:off x="1787652" y="6661404"/>
             <a:ext cx="301752" cy="301752"/>
           </a:xfrm>
           <a:prstGeom prst="rect">
@@ -9533,7 +9533,7 @@
         </p:nvSpPr>
         <p:spPr>
           <a:xfrm>
-            <a:off x="2395728" y="6181343"/>
+            <a:off x="2395728" y="6583680"/>
             <a:ext cx="2834639" cy="457200"/>
           </a:xfrm>
           <a:prstGeom prst="rect">
@@ -9568,7 +9568,7 @@
         </p:nvSpPr>
         <p:spPr>
           <a:xfrm>
-            <a:off x="1664208" y="6940296"/>
+            <a:off x="1664208" y="7498079"/>
             <a:ext cx="548640" cy="548640"/>
           </a:xfrm>
           <a:prstGeom prst="ellipse">
@@ -9620,7 +9620,7 @@
         </p:blipFill>
         <p:spPr>
           <a:xfrm>
-            <a:off x="1787652" y="7063740"/>
+            <a:off x="1787652" y="7621524"/>
             <a:ext cx="301752" cy="301752"/>
           </a:xfrm>
           <a:prstGeom prst="rect">
@@ -9636,7 +9636,7 @@
         </p:nvSpPr>
         <p:spPr>
           <a:xfrm>
-            <a:off x="2395728" y="6986016"/>
+            <a:off x="2395728" y="7543800"/>
             <a:ext cx="2834639" cy="457200"/>
           </a:xfrm>
           <a:prstGeom prst="rect">
@@ -9672,7 +9672,7 @@
         <p:spPr>
           <a:xfrm>
             <a:off x="6675120" y="2743200"/>
-            <a:ext cx="2286000" cy="5394960"/>
+            <a:ext cx="2286000" cy="5852160"/>
           </a:xfrm>
           <a:prstGeom prst="roundRect">
             <a:avLst>
@@ -9723,8 +9723,8 @@
         </p:nvSpPr>
         <p:spPr>
           <a:xfrm rot="16200000">
-            <a:off x="5303520" y="4617720"/>
-            <a:ext cx="5029200" cy="1645920"/>
+            <a:off x="5074920" y="4846320"/>
+            <a:ext cx="5486400" cy="1645920"/>
           </a:xfrm>
           <a:prstGeom prst="rect">
             <a:avLst/>
@@ -9769,7 +9769,7 @@
         </p:nvCxnSpPr>
         <p:spPr>
           <a:xfrm>
-            <a:off x="5550407" y="5440680"/>
+            <a:off x="5550407" y="5806440"/>
             <a:ext cx="1033273" cy="0"/>
           </a:xfrm>
           <a:prstGeom prst="line">
@@ -9807,7 +9807,7 @@
         </p:nvSpPr>
         <p:spPr>
           <a:xfrm>
-            <a:off x="5550407" y="4800600"/>
+            <a:off x="5550407" y="5166360"/>
             <a:ext cx="1033272" cy="548640"/>
           </a:xfrm>
           <a:prstGeom prst="rect">
@@ -9843,11 +9843,11 @@
         <p:spPr>
           <a:xfrm>
             <a:off x="9966960" y="2743200"/>
-            <a:ext cx="7059168" cy="1133856"/>
+            <a:ext cx="7059168" cy="1188720"/>
           </a:xfrm>
           <a:prstGeom prst="roundRect">
             <a:avLst>
-              <a:gd name="adj" fmla="val 22580"/>
+              <a:gd name="adj" fmla="val 21538"/>
             </a:avLst>
           </a:prstGeom>
           <a:solidFill>
@@ -9894,7 +9894,7 @@
         </p:nvSpPr>
         <p:spPr>
           <a:xfrm>
-            <a:off x="10277856" y="2980944"/>
+            <a:off x="10277856" y="3008376"/>
             <a:ext cx="658368" cy="658368"/>
           </a:xfrm>
           <a:prstGeom prst="ellipse">
@@ -9946,7 +9946,7 @@
         </p:blipFill>
         <p:spPr>
           <a:xfrm>
-            <a:off x="10425988" y="3129076"/>
+            <a:off x="10425988" y="3156508"/>
             <a:ext cx="362102" cy="362102"/>
           </a:xfrm>
           <a:prstGeom prst="rect">
@@ -9962,7 +9962,7 @@
         </p:nvSpPr>
         <p:spPr>
           <a:xfrm>
-            <a:off x="11109960" y="2852928"/>
+            <a:off x="11109960" y="2880360"/>
             <a:ext cx="5733288" cy="411480"/>
           </a:xfrm>
           <a:prstGeom prst="rect">
@@ -9997,7 +9997,7 @@
         </p:nvSpPr>
         <p:spPr>
           <a:xfrm>
-            <a:off x="11109960" y="3246120"/>
+            <a:off x="11109960" y="3273552"/>
             <a:ext cx="5733288" cy="594360"/>
           </a:xfrm>
           <a:prstGeom prst="rect">
@@ -10031,7 +10031,7 @@
         </p:nvCxnSpPr>
         <p:spPr>
           <a:xfrm>
-            <a:off x="9006840" y="3310128"/>
+            <a:off x="9006840" y="3337560"/>
             <a:ext cx="886968" cy="0"/>
           </a:xfrm>
           <a:prstGeom prst="line">
@@ -10068,12 +10068,12 @@
         </p:nvSpPr>
         <p:spPr>
           <a:xfrm>
-            <a:off x="9966960" y="4160520"/>
-            <a:ext cx="7059168" cy="1133856"/>
+            <a:off x="9966960" y="4297680"/>
+            <a:ext cx="7059168" cy="1188720"/>
           </a:xfrm>
           <a:prstGeom prst="roundRect">
             <a:avLst>
-              <a:gd name="adj" fmla="val 22580"/>
+              <a:gd name="adj" fmla="val 21538"/>
             </a:avLst>
           </a:prstGeom>
           <a:solidFill>
@@ -10120,7 +10120,7 @@
         </p:nvSpPr>
         <p:spPr>
           <a:xfrm>
-            <a:off x="10277856" y="4398264"/>
+            <a:off x="10277856" y="4562856"/>
             <a:ext cx="658368" cy="658368"/>
           </a:xfrm>
           <a:prstGeom prst="ellipse">
@@ -10172,7 +10172,7 @@
         </p:blipFill>
         <p:spPr>
           <a:xfrm>
-            <a:off x="10425988" y="4546396"/>
+            <a:off x="10425988" y="4710988"/>
             <a:ext cx="362102" cy="362102"/>
           </a:xfrm>
           <a:prstGeom prst="rect">
@@ -10188,7 +10188,7 @@
         </p:nvSpPr>
         <p:spPr>
           <a:xfrm>
-            <a:off x="11109960" y="4270248"/>
+            <a:off x="11109960" y="4434840"/>
             <a:ext cx="5733288" cy="411480"/>
           </a:xfrm>
           <a:prstGeom prst="rect">
@@ -10223,7 +10223,7 @@
         </p:nvSpPr>
         <p:spPr>
           <a:xfrm>
-            <a:off x="11109960" y="4663440"/>
+            <a:off x="11109960" y="4828032"/>
             <a:ext cx="5733288" cy="594360"/>
           </a:xfrm>
           <a:prstGeom prst="rect">
@@ -10257,7 +10257,7 @@
         </p:nvCxnSpPr>
         <p:spPr>
           <a:xfrm>
-            <a:off x="9006840" y="4727448"/>
+            <a:off x="9006840" y="4892040"/>
             <a:ext cx="886968" cy="0"/>
           </a:xfrm>
           <a:prstGeom prst="line">
@@ -10294,12 +10294,12 @@
         </p:nvSpPr>
         <p:spPr>
           <a:xfrm>
-            <a:off x="9966960" y="5577840"/>
-            <a:ext cx="7059168" cy="1133856"/>
+            <a:off x="9966960" y="5852160"/>
+            <a:ext cx="7059168" cy="1188720"/>
           </a:xfrm>
           <a:prstGeom prst="roundRect">
             <a:avLst>
-              <a:gd name="adj" fmla="val 22580"/>
+              <a:gd name="adj" fmla="val 21538"/>
             </a:avLst>
           </a:prstGeom>
           <a:solidFill>
@@ -10346,7 +10346,7 @@
         </p:nvSpPr>
         <p:spPr>
           <a:xfrm>
-            <a:off x="10277856" y="5815583"/>
+            <a:off x="10277856" y="6117336"/>
             <a:ext cx="658368" cy="658368"/>
           </a:xfrm>
           <a:prstGeom prst="ellipse">
@@ -10398,7 +10398,7 @@
         </p:blipFill>
         <p:spPr>
           <a:xfrm>
-            <a:off x="10425988" y="5963716"/>
+            <a:off x="10425988" y="6265468"/>
             <a:ext cx="362102" cy="362102"/>
           </a:xfrm>
           <a:prstGeom prst="rect">
@@ -10414,7 +10414,7 @@
         </p:nvSpPr>
         <p:spPr>
           <a:xfrm>
-            <a:off x="11109960" y="5687568"/>
+            <a:off x="11109960" y="5989320"/>
             <a:ext cx="5733288" cy="411480"/>
           </a:xfrm>
           <a:prstGeom prst="rect">
@@ -10449,7 +10449,7 @@
         </p:nvSpPr>
         <p:spPr>
           <a:xfrm>
-            <a:off x="11109960" y="6080759"/>
+            <a:off x="11109960" y="6382512"/>
             <a:ext cx="5733288" cy="594360"/>
           </a:xfrm>
           <a:prstGeom prst="rect">
@@ -10483,7 +10483,7 @@
         </p:nvCxnSpPr>
         <p:spPr>
           <a:xfrm>
-            <a:off x="9006840" y="6144768"/>
+            <a:off x="9006840" y="6446520"/>
             <a:ext cx="886968" cy="0"/>
           </a:xfrm>
           <a:prstGeom prst="line">
@@ -10520,12 +10520,12 @@
         </p:nvSpPr>
         <p:spPr>
           <a:xfrm>
-            <a:off x="9966960" y="6995160"/>
-            <a:ext cx="7059168" cy="1133856"/>
+            <a:off x="9966960" y="7406640"/>
+            <a:ext cx="7059168" cy="1188720"/>
           </a:xfrm>
           <a:prstGeom prst="roundRect">
             <a:avLst>
-              <a:gd name="adj" fmla="val 22580"/>
+              <a:gd name="adj" fmla="val 21538"/>
             </a:avLst>
           </a:prstGeom>
           <a:solidFill>
@@ -10572,7 +10572,7 @@
         </p:nvSpPr>
         <p:spPr>
           <a:xfrm>
-            <a:off x="10277856" y="7232903"/>
+            <a:off x="10277856" y="7671816"/>
             <a:ext cx="658368" cy="658368"/>
           </a:xfrm>
           <a:prstGeom prst="ellipse">
@@ -10624,7 +10624,7 @@
         </p:blipFill>
         <p:spPr>
           <a:xfrm>
-            <a:off x="10425988" y="7381036"/>
+            <a:off x="10425988" y="7819948"/>
             <a:ext cx="362102" cy="362102"/>
           </a:xfrm>
           <a:prstGeom prst="rect">
@@ -10640,7 +10640,7 @@
         </p:nvSpPr>
         <p:spPr>
           <a:xfrm>
-            <a:off x="11109960" y="7104888"/>
+            <a:off x="11109960" y="7543800"/>
             <a:ext cx="5733288" cy="411480"/>
           </a:xfrm>
           <a:prstGeom prst="rect">
@@ -10675,7 +10675,7 @@
         </p:nvSpPr>
         <p:spPr>
           <a:xfrm>
-            <a:off x="11109960" y="7498080"/>
+            <a:off x="11109960" y="7936992"/>
             <a:ext cx="5733288" cy="594360"/>
           </a:xfrm>
           <a:prstGeom prst="rect">
@@ -10709,7 +10709,7 @@
         </p:nvCxnSpPr>
         <p:spPr>
           <a:xfrm>
-            <a:off x="9006840" y="7562088"/>
+            <a:off x="9006840" y="8001000"/>
             <a:ext cx="886968" cy="0"/>
           </a:xfrm>
           <a:prstGeom prst="line">
@@ -10775,104 +10775,34 @@
       </p:sp>
       <p:sp>
         <p:nvSpPr>
-          <p:cNvPr id="50" name="Rounded Rectangle 49"/>
-          <p:cNvSpPr/>
-          <p:nvPr/>
-        </p:nvSpPr>
-        <p:spPr>
-          <a:xfrm>
-            <a:off x="1252728" y="8412480"/>
-            <a:ext cx="15773400" cy="914400"/>
-          </a:xfrm>
-          <a:prstGeom prst="roundRect">
-            <a:avLst>
-              <a:gd name="adj" fmla="val 22000"/>
-            </a:avLst>
-          </a:prstGeom>
-          <a:solidFill>
-            <a:srgbClr val="C4DEFD"/>
-          </a:solidFill>
-          <a:ln>
-            <a:noFill/>
-          </a:ln>
-          <a:effectLst/>
-        </p:spPr>
-        <p:style>
-          <a:lnRef idx="1">
-            <a:schemeClr val="accent1"/>
-          </a:lnRef>
-          <a:fillRef idx="3">
-            <a:schemeClr val="accent1"/>
-          </a:fillRef>
-          <a:effectRef idx="2">
-            <a:schemeClr val="accent1"/>
-          </a:effectRef>
-          <a:fontRef idx="minor">
-            <a:schemeClr val="lt1"/>
-          </a:fontRef>
-        </p:style>
-        <p:txBody>
-          <a:bodyPr rtlCol="0" anchor="ctr"/>
-          <a:lstStyle/>
-          <a:p>
-            <a:pPr algn="ctr"/>
-          </a:p>
-        </p:txBody>
-      </p:sp>
-      <p:pic>
-        <p:nvPicPr>
-          <p:cNvPr id="51" name="Picture 50" descr="usb_n.png"/>
-          <p:cNvPicPr>
-            <a:picLocks noChangeAspect="1"/>
-          </p:cNvPicPr>
-          <p:nvPr/>
-        </p:nvPicPr>
-        <p:blipFill>
-          <a:blip r:embed="rId11"/>
-          <a:stretch>
-            <a:fillRect/>
-          </a:stretch>
-        </p:blipFill>
-        <p:spPr>
-          <a:xfrm>
-            <a:off x="1572768" y="8595359"/>
-            <a:ext cx="548640" cy="548640"/>
+          <p:cNvPr id="50" name="TextBox 49"/>
+          <p:cNvSpPr txBox="1"/>
+          <p:nvPr/>
+        </p:nvSpPr>
+        <p:spPr>
+          <a:xfrm>
+            <a:off x="1252728" y="8869680"/>
+            <a:ext cx="15773400" cy="457200"/>
           </a:xfrm>
           <a:prstGeom prst="rect">
             <a:avLst/>
           </a:prstGeom>
-        </p:spPr>
-      </p:pic>
-      <p:sp>
-        <p:nvSpPr>
-          <p:cNvPr id="52" name="TextBox 51"/>
-          <p:cNvSpPr txBox="1"/>
-          <p:nvPr/>
-        </p:nvSpPr>
-        <p:spPr>
-          <a:xfrm>
-            <a:off x="2395728" y="8522207"/>
-            <a:ext cx="14356080" cy="694944"/>
-          </a:xfrm>
-          <a:prstGeom prst="rect">
-            <a:avLst/>
-          </a:prstGeom>
           <a:noFill/>
         </p:spPr>
         <p:txBody>
-          <a:bodyPr wrap="square" lIns="45720" tIns="27432" rIns="45720" bIns="27432" anchor="ctr">
+          <a:bodyPr wrap="square" lIns="45720" tIns="27432" rIns="45720" bIns="27432" anchor="t">
             <a:spAutoFit/>
           </a:bodyPr>
           <a:lstStyle/>
           <a:p>
             <a:pPr algn="l"/>
             <a:r>
-              <a:rPr sz="1500">
+              <a:rPr sz="1400">
                 <a:solidFill>
-                  <a:srgbClr val="032954"/>
+                  <a:srgbClr val="7E889A"/>
                 </a:solidFill>
               </a:rPr>
-              <a:t>Think USB-C: one plug, any device. You can read the tool list and know exactly what the agent can reach. Nothing else.</a:t>
+              <a:t>Think USB-C: one plug, any device. Read the tool list and you know exactly what the agent can reach. Nothing else.</a:t>
             </a:r>
           </a:p>
         </p:txBody>
@@ -12538,101 +12468,31 @@
       </p:sp>
       <p:sp>
         <p:nvSpPr>
-          <p:cNvPr id="37" name="Rounded Rectangle 36"/>
-          <p:cNvSpPr/>
-          <p:nvPr/>
-        </p:nvSpPr>
-        <p:spPr>
-          <a:xfrm>
-            <a:off x="1252728" y="8641080"/>
-            <a:ext cx="15773400" cy="731520"/>
-          </a:xfrm>
-          <a:prstGeom prst="roundRect">
-            <a:avLst>
-              <a:gd name="adj" fmla="val 27499"/>
-            </a:avLst>
-          </a:prstGeom>
-          <a:solidFill>
-            <a:srgbClr val="C4DEFD"/>
-          </a:solidFill>
-          <a:ln>
-            <a:noFill/>
-          </a:ln>
-          <a:effectLst/>
-        </p:spPr>
-        <p:style>
-          <a:lnRef idx="1">
-            <a:schemeClr val="accent1"/>
-          </a:lnRef>
-          <a:fillRef idx="3">
-            <a:schemeClr val="accent1"/>
-          </a:fillRef>
-          <a:effectRef idx="2">
-            <a:schemeClr val="accent1"/>
-          </a:effectRef>
-          <a:fontRef idx="minor">
-            <a:schemeClr val="lt1"/>
-          </a:fontRef>
-        </p:style>
-        <p:txBody>
-          <a:bodyPr rtlCol="0" anchor="ctr"/>
-          <a:lstStyle/>
-          <a:p>
-            <a:pPr algn="ctr"/>
-          </a:p>
-        </p:txBody>
-      </p:sp>
-      <p:pic>
-        <p:nvPicPr>
-          <p:cNvPr id="38" name="Picture 37" descr="puzzle_n.png"/>
-          <p:cNvPicPr>
-            <a:picLocks noChangeAspect="1"/>
-          </p:cNvPicPr>
-          <p:nvPr/>
-        </p:nvPicPr>
-        <p:blipFill>
-          <a:blip r:embed="rId8"/>
-          <a:stretch>
-            <a:fillRect/>
-          </a:stretch>
-        </p:blipFill>
-        <p:spPr>
-          <a:xfrm>
-            <a:off x="1572768" y="8823959"/>
-            <a:ext cx="365760" cy="365760"/>
+          <p:cNvPr id="37" name="TextBox 36"/>
+          <p:cNvSpPr txBox="1"/>
+          <p:nvPr/>
+        </p:nvSpPr>
+        <p:spPr>
+          <a:xfrm>
+            <a:off x="1252728" y="8732520"/>
+            <a:ext cx="15773400" cy="457200"/>
           </a:xfrm>
           <a:prstGeom prst="rect">
             <a:avLst/>
           </a:prstGeom>
-        </p:spPr>
-      </p:pic>
-      <p:sp>
-        <p:nvSpPr>
-          <p:cNvPr id="39" name="TextBox 38"/>
-          <p:cNvSpPr txBox="1"/>
-          <p:nvPr/>
-        </p:nvSpPr>
-        <p:spPr>
-          <a:xfrm>
-            <a:off x="2212848" y="8750807"/>
-            <a:ext cx="14538959" cy="512064"/>
-          </a:xfrm>
-          <a:prstGeom prst="rect">
-            <a:avLst/>
-          </a:prstGeom>
           <a:noFill/>
         </p:spPr>
         <p:txBody>
-          <a:bodyPr wrap="square" lIns="45720" tIns="27432" rIns="45720" bIns="27432" anchor="ctr">
+          <a:bodyPr wrap="square" lIns="45720" tIns="27432" rIns="45720" bIns="27432" anchor="t">
             <a:spAutoFit/>
           </a:bodyPr>
           <a:lstStyle/>
           <a:p>
             <a:pPr algn="l"/>
             <a:r>
-              <a:rPr sz="1500">
+              <a:rPr sz="1400">
                 <a:solidFill>
-                  <a:srgbClr val="032954"/>
+                  <a:srgbClr val="7E889A"/>
                 </a:solidFill>
               </a:rPr>
               <a:t>The LLM did not count anything or invent a threshold. It chose the engines and wrote up what came back.</a:t>
@@ -16179,55 +16039,9 @@
           </a:fontRef>
         </p:style>
       </p:cxnSp>
-      <p:sp>
-        <p:nvSpPr>
-          <p:cNvPr id="42" name="Rounded Rectangle 41"/>
-          <p:cNvSpPr/>
-          <p:nvPr/>
-        </p:nvSpPr>
-        <p:spPr>
-          <a:xfrm>
-            <a:off x="1252728" y="8366760"/>
-            <a:ext cx="15773400" cy="1051560"/>
-          </a:xfrm>
-          <a:prstGeom prst="roundRect">
-            <a:avLst>
-              <a:gd name="adj" fmla="val 19130"/>
-            </a:avLst>
-          </a:prstGeom>
-          <a:solidFill>
-            <a:srgbClr val="C4DEFD"/>
-          </a:solidFill>
-          <a:ln>
-            <a:noFill/>
-          </a:ln>
-          <a:effectLst/>
-        </p:spPr>
-        <p:style>
-          <a:lnRef idx="1">
-            <a:schemeClr val="accent1"/>
-          </a:lnRef>
-          <a:fillRef idx="3">
-            <a:schemeClr val="accent1"/>
-          </a:fillRef>
-          <a:effectRef idx="2">
-            <a:schemeClr val="accent1"/>
-          </a:effectRef>
-          <a:fontRef idx="minor">
-            <a:schemeClr val="lt1"/>
-          </a:fontRef>
-        </p:style>
-        <p:txBody>
-          <a:bodyPr rtlCol="0" anchor="ctr"/>
-          <a:lstStyle/>
-          <a:p>
-            <a:pPr algn="ctr"/>
-          </a:p>
-        </p:txBody>
-      </p:sp>
       <p:pic>
         <p:nvPicPr>
-          <p:cNvPr id="43" name="Picture 42" descr="badge_n.png"/>
+          <p:cNvPr id="42" name="Picture 41" descr="check_b.png"/>
           <p:cNvPicPr>
             <a:picLocks noChangeAspect="1"/>
           </p:cNvPicPr>
@@ -16241,8 +16055,8 @@
         </p:blipFill>
         <p:spPr>
           <a:xfrm>
-            <a:off x="1572768" y="8572500"/>
-            <a:ext cx="640080" cy="640080"/>
+            <a:off x="1252728" y="8613648"/>
+            <a:ext cx="365760" cy="365760"/>
           </a:xfrm>
           <a:prstGeom prst="rect">
             <a:avLst/>
@@ -16251,14 +16065,14 @@
       </p:pic>
       <p:sp>
         <p:nvSpPr>
-          <p:cNvPr id="44" name="TextBox 43"/>
+          <p:cNvPr id="43" name="TextBox 42"/>
           <p:cNvSpPr txBox="1"/>
           <p:nvPr/>
         </p:nvSpPr>
         <p:spPr>
           <a:xfrm>
-            <a:off x="2487168" y="8476488"/>
-            <a:ext cx="14264640" cy="832103"/>
+            <a:off x="1755648" y="8503920"/>
+            <a:ext cx="4511040" cy="685800"/>
           </a:xfrm>
           <a:prstGeom prst="rect">
             <a:avLst/>
@@ -16273,24 +16087,128 @@
           <a:p>
             <a:pPr algn="l"/>
             <a:r>
-              <a:rPr sz="1500">
-                <a:solidFill>
-                  <a:srgbClr val="032954"/>
-                </a:solidFill>
-                <a:latin typeface="+mj-lt"/>
-              </a:rPr>
-              <a:t>What this gives you</a:t>
-            </a:r>
-          </a:p>
-          <a:p>
-            <a:pPr algn="l"/>
-            <a:r>
               <a:rPr sz="1300">
                 <a:solidFill>
-                  <a:srgbClr val="032954"/>
+                  <a:srgbClr val="262626"/>
                 </a:solidFill>
               </a:rPr>
-              <a:t>Ask in plain English or Arabic and get governed numbers, cohorts and charts   ·   Score, forecast and test a policy on demand   ·   Every answer cites the guideline and shows the tools it used</a:t>
+              <a:t>Ask in plain English or Arabic; get governed numbers, cohorts and charts</a:t>
+            </a:r>
+          </a:p>
+        </p:txBody>
+      </p:sp>
+      <p:pic>
+        <p:nvPicPr>
+          <p:cNvPr id="44" name="Picture 43" descr="check_b.png"/>
+          <p:cNvPicPr>
+            <a:picLocks noChangeAspect="1"/>
+          </p:cNvPicPr>
+          <p:nvPr/>
+        </p:nvPicPr>
+        <p:blipFill>
+          <a:blip r:embed="rId4"/>
+          <a:stretch>
+            <a:fillRect/>
+          </a:stretch>
+        </p:blipFill>
+        <p:spPr>
+          <a:xfrm>
+            <a:off x="6632448" y="8613648"/>
+            <a:ext cx="365760" cy="365760"/>
+          </a:xfrm>
+          <a:prstGeom prst="rect">
+            <a:avLst/>
+          </a:prstGeom>
+        </p:spPr>
+      </p:pic>
+      <p:sp>
+        <p:nvSpPr>
+          <p:cNvPr id="45" name="TextBox 44"/>
+          <p:cNvSpPr txBox="1"/>
+          <p:nvPr/>
+        </p:nvSpPr>
+        <p:spPr>
+          <a:xfrm>
+            <a:off x="7135368" y="8503920"/>
+            <a:ext cx="4511040" cy="685800"/>
+          </a:xfrm>
+          <a:prstGeom prst="rect">
+            <a:avLst/>
+          </a:prstGeom>
+          <a:noFill/>
+        </p:spPr>
+        <p:txBody>
+          <a:bodyPr wrap="square" lIns="45720" tIns="27432" rIns="45720" bIns="27432" anchor="ctr">
+            <a:spAutoFit/>
+          </a:bodyPr>
+          <a:lstStyle/>
+          <a:p>
+            <a:pPr algn="l"/>
+            <a:r>
+              <a:rPr sz="1300">
+                <a:solidFill>
+                  <a:srgbClr val="262626"/>
+                </a:solidFill>
+              </a:rPr>
+              <a:t>Score, forecast and test a policy on demand</a:t>
+            </a:r>
+          </a:p>
+        </p:txBody>
+      </p:sp>
+      <p:pic>
+        <p:nvPicPr>
+          <p:cNvPr id="46" name="Picture 45" descr="check_b.png"/>
+          <p:cNvPicPr>
+            <a:picLocks noChangeAspect="1"/>
+          </p:cNvPicPr>
+          <p:nvPr/>
+        </p:nvPicPr>
+        <p:blipFill>
+          <a:blip r:embed="rId4"/>
+          <a:stretch>
+            <a:fillRect/>
+          </a:stretch>
+        </p:blipFill>
+        <p:spPr>
+          <a:xfrm>
+            <a:off x="12012168" y="8613648"/>
+            <a:ext cx="365760" cy="365760"/>
+          </a:xfrm>
+          <a:prstGeom prst="rect">
+            <a:avLst/>
+          </a:prstGeom>
+        </p:spPr>
+      </p:pic>
+      <p:sp>
+        <p:nvSpPr>
+          <p:cNvPr id="47" name="TextBox 46"/>
+          <p:cNvSpPr txBox="1"/>
+          <p:nvPr/>
+        </p:nvSpPr>
+        <p:spPr>
+          <a:xfrm>
+            <a:off x="12515088" y="8503920"/>
+            <a:ext cx="4511040" cy="685800"/>
+          </a:xfrm>
+          <a:prstGeom prst="rect">
+            <a:avLst/>
+          </a:prstGeom>
+          <a:noFill/>
+        </p:spPr>
+        <p:txBody>
+          <a:bodyPr wrap="square" lIns="45720" tIns="27432" rIns="45720" bIns="27432" anchor="ctr">
+            <a:spAutoFit/>
+          </a:bodyPr>
+          <a:lstStyle/>
+          <a:p>
+            <a:pPr algn="l"/>
+            <a:r>
+              <a:rPr sz="1300">
+                <a:solidFill>
+                  <a:srgbClr val="262626"/>
+                </a:solidFill>
+              </a:rPr>
+              <a:t>Every answer cites the guideline and shows the tools it used</a:t>
             </a:r>
           </a:p>
         </p:txBody>
@@ -21898,7 +21816,7 @@
         <p:spPr>
           <a:xfrm>
             <a:off x="1252728" y="3246120"/>
-            <a:ext cx="2847441" cy="4846320"/>
+            <a:ext cx="2847441" cy="4572000"/>
           </a:xfrm>
           <a:prstGeom prst="roundRect">
             <a:avLst>
@@ -22112,7 +22030,7 @@
         <p:spPr>
           <a:xfrm>
             <a:off x="1527048" y="4937760"/>
-            <a:ext cx="2298801" cy="2286000"/>
+            <a:ext cx="2298801" cy="2011680"/>
           </a:xfrm>
           <a:prstGeom prst="rect">
             <a:avLst/>
@@ -22127,7 +22045,7 @@
           <a:p>
             <a:pPr algn="l"/>
             <a:r>
-              <a:rPr sz="1300">
+              <a:rPr sz="1400">
                 <a:solidFill>
                   <a:srgbClr val="262626"/>
                 </a:solidFill>
@@ -22145,7 +22063,7 @@
         </p:nvSpPr>
         <p:spPr>
           <a:xfrm>
-            <a:off x="1527048" y="7315200"/>
+            <a:off x="1527048" y="7040880"/>
             <a:ext cx="2298801" cy="457200"/>
           </a:xfrm>
           <a:prstGeom prst="roundRect">
@@ -22200,7 +22118,7 @@
         </p:nvSpPr>
         <p:spPr>
           <a:xfrm>
-            <a:off x="4155033" y="5468112"/>
+            <a:off x="4155033" y="5330952"/>
             <a:ext cx="274320" cy="402336"/>
           </a:xfrm>
           <a:prstGeom prst="chevron">
@@ -22245,7 +22163,7 @@
         <p:spPr>
           <a:xfrm>
             <a:off x="4484217" y="3246120"/>
-            <a:ext cx="2847441" cy="4846320"/>
+            <a:ext cx="2847441" cy="4572000"/>
           </a:xfrm>
           <a:prstGeom prst="roundRect">
             <a:avLst>
@@ -22459,7 +22377,7 @@
         <p:spPr>
           <a:xfrm>
             <a:off x="4758537" y="4937760"/>
-            <a:ext cx="2298801" cy="2286000"/>
+            <a:ext cx="2298801" cy="2011680"/>
           </a:xfrm>
           <a:prstGeom prst="rect">
             <a:avLst/>
@@ -22474,7 +22392,7 @@
           <a:p>
             <a:pPr algn="l"/>
             <a:r>
-              <a:rPr sz="1300">
+              <a:rPr sz="1400">
                 <a:solidFill>
                   <a:srgbClr val="262626"/>
                 </a:solidFill>
@@ -22492,7 +22410,7 @@
         </p:nvSpPr>
         <p:spPr>
           <a:xfrm>
-            <a:off x="4758537" y="7315200"/>
+            <a:off x="4758537" y="7040880"/>
             <a:ext cx="2298801" cy="457200"/>
           </a:xfrm>
           <a:prstGeom prst="roundRect">
@@ -22547,7 +22465,7 @@
         </p:nvSpPr>
         <p:spPr>
           <a:xfrm>
-            <a:off x="7386523" y="5468112"/>
+            <a:off x="7386523" y="5330952"/>
             <a:ext cx="274320" cy="402336"/>
           </a:xfrm>
           <a:prstGeom prst="chevron">
@@ -22592,7 +22510,7 @@
         <p:spPr>
           <a:xfrm>
             <a:off x="7715707" y="3246120"/>
-            <a:ext cx="2847441" cy="4846320"/>
+            <a:ext cx="2847441" cy="4572000"/>
           </a:xfrm>
           <a:prstGeom prst="roundRect">
             <a:avLst>
@@ -22806,7 +22724,7 @@
         <p:spPr>
           <a:xfrm>
             <a:off x="7990027" y="4937760"/>
-            <a:ext cx="2298801" cy="2286000"/>
+            <a:ext cx="2298801" cy="2011680"/>
           </a:xfrm>
           <a:prstGeom prst="rect">
             <a:avLst/>
@@ -22821,7 +22739,7 @@
           <a:p>
             <a:pPr algn="l"/>
             <a:r>
-              <a:rPr sz="1300">
+              <a:rPr sz="1400">
                 <a:solidFill>
                   <a:srgbClr val="262626"/>
                 </a:solidFill>
@@ -22839,7 +22757,7 @@
         </p:nvSpPr>
         <p:spPr>
           <a:xfrm>
-            <a:off x="7990027" y="7315200"/>
+            <a:off x="7990027" y="7040880"/>
             <a:ext cx="2298801" cy="457200"/>
           </a:xfrm>
           <a:prstGeom prst="roundRect">
@@ -22894,7 +22812,7 @@
         </p:nvSpPr>
         <p:spPr>
           <a:xfrm>
-            <a:off x="10618012" y="5468112"/>
+            <a:off x="10618012" y="5330952"/>
             <a:ext cx="274320" cy="402336"/>
           </a:xfrm>
           <a:prstGeom prst="chevron">
@@ -22939,7 +22857,7 @@
         <p:spPr>
           <a:xfrm>
             <a:off x="10947196" y="3246120"/>
-            <a:ext cx="2847441" cy="4846320"/>
+            <a:ext cx="2847441" cy="4572000"/>
           </a:xfrm>
           <a:prstGeom prst="roundRect">
             <a:avLst>
@@ -23153,7 +23071,7 @@
         <p:spPr>
           <a:xfrm>
             <a:off x="11221516" y="4937760"/>
-            <a:ext cx="2298801" cy="2286000"/>
+            <a:ext cx="2298801" cy="2011680"/>
           </a:xfrm>
           <a:prstGeom prst="rect">
             <a:avLst/>
@@ -23168,7 +23086,7 @@
           <a:p>
             <a:pPr algn="l"/>
             <a:r>
-              <a:rPr sz="1300">
+              <a:rPr sz="1400">
                 <a:solidFill>
                   <a:srgbClr val="262626"/>
                 </a:solidFill>
@@ -23186,7 +23104,7 @@
         </p:nvSpPr>
         <p:spPr>
           <a:xfrm>
-            <a:off x="11221516" y="7315200"/>
+            <a:off x="11221516" y="7040880"/>
             <a:ext cx="2298801" cy="457200"/>
           </a:xfrm>
           <a:prstGeom prst="roundRect">
@@ -23241,7 +23159,7 @@
         </p:nvSpPr>
         <p:spPr>
           <a:xfrm>
-            <a:off x="13849502" y="5468112"/>
+            <a:off x="13849502" y="5330952"/>
             <a:ext cx="274320" cy="402336"/>
           </a:xfrm>
           <a:prstGeom prst="chevron">
@@ -23286,7 +23204,7 @@
         <p:spPr>
           <a:xfrm>
             <a:off x="14178686" y="3246120"/>
-            <a:ext cx="2847441" cy="4846320"/>
+            <a:ext cx="2847441" cy="4572000"/>
           </a:xfrm>
           <a:prstGeom prst="roundRect">
             <a:avLst>
@@ -23500,7 +23418,7 @@
         <p:spPr>
           <a:xfrm>
             <a:off x="14453006" y="4937760"/>
-            <a:ext cx="2298801" cy="2286000"/>
+            <a:ext cx="2298801" cy="2011680"/>
           </a:xfrm>
           <a:prstGeom prst="rect">
             <a:avLst/>
@@ -23515,7 +23433,7 @@
           <a:p>
             <a:pPr algn="l"/>
             <a:r>
-              <a:rPr sz="1300">
+              <a:rPr sz="1400">
                 <a:solidFill>
                   <a:srgbClr val="262626"/>
                 </a:solidFill>
@@ -23533,7 +23451,7 @@
         </p:nvSpPr>
         <p:spPr>
           <a:xfrm>
-            <a:off x="14453006" y="7315200"/>
+            <a:off x="14453006" y="7040880"/>
             <a:ext cx="2298801" cy="457200"/>
           </a:xfrm>
           <a:prstGeom prst="roundRect">
@@ -23582,104 +23500,34 @@
       </p:sp>
       <p:sp>
         <p:nvSpPr>
-          <p:cNvPr id="44" name="Rounded Rectangle 43"/>
-          <p:cNvSpPr/>
-          <p:nvPr/>
-        </p:nvSpPr>
-        <p:spPr>
-          <a:xfrm>
-            <a:off x="1252728" y="8412480"/>
-            <a:ext cx="15773400" cy="914400"/>
-          </a:xfrm>
-          <a:prstGeom prst="roundRect">
-            <a:avLst>
-              <a:gd name="adj" fmla="val 22000"/>
-            </a:avLst>
-          </a:prstGeom>
-          <a:solidFill>
-            <a:srgbClr val="C4DEFD"/>
-          </a:solidFill>
-          <a:ln>
-            <a:noFill/>
-          </a:ln>
-          <a:effectLst/>
-        </p:spPr>
-        <p:style>
-          <a:lnRef idx="1">
-            <a:schemeClr val="accent1"/>
-          </a:lnRef>
-          <a:fillRef idx="3">
-            <a:schemeClr val="accent1"/>
-          </a:fillRef>
-          <a:effectRef idx="2">
-            <a:schemeClr val="accent1"/>
-          </a:effectRef>
-          <a:fontRef idx="minor">
-            <a:schemeClr val="lt1"/>
-          </a:fontRef>
-        </p:style>
-        <p:txBody>
-          <a:bodyPr rtlCol="0" anchor="ctr"/>
-          <a:lstStyle/>
-          <a:p>
-            <a:pPr algn="ctr"/>
-          </a:p>
-        </p:txBody>
-      </p:sp>
-      <p:pic>
-        <p:nvPicPr>
-          <p:cNvPr id="45" name="Picture 44" descr="wand_n.png"/>
-          <p:cNvPicPr>
-            <a:picLocks noChangeAspect="1"/>
-          </p:cNvPicPr>
-          <p:nvPr/>
-        </p:nvPicPr>
-        <p:blipFill>
-          <a:blip r:embed="rId7"/>
-          <a:stretch>
-            <a:fillRect/>
-          </a:stretch>
-        </p:blipFill>
-        <p:spPr>
-          <a:xfrm>
-            <a:off x="1572768" y="8595359"/>
-            <a:ext cx="548640" cy="548640"/>
+          <p:cNvPr id="44" name="TextBox 43"/>
+          <p:cNvSpPr txBox="1"/>
+          <p:nvPr/>
+        </p:nvSpPr>
+        <p:spPr>
+          <a:xfrm>
+            <a:off x="1252728" y="8183879"/>
+            <a:ext cx="15773400" cy="457200"/>
           </a:xfrm>
           <a:prstGeom prst="rect">
             <a:avLst/>
           </a:prstGeom>
-        </p:spPr>
-      </p:pic>
-      <p:sp>
-        <p:nvSpPr>
-          <p:cNvPr id="46" name="TextBox 45"/>
-          <p:cNvSpPr txBox="1"/>
-          <p:nvPr/>
-        </p:nvSpPr>
-        <p:spPr>
-          <a:xfrm>
-            <a:off x="2395728" y="8522207"/>
-            <a:ext cx="14356080" cy="694944"/>
-          </a:xfrm>
-          <a:prstGeom prst="rect">
-            <a:avLst/>
-          </a:prstGeom>
           <a:noFill/>
         </p:spPr>
         <p:txBody>
-          <a:bodyPr wrap="square" lIns="45720" tIns="27432" rIns="45720" bIns="27432" anchor="ctr">
+          <a:bodyPr wrap="square" lIns="45720" tIns="27432" rIns="45720" bIns="27432" anchor="t">
             <a:spAutoFit/>
           </a:bodyPr>
           <a:lstStyle/>
           <a:p>
             <a:pPr algn="l"/>
             <a:r>
-              <a:rPr sz="1500">
+              <a:rPr sz="1400">
                 <a:solidFill>
-                  <a:srgbClr val="032954"/>
+                  <a:srgbClr val="7E889A"/>
                 </a:solidFill>
               </a:rPr>
-              <a:t>Steps 1 and 2 can be done by talking to the copilot agent in RAM, which drives SAS Viya through MCP. Worth watching in itself. Steps 3 to 5 are yours.</a:t>
+              <a:t>Steps 1 and 2 can be done by talking to the copilot agent in RAM, which drives SAS Viya through MCP. Steps 3 to 5 are yours.</a:t>
             </a:r>
           </a:p>
         </p:txBody>
@@ -25630,97 +25478,18 @@
       </p:sp>
       <p:sp>
         <p:nvSpPr>
-          <p:cNvPr id="5" name="Right Arrow 4"/>
+          <p:cNvPr id="5" name="Rounded Rectangle 4"/>
           <p:cNvSpPr/>
           <p:nvPr/>
         </p:nvSpPr>
         <p:spPr>
           <a:xfrm>
-            <a:off x="1252728" y="2697480"/>
-            <a:ext cx="15773400" cy="548640"/>
-          </a:xfrm>
-          <a:prstGeom prst="rightArrow">
-            <a:avLst/>
-          </a:prstGeom>
-          <a:solidFill>
-            <a:srgbClr val="C4DEFD"/>
-          </a:solidFill>
-          <a:ln>
-            <a:noFill/>
-          </a:ln>
-          <a:effectLst/>
-        </p:spPr>
-        <p:style>
-          <a:lnRef idx="1">
-            <a:schemeClr val="accent1"/>
-          </a:lnRef>
-          <a:fillRef idx="3">
-            <a:schemeClr val="accent1"/>
-          </a:fillRef>
-          <a:effectRef idx="2">
-            <a:schemeClr val="accent1"/>
-          </a:effectRef>
-          <a:fontRef idx="minor">
-            <a:schemeClr val="lt1"/>
-          </a:fontRef>
-        </p:style>
-        <p:txBody>
-          <a:bodyPr rtlCol="0" anchor="ctr"/>
-          <a:lstStyle/>
-          <a:p>
-            <a:pPr algn="ctr"/>
-          </a:p>
-        </p:txBody>
-      </p:sp>
-      <p:sp>
-        <p:nvSpPr>
-          <p:cNvPr id="6" name="TextBox 5"/>
-          <p:cNvSpPr txBox="1"/>
-          <p:nvPr/>
-        </p:nvSpPr>
-        <p:spPr>
-          <a:xfrm>
-            <a:off x="1618488" y="2697480"/>
-            <a:ext cx="14676120" cy="548640"/>
-          </a:xfrm>
-          <a:prstGeom prst="rect">
-            <a:avLst/>
-          </a:prstGeom>
-          <a:noFill/>
-        </p:spPr>
-        <p:txBody>
-          <a:bodyPr wrap="square" lIns="45720" tIns="27432" rIns="45720" bIns="27432" anchor="ctr">
-            <a:spAutoFit/>
-          </a:bodyPr>
-          <a:lstStyle/>
-          <a:p>
-            <a:pPr algn="l"/>
-            <a:r>
-              <a:rPr sz="1600">
-                <a:solidFill>
-                  <a:srgbClr val="032954"/>
-                </a:solidFill>
-                <a:latin typeface="+mj-lt"/>
-              </a:rPr>
-              <a:t>Predict  →  Generate  →  Act</a:t>
-            </a:r>
-          </a:p>
-        </p:txBody>
-      </p:sp>
-      <p:sp>
-        <p:nvSpPr>
-          <p:cNvPr id="7" name="Rounded Rectangle 6"/>
-          <p:cNvSpPr/>
-          <p:nvPr/>
-        </p:nvSpPr>
-        <p:spPr>
-          <a:xfrm>
-            <a:off x="1252728" y="3749039"/>
-            <a:ext cx="4983480" cy="4434840"/>
+            <a:off x="1252728" y="3246120"/>
+            <a:ext cx="4983480" cy="4480560"/>
           </a:xfrm>
           <a:prstGeom prst="roundRect">
             <a:avLst>
-              <a:gd name="adj" fmla="val 5773"/>
+              <a:gd name="adj" fmla="val 5714"/>
             </a:avLst>
           </a:prstGeom>
           <a:solidFill>
@@ -25761,13 +25530,13 @@
       </p:sp>
       <p:sp>
         <p:nvSpPr>
-          <p:cNvPr id="8" name="Oval 7"/>
+          <p:cNvPr id="6" name="Oval 5"/>
           <p:cNvSpPr/>
           <p:nvPr/>
         </p:nvSpPr>
         <p:spPr>
           <a:xfrm>
-            <a:off x="3218688" y="3223259"/>
+            <a:off x="3218688" y="2720339"/>
             <a:ext cx="1051560" cy="1051560"/>
           </a:xfrm>
           <a:prstGeom prst="ellipse">
@@ -25811,7 +25580,7 @@
       </p:sp>
       <p:pic>
         <p:nvPicPr>
-          <p:cNvPr id="9" name="Picture 8" descr="model_w.png"/>
+          <p:cNvPr id="7" name="Picture 6" descr="model_w.png"/>
           <p:cNvPicPr>
             <a:picLocks noChangeAspect="1"/>
           </p:cNvPicPr>
@@ -25825,7 +25594,7 @@
         </p:blipFill>
         <p:spPr>
           <a:xfrm>
-            <a:off x="3471062" y="3475634"/>
+            <a:off x="3471062" y="2972714"/>
             <a:ext cx="546811" cy="546811"/>
           </a:xfrm>
           <a:prstGeom prst="rect">
@@ -25835,13 +25604,13 @@
       </p:pic>
       <p:sp>
         <p:nvSpPr>
-          <p:cNvPr id="10" name="TextBox 9"/>
+          <p:cNvPr id="8" name="TextBox 7"/>
           <p:cNvSpPr txBox="1"/>
           <p:nvPr/>
         </p:nvSpPr>
         <p:spPr>
           <a:xfrm>
-            <a:off x="1527048" y="4506163"/>
+            <a:off x="1527048" y="4003243"/>
             <a:ext cx="4434840" cy="594360"/>
           </a:xfrm>
           <a:prstGeom prst="rect">
@@ -25857,7 +25626,7 @@
           <a:p>
             <a:pPr algn="ctr"/>
             <a:r>
-              <a:rPr sz="2100">
+              <a:rPr sz="2200">
                 <a:solidFill>
                   <a:srgbClr val="262626"/>
                 </a:solidFill>
@@ -25870,14 +25639,14 @@
       </p:sp>
       <p:sp>
         <p:nvSpPr>
-          <p:cNvPr id="11" name="TextBox 10"/>
+          <p:cNvPr id="9" name="TextBox 8"/>
           <p:cNvSpPr txBox="1"/>
           <p:nvPr/>
         </p:nvSpPr>
         <p:spPr>
           <a:xfrm>
-            <a:off x="1572768" y="5191963"/>
-            <a:ext cx="4343400" cy="1894636"/>
+            <a:off x="1572768" y="4689043"/>
+            <a:ext cx="4343400" cy="1940356"/>
           </a:xfrm>
           <a:prstGeom prst="rect">
             <a:avLst/>
@@ -25892,7 +25661,7 @@
           <a:p>
             <a:pPr algn="l"/>
             <a:r>
-              <a:rPr sz="1600">
+              <a:rPr sz="1700">
                 <a:solidFill>
                   <a:srgbClr val="262626"/>
                 </a:solidFill>
@@ -25903,9 +25672,44 @@
           <a:p>
             <a:pPr algn="l">
               <a:spcBef>
-                <a:spcPts val="1200"/>
+                <a:spcPts val="1400"/>
               </a:spcBef>
             </a:pPr>
+            <a:r>
+              <a:rPr sz="1700">
+                <a:solidFill>
+                  <a:srgbClr val="0766D1"/>
+                </a:solidFill>
+                <a:latin typeface="+mj-lt"/>
+              </a:rPr>
+              <a:t>This is the risk model in today's demo.</a:t>
+            </a:r>
+          </a:p>
+        </p:txBody>
+      </p:sp>
+      <p:sp>
+        <p:nvSpPr>
+          <p:cNvPr id="10" name="TextBox 9"/>
+          <p:cNvSpPr txBox="1"/>
+          <p:nvPr/>
+        </p:nvSpPr>
+        <p:spPr>
+          <a:xfrm>
+            <a:off x="1572768" y="6675119"/>
+            <a:ext cx="4343400" cy="868680"/>
+          </a:xfrm>
+          <a:prstGeom prst="rect">
+            <a:avLst/>
+          </a:prstGeom>
+          <a:noFill/>
+        </p:spPr>
+        <p:txBody>
+          <a:bodyPr wrap="square" lIns="45720" tIns="27432" rIns="45720" bIns="27432" anchor="b">
+            <a:spAutoFit/>
+          </a:bodyPr>
+          <a:lstStyle/>
+          <a:p>
+            <a:pPr algn="l"/>
             <a:r>
               <a:rPr sz="1600">
                 <a:solidFill>
@@ -25913,41 +25717,6 @@
                 </a:solidFill>
                 <a:latin typeface="+mj-lt"/>
               </a:rPr>
-              <a:t>This is the risk model in today's demo.</a:t>
-            </a:r>
-          </a:p>
-        </p:txBody>
-      </p:sp>
-      <p:sp>
-        <p:nvSpPr>
-          <p:cNvPr id="12" name="TextBox 11"/>
-          <p:cNvSpPr txBox="1"/>
-          <p:nvPr/>
-        </p:nvSpPr>
-        <p:spPr>
-          <a:xfrm>
-            <a:off x="1572768" y="7132319"/>
-            <a:ext cx="4343400" cy="868680"/>
-          </a:xfrm>
-          <a:prstGeom prst="rect">
-            <a:avLst/>
-          </a:prstGeom>
-          <a:noFill/>
-        </p:spPr>
-        <p:txBody>
-          <a:bodyPr wrap="square" lIns="45720" tIns="27432" rIns="45720" bIns="27432" anchor="b">
-            <a:spAutoFit/>
-          </a:bodyPr>
-          <a:lstStyle/>
-          <a:p>
-            <a:pPr algn="l"/>
-            <a:r>
-              <a:rPr sz="1500">
-                <a:solidFill>
-                  <a:srgbClr val="0766D1"/>
-                </a:solidFill>
-                <a:latin typeface="+mj-lt"/>
-              </a:rPr>
               <a:t>Good at: how likely? how many?</a:t>
             </a:r>
           </a:p>
@@ -25955,18 +25724,18 @@
       </p:sp>
       <p:sp>
         <p:nvSpPr>
-          <p:cNvPr id="13" name="Rounded Rectangle 12"/>
+          <p:cNvPr id="11" name="Rounded Rectangle 10"/>
           <p:cNvSpPr/>
           <p:nvPr/>
         </p:nvSpPr>
         <p:spPr>
           <a:xfrm>
-            <a:off x="6647688" y="3749039"/>
-            <a:ext cx="4983480" cy="4434840"/>
+            <a:off x="6647688" y="3246120"/>
+            <a:ext cx="4983480" cy="4480560"/>
           </a:xfrm>
           <a:prstGeom prst="roundRect">
             <a:avLst>
-              <a:gd name="adj" fmla="val 5773"/>
+              <a:gd name="adj" fmla="val 5714"/>
             </a:avLst>
           </a:prstGeom>
           <a:solidFill>
@@ -26007,13 +25776,13 @@
       </p:sp>
       <p:sp>
         <p:nvSpPr>
-          <p:cNvPr id="14" name="Oval 13"/>
+          <p:cNvPr id="12" name="Oval 11"/>
           <p:cNvSpPr/>
           <p:nvPr/>
         </p:nvSpPr>
         <p:spPr>
           <a:xfrm>
-            <a:off x="8613648" y="3223259"/>
+            <a:off x="8613648" y="2720339"/>
             <a:ext cx="1051560" cy="1051560"/>
           </a:xfrm>
           <a:prstGeom prst="ellipse">
@@ -26057,7 +25826,7 @@
       </p:sp>
       <p:pic>
         <p:nvPicPr>
-          <p:cNvPr id="15" name="Picture 14" descr="sparkles_w.png"/>
+          <p:cNvPr id="13" name="Picture 12" descr="sparkles_w.png"/>
           <p:cNvPicPr>
             <a:picLocks noChangeAspect="1"/>
           </p:cNvPicPr>
@@ -26071,7 +25840,7 @@
         </p:blipFill>
         <p:spPr>
           <a:xfrm>
-            <a:off x="8866022" y="3475634"/>
+            <a:off x="8866022" y="2972714"/>
             <a:ext cx="546811" cy="546811"/>
           </a:xfrm>
           <a:prstGeom prst="rect">
@@ -26081,13 +25850,13 @@
       </p:pic>
       <p:sp>
         <p:nvSpPr>
-          <p:cNvPr id="16" name="TextBox 15"/>
+          <p:cNvPr id="14" name="TextBox 13"/>
           <p:cNvSpPr txBox="1"/>
           <p:nvPr/>
         </p:nvSpPr>
         <p:spPr>
           <a:xfrm>
-            <a:off x="6922008" y="4506163"/>
+            <a:off x="6922008" y="4003243"/>
             <a:ext cx="4434840" cy="594360"/>
           </a:xfrm>
           <a:prstGeom prst="rect">
@@ -26103,7 +25872,7 @@
           <a:p>
             <a:pPr algn="ctr"/>
             <a:r>
-              <a:rPr sz="2100">
+              <a:rPr sz="2200">
                 <a:solidFill>
                   <a:srgbClr val="262626"/>
                 </a:solidFill>
@@ -26116,14 +25885,14 @@
       </p:sp>
       <p:sp>
         <p:nvSpPr>
-          <p:cNvPr id="17" name="TextBox 16"/>
+          <p:cNvPr id="15" name="TextBox 14"/>
           <p:cNvSpPr txBox="1"/>
           <p:nvPr/>
         </p:nvSpPr>
         <p:spPr>
           <a:xfrm>
-            <a:off x="6967728" y="5191963"/>
-            <a:ext cx="4343400" cy="1894636"/>
+            <a:off x="6967728" y="4689043"/>
+            <a:ext cx="4343400" cy="1940356"/>
           </a:xfrm>
           <a:prstGeom prst="rect">
             <a:avLst/>
@@ -26138,7 +25907,7 @@
           <a:p>
             <a:pPr algn="l"/>
             <a:r>
-              <a:rPr sz="1600">
+              <a:rPr sz="1700">
                 <a:solidFill>
                   <a:srgbClr val="262626"/>
                 </a:solidFill>
@@ -26149,9 +25918,44 @@
           <a:p>
             <a:pPr algn="l">
               <a:spcBef>
-                <a:spcPts val="1200"/>
+                <a:spcPts val="1400"/>
               </a:spcBef>
             </a:pPr>
+            <a:r>
+              <a:rPr sz="1700">
+                <a:solidFill>
+                  <a:srgbClr val="0766D1"/>
+                </a:solidFill>
+                <a:latin typeface="+mj-lt"/>
+              </a:rPr>
+              <a:t>This is what writes the answers in the demo.</a:t>
+            </a:r>
+          </a:p>
+        </p:txBody>
+      </p:sp>
+      <p:sp>
+        <p:nvSpPr>
+          <p:cNvPr id="16" name="TextBox 15"/>
+          <p:cNvSpPr txBox="1"/>
+          <p:nvPr/>
+        </p:nvSpPr>
+        <p:spPr>
+          <a:xfrm>
+            <a:off x="6967728" y="6675119"/>
+            <a:ext cx="4343400" cy="868680"/>
+          </a:xfrm>
+          <a:prstGeom prst="rect">
+            <a:avLst/>
+          </a:prstGeom>
+          <a:noFill/>
+        </p:spPr>
+        <p:txBody>
+          <a:bodyPr wrap="square" lIns="45720" tIns="27432" rIns="45720" bIns="27432" anchor="b">
+            <a:spAutoFit/>
+          </a:bodyPr>
+          <a:lstStyle/>
+          <a:p>
+            <a:pPr algn="l"/>
             <a:r>
               <a:rPr sz="1600">
                 <a:solidFill>
@@ -26159,41 +25963,6 @@
                 </a:solidFill>
                 <a:latin typeface="+mj-lt"/>
               </a:rPr>
-              <a:t>This is what writes the answers in the demo.</a:t>
-            </a:r>
-          </a:p>
-        </p:txBody>
-      </p:sp>
-      <p:sp>
-        <p:nvSpPr>
-          <p:cNvPr id="18" name="TextBox 17"/>
-          <p:cNvSpPr txBox="1"/>
-          <p:nvPr/>
-        </p:nvSpPr>
-        <p:spPr>
-          <a:xfrm>
-            <a:off x="6967728" y="7132319"/>
-            <a:ext cx="4343400" cy="868680"/>
-          </a:xfrm>
-          <a:prstGeom prst="rect">
-            <a:avLst/>
-          </a:prstGeom>
-          <a:noFill/>
-        </p:spPr>
-        <p:txBody>
-          <a:bodyPr wrap="square" lIns="45720" tIns="27432" rIns="45720" bIns="27432" anchor="b">
-            <a:spAutoFit/>
-          </a:bodyPr>
-          <a:lstStyle/>
-          <a:p>
-            <a:pPr algn="l"/>
-            <a:r>
-              <a:rPr sz="1500">
-                <a:solidFill>
-                  <a:srgbClr val="0766D1"/>
-                </a:solidFill>
-                <a:latin typeface="+mj-lt"/>
-              </a:rPr>
               <a:t>Good at: explain this, write that.</a:t>
             </a:r>
           </a:p>
@@ -26201,18 +25970,18 @@
       </p:sp>
       <p:sp>
         <p:nvSpPr>
-          <p:cNvPr id="19" name="Rounded Rectangle 18"/>
+          <p:cNvPr id="17" name="Rounded Rectangle 16"/>
           <p:cNvSpPr/>
           <p:nvPr/>
         </p:nvSpPr>
         <p:spPr>
           <a:xfrm>
-            <a:off x="12042648" y="3749039"/>
-            <a:ext cx="4983480" cy="4434840"/>
+            <a:off x="12042648" y="3246120"/>
+            <a:ext cx="4983480" cy="4480560"/>
           </a:xfrm>
           <a:prstGeom prst="roundRect">
             <a:avLst>
-              <a:gd name="adj" fmla="val 5773"/>
+              <a:gd name="adj" fmla="val 5714"/>
             </a:avLst>
           </a:prstGeom>
           <a:solidFill>
@@ -26253,13 +26022,13 @@
       </p:sp>
       <p:sp>
         <p:nvSpPr>
-          <p:cNvPr id="20" name="Oval 19"/>
+          <p:cNvPr id="18" name="Oval 17"/>
           <p:cNvSpPr/>
           <p:nvPr/>
         </p:nvSpPr>
         <p:spPr>
           <a:xfrm>
-            <a:off x="14008608" y="3223259"/>
+            <a:off x="14008608" y="2720339"/>
             <a:ext cx="1051560" cy="1051560"/>
           </a:xfrm>
           <a:prstGeom prst="ellipse">
@@ -26303,7 +26072,7 @@
       </p:sp>
       <p:pic>
         <p:nvPicPr>
-          <p:cNvPr id="21" name="Picture 20" descr="robot_b.png"/>
+          <p:cNvPr id="19" name="Picture 18" descr="robot_b.png"/>
           <p:cNvPicPr>
             <a:picLocks noChangeAspect="1"/>
           </p:cNvPicPr>
@@ -26317,7 +26086,7 @@
         </p:blipFill>
         <p:spPr>
           <a:xfrm>
-            <a:off x="14260982" y="3475634"/>
+            <a:off x="14260982" y="2972714"/>
             <a:ext cx="546811" cy="546811"/>
           </a:xfrm>
           <a:prstGeom prst="rect">
@@ -26327,13 +26096,13 @@
       </p:pic>
       <p:sp>
         <p:nvSpPr>
-          <p:cNvPr id="22" name="TextBox 21"/>
+          <p:cNvPr id="20" name="TextBox 19"/>
           <p:cNvSpPr txBox="1"/>
           <p:nvPr/>
         </p:nvSpPr>
         <p:spPr>
           <a:xfrm>
-            <a:off x="12316968" y="4506163"/>
+            <a:off x="12316968" y="4003243"/>
             <a:ext cx="4434840" cy="594360"/>
           </a:xfrm>
           <a:prstGeom prst="rect">
@@ -26349,7 +26118,7 @@
           <a:p>
             <a:pPr algn="ctr"/>
             <a:r>
-              <a:rPr sz="2100">
+              <a:rPr sz="2200">
                 <a:solidFill>
                   <a:srgbClr val="FFFFFF"/>
                 </a:solidFill>
@@ -26362,14 +26131,14 @@
       </p:sp>
       <p:sp>
         <p:nvSpPr>
-          <p:cNvPr id="23" name="TextBox 22"/>
+          <p:cNvPr id="21" name="TextBox 20"/>
           <p:cNvSpPr txBox="1"/>
           <p:nvPr/>
         </p:nvSpPr>
         <p:spPr>
           <a:xfrm>
-            <a:off x="12362688" y="5191963"/>
-            <a:ext cx="4343400" cy="1894636"/>
+            <a:off x="12362688" y="4689043"/>
+            <a:ext cx="4343400" cy="1940356"/>
           </a:xfrm>
           <a:prstGeom prst="rect">
             <a:avLst/>
@@ -26384,7 +26153,7 @@
           <a:p>
             <a:pPr algn="l"/>
             <a:r>
-              <a:rPr sz="1600">
+              <a:rPr sz="1700">
                 <a:solidFill>
                   <a:srgbClr val="FFFFFF"/>
                 </a:solidFill>
@@ -26395,9 +26164,44 @@
           <a:p>
             <a:pPr algn="l">
               <a:spcBef>
-                <a:spcPts val="1200"/>
+                <a:spcPts val="1400"/>
               </a:spcBef>
             </a:pPr>
+            <a:r>
+              <a:rPr sz="1700">
+                <a:solidFill>
+                  <a:srgbClr val="C4DEFD"/>
+                </a:solidFill>
+                <a:latin typeface="+mj-lt"/>
+              </a:rPr>
+              <a:t>This is the whole Population Health Agent.</a:t>
+            </a:r>
+          </a:p>
+        </p:txBody>
+      </p:sp>
+      <p:sp>
+        <p:nvSpPr>
+          <p:cNvPr id="22" name="TextBox 21"/>
+          <p:cNvSpPr txBox="1"/>
+          <p:nvPr/>
+        </p:nvSpPr>
+        <p:spPr>
+          <a:xfrm>
+            <a:off x="12362688" y="6675119"/>
+            <a:ext cx="4343400" cy="868680"/>
+          </a:xfrm>
+          <a:prstGeom prst="rect">
+            <a:avLst/>
+          </a:prstGeom>
+          <a:noFill/>
+        </p:spPr>
+        <p:txBody>
+          <a:bodyPr wrap="square" lIns="45720" tIns="27432" rIns="45720" bIns="27432" anchor="b">
+            <a:spAutoFit/>
+          </a:bodyPr>
+          <a:lstStyle/>
+          <a:p>
+            <a:pPr algn="l"/>
             <a:r>
               <a:rPr sz="1600">
                 <a:solidFill>
@@ -26405,21 +26209,21 @@
                 </a:solidFill>
                 <a:latin typeface="+mj-lt"/>
               </a:rPr>
-              <a:t>This is the whole Population Health Agent.</a:t>
-            </a:r>
-          </a:p>
-        </p:txBody>
-      </p:sp>
-      <p:sp>
-        <p:nvSpPr>
-          <p:cNvPr id="24" name="TextBox 23"/>
+              <a:t>Good at: get this done, and show me how.</a:t>
+            </a:r>
+          </a:p>
+        </p:txBody>
+      </p:sp>
+      <p:sp>
+        <p:nvSpPr>
+          <p:cNvPr id="23" name="TextBox 22"/>
           <p:cNvSpPr txBox="1"/>
           <p:nvPr/>
         </p:nvSpPr>
         <p:spPr>
           <a:xfrm>
-            <a:off x="12362688" y="7132319"/>
-            <a:ext cx="4343400" cy="868680"/>
+            <a:off x="1252728" y="8092440"/>
+            <a:ext cx="15773400" cy="457200"/>
           </a:xfrm>
           <a:prstGeom prst="rect">
             <a:avLst/>
@@ -26427,121 +26231,16 @@
           <a:noFill/>
         </p:spPr>
         <p:txBody>
-          <a:bodyPr wrap="square" lIns="45720" tIns="27432" rIns="45720" bIns="27432" anchor="b">
+          <a:bodyPr wrap="square" lIns="45720" tIns="27432" rIns="45720" bIns="27432" anchor="t">
             <a:spAutoFit/>
           </a:bodyPr>
           <a:lstStyle/>
           <a:p>
             <a:pPr algn="l"/>
             <a:r>
-              <a:rPr sz="1500">
+              <a:rPr sz="1400">
                 <a:solidFill>
-                  <a:srgbClr val="C4DEFD"/>
-                </a:solidFill>
-                <a:latin typeface="+mj-lt"/>
-              </a:rPr>
-              <a:t>Good at: get this done, and show me how.</a:t>
-            </a:r>
-          </a:p>
-        </p:txBody>
-      </p:sp>
-      <p:sp>
-        <p:nvSpPr>
-          <p:cNvPr id="25" name="Rounded Rectangle 24"/>
-          <p:cNvSpPr/>
-          <p:nvPr/>
-        </p:nvSpPr>
-        <p:spPr>
-          <a:xfrm>
-            <a:off x="1252728" y="8412480"/>
-            <a:ext cx="15773400" cy="914400"/>
-          </a:xfrm>
-          <a:prstGeom prst="roundRect">
-            <a:avLst>
-              <a:gd name="adj" fmla="val 22000"/>
-            </a:avLst>
-          </a:prstGeom>
-          <a:solidFill>
-            <a:srgbClr val="C4DEFD"/>
-          </a:solidFill>
-          <a:ln>
-            <a:noFill/>
-          </a:ln>
-          <a:effectLst/>
-        </p:spPr>
-        <p:style>
-          <a:lnRef idx="1">
-            <a:schemeClr val="accent1"/>
-          </a:lnRef>
-          <a:fillRef idx="3">
-            <a:schemeClr val="accent1"/>
-          </a:fillRef>
-          <a:effectRef idx="2">
-            <a:schemeClr val="accent1"/>
-          </a:effectRef>
-          <a:fontRef idx="minor">
-            <a:schemeClr val="lt1"/>
-          </a:fontRef>
-        </p:style>
-        <p:txBody>
-          <a:bodyPr rtlCol="0" anchor="ctr"/>
-          <a:lstStyle/>
-          <a:p>
-            <a:pPr algn="ctr"/>
-          </a:p>
-        </p:txBody>
-      </p:sp>
-      <p:pic>
-        <p:nvPicPr>
-          <p:cNvPr id="26" name="Picture 25" descr="lightbulb_n.png"/>
-          <p:cNvPicPr>
-            <a:picLocks noChangeAspect="1"/>
-          </p:cNvPicPr>
-          <p:nvPr/>
-        </p:nvPicPr>
-        <p:blipFill>
-          <a:blip r:embed="rId5"/>
-          <a:stretch>
-            <a:fillRect/>
-          </a:stretch>
-        </p:blipFill>
-        <p:spPr>
-          <a:xfrm>
-            <a:off x="1572768" y="8595359"/>
-            <a:ext cx="548640" cy="548640"/>
-          </a:xfrm>
-          <a:prstGeom prst="rect">
-            <a:avLst/>
-          </a:prstGeom>
-        </p:spPr>
-      </p:pic>
-      <p:sp>
-        <p:nvSpPr>
-          <p:cNvPr id="27" name="TextBox 26"/>
-          <p:cNvSpPr txBox="1"/>
-          <p:nvPr/>
-        </p:nvSpPr>
-        <p:spPr>
-          <a:xfrm>
-            <a:off x="2395728" y="8522207"/>
-            <a:ext cx="14356080" cy="694944"/>
-          </a:xfrm>
-          <a:prstGeom prst="rect">
-            <a:avLst/>
-          </a:prstGeom>
-          <a:noFill/>
-        </p:spPr>
-        <p:txBody>
-          <a:bodyPr wrap="square" lIns="45720" tIns="27432" rIns="45720" bIns="27432" anchor="ctr">
-            <a:spAutoFit/>
-          </a:bodyPr>
-          <a:lstStyle/>
-          <a:p>
-            <a:pPr algn="l"/>
-            <a:r>
-              <a:rPr sz="1600">
-                <a:solidFill>
-                  <a:srgbClr val="032954"/>
+                  <a:srgbClr val="7E889A"/>
                 </a:solidFill>
               </a:rPr>
               <a:t>Nothing here replaces what you already have. The agent is the layer that puts your models and the language model to work.</a:t>
@@ -27343,11 +27042,11 @@
         <p:spPr>
           <a:xfrm>
             <a:off x="9144000" y="2743200"/>
-            <a:ext cx="7882128" cy="4892040"/>
+            <a:ext cx="7882128" cy="6309360"/>
           </a:xfrm>
           <a:prstGeom prst="roundRect">
             <a:avLst>
-              <a:gd name="adj" fmla="val 5233"/>
+              <a:gd name="adj" fmla="val 4057"/>
             </a:avLst>
           </a:prstGeom>
           <a:solidFill>
@@ -27969,86 +27668,52 @@
           </a:p>
         </p:txBody>
       </p:sp>
-      <p:sp>
-        <p:nvSpPr>
-          <p:cNvPr id="33" name="Rounded Rectangle 32"/>
-          <p:cNvSpPr/>
-          <p:nvPr/>
-        </p:nvSpPr>
-        <p:spPr>
-          <a:xfrm>
-            <a:off x="9144000" y="7909560"/>
-            <a:ext cx="7882128" cy="1417320"/>
-          </a:xfrm>
-          <a:prstGeom prst="roundRect">
-            <a:avLst>
-              <a:gd name="adj" fmla="val 14193"/>
-            </a:avLst>
-          </a:prstGeom>
-          <a:solidFill>
-            <a:srgbClr val="C4DEFD"/>
-          </a:solidFill>
-          <a:ln>
-            <a:noFill/>
+      <p:cxnSp>
+        <p:nvCxnSpPr>
+          <p:cNvPr id="33" name="Connector 32"/>
+          <p:cNvCxnSpPr/>
+          <p:nvPr/>
+        </p:nvCxnSpPr>
+        <p:spPr>
+          <a:xfrm>
+            <a:off x="9555480" y="7726679"/>
+            <a:ext cx="7059168" cy="0"/>
+          </a:xfrm>
+          <a:prstGeom prst="line">
+            <a:avLst/>
+          </a:prstGeom>
+          <a:ln w="12700">
+            <a:solidFill>
+              <a:srgbClr val="E4E7EA"/>
+            </a:solidFill>
           </a:ln>
           <a:effectLst/>
         </p:spPr>
         <p:style>
-          <a:lnRef idx="1">
+          <a:lnRef idx="2">
             <a:schemeClr val="accent1"/>
           </a:lnRef>
-          <a:fillRef idx="3">
+          <a:fillRef idx="0">
             <a:schemeClr val="accent1"/>
           </a:fillRef>
-          <a:effectRef idx="2">
+          <a:effectRef idx="1">
             <a:schemeClr val="accent1"/>
           </a:effectRef>
           <a:fontRef idx="minor">
-            <a:schemeClr val="lt1"/>
+            <a:schemeClr val="tx1"/>
           </a:fontRef>
         </p:style>
-        <p:txBody>
-          <a:bodyPr rtlCol="0" anchor="ctr"/>
-          <a:lstStyle/>
-          <a:p>
-            <a:pPr algn="ctr"/>
-          </a:p>
-        </p:txBody>
-      </p:sp>
-      <p:pic>
-        <p:nvPicPr>
-          <p:cNvPr id="34" name="Picture 33" descr="robot_n.png"/>
-          <p:cNvPicPr>
-            <a:picLocks noChangeAspect="1"/>
-          </p:cNvPicPr>
-          <p:nvPr/>
-        </p:nvPicPr>
-        <p:blipFill>
-          <a:blip r:embed="rId6"/>
-          <a:stretch>
-            <a:fillRect/>
-          </a:stretch>
-        </p:blipFill>
-        <p:spPr>
-          <a:xfrm>
-            <a:off x="9464040" y="8298180"/>
-            <a:ext cx="640080" cy="640080"/>
-          </a:xfrm>
-          <a:prstGeom prst="rect">
-            <a:avLst/>
-          </a:prstGeom>
-        </p:spPr>
-      </p:pic>
-      <p:sp>
-        <p:nvSpPr>
-          <p:cNvPr id="35" name="TextBox 34"/>
+      </p:cxnSp>
+      <p:sp>
+        <p:nvSpPr>
+          <p:cNvPr id="34" name="TextBox 33"/>
           <p:cNvSpPr txBox="1"/>
           <p:nvPr/>
         </p:nvSpPr>
         <p:spPr>
           <a:xfrm>
-            <a:off x="10378440" y="8019288"/>
-            <a:ext cx="6373368" cy="1197864"/>
+            <a:off x="9555480" y="7863840"/>
+            <a:ext cx="7059168" cy="1005840"/>
           </a:xfrm>
           <a:prstGeom prst="rect">
             <a:avLst/>
@@ -28063,7 +27728,7 @@
           <a:p>
             <a:pPr algn="l"/>
             <a:r>
-              <a:rPr sz="1500">
+              <a:rPr sz="1600">
                 <a:solidFill>
                   <a:srgbClr val="032954"/>
                 </a:solidFill>
@@ -28071,7 +27736,7 @@
               <a:t>In one sentence: an agent chases a </a:t>
             </a:r>
             <a:r>
-              <a:rPr sz="1500">
+              <a:rPr sz="1600">
                 <a:solidFill>
                   <a:srgbClr val="032954"/>
                 </a:solidFill>
@@ -28080,7 +27745,7 @@
               <a:t>goal</a:t>
             </a:r>
             <a:r>
-              <a:rPr sz="1500">
+              <a:rPr sz="1600">
                 <a:solidFill>
                   <a:srgbClr val="032954"/>
                 </a:solidFill>
@@ -28088,7 +27753,7 @@
               <a:t>, uses </a:t>
             </a:r>
             <a:r>
-              <a:rPr sz="1500">
+              <a:rPr sz="1600">
                 <a:solidFill>
                   <a:srgbClr val="032954"/>
                 </a:solidFill>
@@ -28097,7 +27762,7 @@
               <a:t>tools</a:t>
             </a:r>
             <a:r>
-              <a:rPr sz="1500">
+              <a:rPr sz="1600">
                 <a:solidFill>
                   <a:srgbClr val="032954"/>
                 </a:solidFill>
@@ -28105,7 +27770,7 @@
               <a:t>, checks its own work, and stays inside the </a:t>
             </a:r>
             <a:r>
-              <a:rPr sz="1500">
+              <a:rPr sz="1600">
                 <a:solidFill>
                   <a:srgbClr val="032954"/>
                 </a:solidFill>
@@ -28114,7 +27779,7 @@
               <a:t>lines we draw</a:t>
             </a:r>
             <a:r>
-              <a:rPr sz="1500">
+              <a:rPr sz="1600">
                 <a:solidFill>
                   <a:srgbClr val="032954"/>
                 </a:solidFill>
@@ -31605,11 +31270,11 @@
         <p:spPr>
           <a:xfrm>
             <a:off x="1252728" y="2743200"/>
-            <a:ext cx="7680960" cy="5257800"/>
+            <a:ext cx="7680960" cy="4937760"/>
           </a:xfrm>
           <a:prstGeom prst="roundRect">
             <a:avLst>
-              <a:gd name="adj" fmla="val 4869"/>
+              <a:gd name="adj" fmla="val 5185"/>
             </a:avLst>
           </a:prstGeom>
           <a:solidFill>
@@ -31759,8 +31424,8 @@
         </p:nvSpPr>
         <p:spPr>
           <a:xfrm>
-            <a:off x="1664208" y="4069080"/>
-            <a:ext cx="6858000" cy="2926080"/>
+            <a:off x="1664208" y="4114800"/>
+            <a:ext cx="6858000" cy="3200400"/>
           </a:xfrm>
           <a:prstGeom prst="rect">
             <a:avLst/>
@@ -31775,7 +31440,7 @@
           <a:p>
             <a:pPr algn="l" marL="237744" indent="-237744">
               <a:spcAft>
-                <a:spcPts val="1200"/>
+                <a:spcPts val="1600"/>
               </a:spcAft>
               <a:buClr>
                 <a:srgbClr val="0766D1"/>
@@ -31784,7 +31449,7 @@
               <a:buChar char="•"/>
             </a:pPr>
             <a:r>
-              <a:rPr sz="1800">
+              <a:rPr sz="2000">
                 <a:solidFill>
                   <a:srgbClr val="262626"/>
                 </a:solidFill>
@@ -31795,7 +31460,7 @@
           <a:p>
             <a:pPr algn="l" marL="237744" indent="-237744">
               <a:spcAft>
-                <a:spcPts val="1200"/>
+                <a:spcPts val="1600"/>
               </a:spcAft>
               <a:buClr>
                 <a:srgbClr val="0766D1"/>
@@ -31804,7 +31469,7 @@
               <a:buChar char="•"/>
             </a:pPr>
             <a:r>
-              <a:rPr sz="1800">
+              <a:rPr sz="2000">
                 <a:solidFill>
                   <a:srgbClr val="262626"/>
                 </a:solidFill>
@@ -31815,7 +31480,7 @@
           <a:p>
             <a:pPr algn="l" marL="237744" indent="-237744">
               <a:spcAft>
-                <a:spcPts val="1200"/>
+                <a:spcPts val="1600"/>
               </a:spcAft>
               <a:buClr>
                 <a:srgbClr val="0766D1"/>
@@ -31824,7 +31489,7 @@
               <a:buChar char="•"/>
             </a:pPr>
             <a:r>
-              <a:rPr sz="1800">
+              <a:rPr sz="2000">
                 <a:solidFill>
                   <a:srgbClr val="262626"/>
                 </a:solidFill>
@@ -31835,7 +31500,7 @@
           <a:p>
             <a:pPr algn="l" marL="237744" indent="-237744">
               <a:spcAft>
-                <a:spcPts val="1200"/>
+                <a:spcPts val="1600"/>
               </a:spcAft>
               <a:buClr>
                 <a:srgbClr val="0766D1"/>
@@ -31844,7 +31509,7 @@
               <a:buChar char="•"/>
             </a:pPr>
             <a:r>
-              <a:rPr sz="1800">
+              <a:rPr sz="2000">
                 <a:solidFill>
                   <a:srgbClr val="262626"/>
                 </a:solidFill>
@@ -31862,7 +31527,7 @@
         </p:nvSpPr>
         <p:spPr>
           <a:xfrm>
-            <a:off x="1664208" y="7040880"/>
+            <a:off x="1664208" y="6720840"/>
             <a:ext cx="6858000" cy="777240"/>
           </a:xfrm>
           <a:prstGeom prst="rect">
@@ -31898,11 +31563,11 @@
         <p:spPr>
           <a:xfrm>
             <a:off x="9345167" y="2743200"/>
-            <a:ext cx="7680960" cy="5257800"/>
+            <a:ext cx="7680960" cy="4937760"/>
           </a:xfrm>
           <a:prstGeom prst="roundRect">
             <a:avLst>
-              <a:gd name="adj" fmla="val 4869"/>
+              <a:gd name="adj" fmla="val 5185"/>
             </a:avLst>
           </a:prstGeom>
           <a:solidFill>
@@ -32052,8 +31717,8 @@
         </p:nvSpPr>
         <p:spPr>
           <a:xfrm>
-            <a:off x="9756647" y="4069080"/>
-            <a:ext cx="6858000" cy="2926080"/>
+            <a:off x="9756647" y="4114800"/>
+            <a:ext cx="6858000" cy="3200400"/>
           </a:xfrm>
           <a:prstGeom prst="rect">
             <a:avLst/>
@@ -32068,7 +31733,7 @@
           <a:p>
             <a:pPr algn="l" marL="237744" indent="-237744">
               <a:spcAft>
-                <a:spcPts val="1200"/>
+                <a:spcPts val="1600"/>
               </a:spcAft>
               <a:buClr>
                 <a:srgbClr val="C00000"/>
@@ -32077,7 +31742,7 @@
               <a:buChar char="•"/>
             </a:pPr>
             <a:r>
-              <a:rPr sz="1800">
+              <a:rPr sz="2000">
                 <a:solidFill>
                   <a:srgbClr val="262626"/>
                 </a:solidFill>
@@ -32088,7 +31753,7 @@
           <a:p>
             <a:pPr algn="l" marL="237744" indent="-237744">
               <a:spcAft>
-                <a:spcPts val="1200"/>
+                <a:spcPts val="1600"/>
               </a:spcAft>
               <a:buClr>
                 <a:srgbClr val="C00000"/>
@@ -32097,7 +31762,7 @@
               <a:buChar char="•"/>
             </a:pPr>
             <a:r>
-              <a:rPr sz="1800">
+              <a:rPr sz="2000">
                 <a:solidFill>
                   <a:srgbClr val="262626"/>
                 </a:solidFill>
@@ -32108,7 +31773,7 @@
           <a:p>
             <a:pPr algn="l" marL="237744" indent="-237744">
               <a:spcAft>
-                <a:spcPts val="1200"/>
+                <a:spcPts val="1600"/>
               </a:spcAft>
               <a:buClr>
                 <a:srgbClr val="C00000"/>
@@ -32117,7 +31782,7 @@
               <a:buChar char="•"/>
             </a:pPr>
             <a:r>
-              <a:rPr sz="1800">
+              <a:rPr sz="2000">
                 <a:solidFill>
                   <a:srgbClr val="262626"/>
                 </a:solidFill>
@@ -32128,7 +31793,7 @@
           <a:p>
             <a:pPr algn="l" marL="237744" indent="-237744">
               <a:spcAft>
-                <a:spcPts val="1200"/>
+                <a:spcPts val="1600"/>
               </a:spcAft>
               <a:buClr>
                 <a:srgbClr val="C00000"/>
@@ -32137,7 +31802,7 @@
               <a:buChar char="•"/>
             </a:pPr>
             <a:r>
-              <a:rPr sz="1800">
+              <a:rPr sz="2000">
                 <a:solidFill>
                   <a:srgbClr val="262626"/>
                 </a:solidFill>
@@ -32155,7 +31820,7 @@
         </p:nvSpPr>
         <p:spPr>
           <a:xfrm>
-            <a:off x="9756647" y="7040880"/>
+            <a:off x="9756647" y="6720840"/>
             <a:ext cx="6858000" cy="777240"/>
           </a:xfrm>
           <a:prstGeom prst="rect">
@@ -32184,155 +31849,34 @@
       </p:sp>
       <p:sp>
         <p:nvSpPr>
-          <p:cNvPr id="17" name="Rounded Rectangle 16"/>
-          <p:cNvSpPr/>
-          <p:nvPr/>
-        </p:nvSpPr>
-        <p:spPr>
-          <a:xfrm>
-            <a:off x="1252728" y="8366760"/>
-            <a:ext cx="15773400" cy="960120"/>
-          </a:xfrm>
-          <a:prstGeom prst="roundRect">
-            <a:avLst>
-              <a:gd name="adj" fmla="val 20952"/>
-            </a:avLst>
-          </a:prstGeom>
-          <a:solidFill>
-            <a:srgbClr val="C4DEFD"/>
-          </a:solidFill>
-          <a:ln>
-            <a:noFill/>
-          </a:ln>
-          <a:effectLst/>
-        </p:spPr>
-        <p:style>
-          <a:lnRef idx="1">
-            <a:schemeClr val="accent1"/>
-          </a:lnRef>
-          <a:fillRef idx="3">
-            <a:schemeClr val="accent1"/>
-          </a:fillRef>
-          <a:effectRef idx="2">
-            <a:schemeClr val="accent1"/>
-          </a:effectRef>
-          <a:fontRef idx="minor">
-            <a:schemeClr val="lt1"/>
-          </a:fontRef>
-        </p:style>
-        <p:txBody>
-          <a:bodyPr rtlCol="0" anchor="ctr"/>
-          <a:lstStyle/>
-          <a:p>
-            <a:pPr algn="ctr"/>
-          </a:p>
-        </p:txBody>
-      </p:sp>
-      <p:pic>
-        <p:nvPicPr>
-          <p:cNvPr id="18" name="Picture 17" descr="lightbulb_n.png"/>
-          <p:cNvPicPr>
-            <a:picLocks noChangeAspect="1"/>
-          </p:cNvPicPr>
-          <p:nvPr/>
-        </p:nvPicPr>
-        <p:blipFill>
-          <a:blip r:embed="rId4"/>
-          <a:stretch>
-            <a:fillRect/>
-          </a:stretch>
-        </p:blipFill>
-        <p:spPr>
-          <a:xfrm>
-            <a:off x="1572768" y="8549640"/>
-            <a:ext cx="594360" cy="594360"/>
+          <p:cNvPr id="17" name="TextBox 16"/>
+          <p:cNvSpPr txBox="1"/>
+          <p:nvPr/>
+        </p:nvSpPr>
+        <p:spPr>
+          <a:xfrm>
+            <a:off x="1252728" y="8092440"/>
+            <a:ext cx="15773400" cy="457200"/>
           </a:xfrm>
           <a:prstGeom prst="rect">
             <a:avLst/>
           </a:prstGeom>
-        </p:spPr>
-      </p:pic>
-      <p:sp>
-        <p:nvSpPr>
-          <p:cNvPr id="19" name="TextBox 18"/>
-          <p:cNvSpPr txBox="1"/>
-          <p:nvPr/>
-        </p:nvSpPr>
-        <p:spPr>
-          <a:xfrm>
-            <a:off x="2441448" y="8476488"/>
-            <a:ext cx="14310359" cy="740664"/>
-          </a:xfrm>
-          <a:prstGeom prst="rect">
-            <a:avLst/>
-          </a:prstGeom>
           <a:noFill/>
         </p:spPr>
         <p:txBody>
-          <a:bodyPr wrap="square" lIns="45720" tIns="27432" rIns="45720" bIns="27432" anchor="ctr">
+          <a:bodyPr wrap="square" lIns="45720" tIns="27432" rIns="45720" bIns="27432" anchor="t">
             <a:spAutoFit/>
           </a:bodyPr>
           <a:lstStyle/>
           <a:p>
             <a:pPr algn="l"/>
             <a:r>
-              <a:rPr sz="1600">
+              <a:rPr sz="1400">
                 <a:solidFill>
-                  <a:srgbClr val="032954"/>
+                  <a:srgbClr val="7E889A"/>
                 </a:solidFill>
               </a:rPr>
-              <a:t>So we surround it. </a:t>
-            </a:r>
-            <a:r>
-              <a:rPr sz="1600">
-                <a:solidFill>
-                  <a:srgbClr val="032954"/>
-                </a:solidFill>
-                <a:latin typeface="+mj-lt"/>
-              </a:rPr>
-              <a:t>RAG</a:t>
-            </a:r>
-            <a:r>
-              <a:rPr sz="1600">
-                <a:solidFill>
-                  <a:srgbClr val="032954"/>
-                </a:solidFill>
-              </a:rPr>
-              <a:t> for the quotes, </a:t>
-            </a:r>
-            <a:r>
-              <a:rPr sz="1600">
-                <a:solidFill>
-                  <a:srgbClr val="032954"/>
-                </a:solidFill>
-                <a:latin typeface="+mj-lt"/>
-              </a:rPr>
-              <a:t>tools and models</a:t>
-            </a:r>
-            <a:r>
-              <a:rPr sz="1600">
-                <a:solidFill>
-                  <a:srgbClr val="032954"/>
-                </a:solidFill>
-              </a:rPr>
-              <a:t> for the numbers, </a:t>
-            </a:r>
-            <a:r>
-              <a:rPr sz="1600">
-                <a:solidFill>
-                  <a:srgbClr val="032954"/>
-                </a:solidFill>
-                <a:latin typeface="+mj-lt"/>
-              </a:rPr>
-              <a:t>people</a:t>
-            </a:r>
-            <a:r>
-              <a:rPr sz="1600">
-                <a:solidFill>
-                  <a:srgbClr val="032954"/>
-                </a:solidFill>
-              </a:rPr>
-              <a:t> for the decisions.</a:t>
+              <a:t>So we surround it. RAG for the quotes, tools and models for the numbers, people for the decisions.</a:t>
             </a:r>
           </a:p>
         </p:txBody>

</xml_diff>